<commit_message>
docs: update project documentation to clarify SDD and BMAD methodologies
</commit_message>
<xml_diff>
--- a/presentations/presentacion-ejecutiva-skills-ia-bcv-resumen.pptx
+++ b/presentations/presentacion-ejecutiva-skills-ia-bcv-resumen.pptx
@@ -3421,8 +3421,8 @@
         </p:nvSpPr>
         <p:spPr>
           <a:xfrm>
-            <a:off x="594360" y="1847088"/>
-            <a:ext cx="3703320" cy="731520"/>
+            <a:off x="594360" y="1828800"/>
+            <a:ext cx="3703320" cy="777240"/>
           </a:xfrm>
           <a:prstGeom prst="rect">
             <a:avLst/>
@@ -3435,10 +3435,13 @@
           <a:lstStyle/>
           <a:p>
             <a:pPr algn="l" indent="0" marL="0">
-              <a:buNone/>
-            </a:pPr>
-            <a:r>
-              <a:rPr lang="en-US" sz="1100" dirty="0">
+              <a:lnSpc>
+                <a:spcPct val="112000"/>
+              </a:lnSpc>
+              <a:buNone/>
+            </a:pPr>
+            <a:r>
+              <a:rPr lang="en-US" sz="980" dirty="0">
                 <a:solidFill>
                   <a:srgbClr val="FFFFFF"/>
                 </a:solidFill>
@@ -3446,9 +3449,9 @@
                 <a:ea typeface="Arial" pitchFamily="34" charset="-122"/>
                 <a:cs typeface="Arial" pitchFamily="34" charset="-120"/>
               </a:rPr>
-              <a:t>La especificación (la DHU) es el artefacto central y va antes del código.</a:t>
-            </a:r>
-            <a:endParaRPr lang="en-US" sz="1100" dirty="0"/>
+              <a:t>Framework de desarrollo guiado por especificaciones. Antes de escribir código se produce y aprueba una spec (la DHU) con criterios de aceptación y mapa técnico — bcv-hu-implementer no genera código si la DHU tiene gaps sin resolver.</a:t>
+            </a:r>
+            <a:endParaRPr lang="en-US" sz="980" dirty="0"/>
           </a:p>
         </p:txBody>
       </p:sp>
@@ -3526,8 +3529,8 @@
         </p:nvSpPr>
         <p:spPr>
           <a:xfrm>
-            <a:off x="4937760" y="1847088"/>
-            <a:ext cx="3703320" cy="731520"/>
+            <a:off x="4937760" y="1828800"/>
+            <a:ext cx="3703320" cy="777240"/>
           </a:xfrm>
           <a:prstGeom prst="rect">
             <a:avLst/>
@@ -3540,10 +3543,13 @@
           <a:lstStyle/>
           <a:p>
             <a:pPr algn="l" indent="0" marL="0">
-              <a:buNone/>
-            </a:pPr>
-            <a:r>
-              <a:rPr lang="en-US" sz="1100" dirty="0">
+              <a:lnSpc>
+                <a:spcPct val="112000"/>
+              </a:lnSpc>
+              <a:buNone/>
+            </a:pPr>
+            <a:r>
+              <a:rPr lang="en-US" sz="980" dirty="0">
                 <a:solidFill>
                   <a:srgbClr val="FFFFFF"/>
                 </a:solidFill>
@@ -3551,9 +3557,9 @@
                 <a:ea typeface="Arial" pitchFamily="34" charset="-122"/>
                 <a:cs typeface="Arial" pitchFamily="34" charset="-120"/>
               </a:rPr>
-              <a:t>Understand → Design → Build → Validate, para la construcción de cada cambio.</a:t>
-            </a:r>
-            <a:endParaRPr lang="en-US" sz="1100" dirty="0"/>
+              <a:t>Framework de desarrollo ágil con IA. Es el ciclo interno que cada skill sigue al construir algo: Understand (entender la tarea y el código), Design (diseñar el cambio), Build (generarlo) y Validate (verificarlo).</a:t>
+            </a:r>
+            <a:endParaRPr lang="en-US" sz="980" dirty="0"/>
           </a:p>
         </p:txBody>
       </p:sp>
@@ -3739,7 +3745,7 @@
                           <a:ea typeface="Arial" pitchFamily="34" charset="-122"/>
                           <a:cs typeface="Arial" pitchFamily="34" charset="-120"/>
                         </a:rPr>
-                        <a:t>Especificar (entrada)</a:t>
+                        <a:t>Intención de entrada</a:t>
                       </a:r>
                       <a:endParaRPr lang="en-US" sz="1000" dirty="0">
                         <a:latin typeface="Arial" charset="0"/>
@@ -5689,7 +5695,7 @@
                 <a:ea typeface="Noto Sans" pitchFamily="34" charset="-122"/>
                 <a:cs typeface="Noto Sans" pitchFamily="34" charset="-120"/>
               </a:rPr>
-              <a:t>Solo 3 skills, un pipeline completo</a:t>
+              <a:t>Primera entrega: un plan de tareas validado</a:t>
             </a:r>
             <a:endParaRPr lang="en-US" sz="1200" dirty="0"/>
           </a:p>
@@ -5704,7 +5710,7 @@
         <p:spPr>
           <a:xfrm>
             <a:off x="594360" y="3703320"/>
-            <a:ext cx="8046720" cy="640080"/>
+            <a:ext cx="8046720" cy="685800"/>
           </a:xfrm>
           <a:prstGeom prst="rect">
             <a:avLst/>
@@ -5717,10 +5723,13 @@
           <a:lstStyle/>
           <a:p>
             <a:pPr algn="l" indent="0" marL="0">
-              <a:buNone/>
-            </a:pPr>
-            <a:r>
-              <a:rPr lang="en-US" sz="1100" dirty="0">
+              <a:lnSpc>
+                <a:spcPct val="115000"/>
+              </a:lnSpc>
+              <a:buNone/>
+            </a:pPr>
+            <a:r>
+              <a:rPr lang="en-US" sz="1050" dirty="0">
                 <a:solidFill>
                   <a:srgbClr val="D6D6D6"/>
                 </a:solidFill>
@@ -5728,9 +5737,9 @@
                 <a:ea typeface="Arial" pitchFamily="34" charset="-122"/>
                 <a:cs typeface="Arial" pitchFamily="34" charset="-120"/>
               </a:rPr>
-              <a:t>bcv-hu-context-analyzer (research con graphify), bcv-dhu-writer (especificación) y bcv-hu-implementer (implementación) cubren el flujo completo HU → DHU → código.</a:t>
-            </a:r>
-            <a:endParaRPr lang="en-US" sz="1100" dirty="0"/>
+              <a:t>bcv-hu-context-analyzer (research con graphify) y bcv-dhu-writer (especificación) ejecutan la primera parte del pipeline y entregan un plan de tareas (la DHU) validado. Desde ahí, bcv-hu-implementer aplica el plan y genera el código, iterando con el feedback del equipo dev.</a:t>
+            </a:r>
+            <a:endParaRPr lang="en-US" sz="1050" dirty="0"/>
           </a:p>
         </p:txBody>
       </p:sp>

</xml_diff>

<commit_message>
docs: update executive presentation with revised roadmap and additional skills
</commit_message>
<xml_diff>
--- a/presentations/presentacion-ejecutiva-skills-ia-bcv-resumen.pptx
+++ b/presentations/presentacion-ejecutiva-skills-ia-bcv-resumen.pptx
@@ -2272,7 +2272,7 @@
                 <a:ea typeface="Arial" pitchFamily="34" charset="-122"/>
                 <a:cs typeface="Arial" pitchFamily="34" charset="-120"/>
               </a:rPr>
-              <a:t>Cronograma: 13 ago → 09 oct 2026 · Sprint 2 en curso (4 sprints de 2 semanas + cierre)</a:t>
+              <a:t>Cronograma: 13 ago → 09 oct 2026 · Sprint 2 en curso (4 sprints de 2 semanas)</a:t>
             </a:r>
             <a:endParaRPr lang="en-US" sz="1150" dirty="0"/>
           </a:p>
@@ -9543,7 +9543,7 @@
                 <a:ea typeface="Arial" pitchFamily="34" charset="-122"/>
                 <a:cs typeface="Arial" pitchFamily="34" charset="-120"/>
               </a:rPr>
-              <a:t>Refinar los skills del pipeline según feedback</a:t>
+              <a:t>Skills adicionales: bcv-hexagonal-architecture y bcv-openapi-design</a:t>
             </a:r>
             <a:endParaRPr lang="en-US" sz="800" dirty="0"/>
           </a:p>
@@ -9612,7 +9612,7 @@
                 <a:ea typeface="Arial" pitchFamily="34" charset="-122"/>
                 <a:cs typeface="Arial" pitchFamily="34" charset="-120"/>
               </a:rPr>
-              <a:t>Avanzar el pipeline con la DHU (bcv-dhu-writer)</a:t>
+              <a:t>Sumar bcv-spring-data-jpa-sql-server (persistencia SQL Server)</a:t>
             </a:r>
             <a:endParaRPr lang="en-US" sz="800" dirty="0"/>
           </a:p>
@@ -9852,7 +9852,7 @@
         <p:spPr>
           <a:xfrm>
             <a:off x="6077712" y="1097280"/>
-            <a:ext cx="1839976" cy="292608"/>
+            <a:ext cx="2791968" cy="292608"/>
           </a:xfrm>
           <a:prstGeom prst="roundRect">
             <a:avLst>
@@ -9879,7 +9879,7 @@
         <p:spPr>
           <a:xfrm>
             <a:off x="6077712" y="1097280"/>
-            <a:ext cx="1839976" cy="292608"/>
+            <a:ext cx="2791968" cy="292608"/>
           </a:xfrm>
           <a:prstGeom prst="rect">
             <a:avLst/>
@@ -9918,7 +9918,7 @@
         <p:spPr>
           <a:xfrm>
             <a:off x="6077712" y="1408176"/>
-            <a:ext cx="1839976" cy="182880"/>
+            <a:ext cx="2791968" cy="182880"/>
           </a:xfrm>
           <a:prstGeom prst="rect">
             <a:avLst/>
@@ -9942,7 +9942,7 @@
                 <a:ea typeface="Arial" pitchFamily="34" charset="-122"/>
                 <a:cs typeface="Arial" pitchFamily="34" charset="-120"/>
               </a:rPr>
-              <a:t>24 sep–07 oct</a:t>
+              <a:t>24 sep–09 oct</a:t>
             </a:r>
             <a:endParaRPr lang="en-US" sz="800" dirty="0"/>
           </a:p>
@@ -10406,111 +10406,6 @@
         </p:nvSpPr>
         <p:spPr>
           <a:xfrm>
-            <a:off x="7981696" y="1097280"/>
-            <a:ext cx="887984" cy="292608"/>
-          </a:xfrm>
-          <a:prstGeom prst="roundRect">
-            <a:avLst>
-              <a:gd name="adj" fmla="val 50000"/>
-            </a:avLst>
-          </a:prstGeom>
-          <a:solidFill>
-            <a:srgbClr val="005B96"/>
-          </a:solidFill>
-          <a:ln w="12700">
-            <a:solidFill>
-              <a:srgbClr val="333333"/>
-            </a:solidFill>
-            <a:prstDash val="solid"/>
-          </a:ln>
-        </p:spPr>
-      </p:sp>
-      <p:sp>
-        <p:nvSpPr>
-          <p:cNvPr id="66" name="Text 63"/>
-          <p:cNvSpPr/>
-          <p:nvPr/>
-        </p:nvSpPr>
-        <p:spPr>
-          <a:xfrm>
-            <a:off x="7981696" y="1097280"/>
-            <a:ext cx="887984" cy="292608"/>
-          </a:xfrm>
-          <a:prstGeom prst="rect">
-            <a:avLst/>
-          </a:prstGeom>
-          <a:noFill/>
-          <a:ln/>
-        </p:spPr>
-        <p:txBody>
-          <a:bodyPr wrap="square" lIns="0" tIns="0" rIns="0" bIns="0" rtlCol="0" anchor="ctr"/>
-          <a:lstStyle/>
-          <a:p>
-            <a:pPr algn="ctr" indent="0" marL="0">
-              <a:buNone/>
-            </a:pPr>
-            <a:r>
-              <a:rPr lang="en-US" sz="1050" b="1" dirty="0">
-                <a:solidFill>
-                  <a:srgbClr val="FFFFFF"/>
-                </a:solidFill>
-                <a:latin typeface="Noto Sans" pitchFamily="34" charset="0"/>
-                <a:ea typeface="Noto Sans" pitchFamily="34" charset="-122"/>
-                <a:cs typeface="Noto Sans" pitchFamily="34" charset="-120"/>
-              </a:rPr>
-              <a:t>CIERRE</a:t>
-            </a:r>
-            <a:endParaRPr lang="en-US" sz="1050" dirty="0"/>
-          </a:p>
-        </p:txBody>
-      </p:sp>
-      <p:sp>
-        <p:nvSpPr>
-          <p:cNvPr id="67" name="Text 64"/>
-          <p:cNvSpPr/>
-          <p:nvPr/>
-        </p:nvSpPr>
-        <p:spPr>
-          <a:xfrm>
-            <a:off x="7981696" y="1408176"/>
-            <a:ext cx="887984" cy="182880"/>
-          </a:xfrm>
-          <a:prstGeom prst="rect">
-            <a:avLst/>
-          </a:prstGeom>
-          <a:noFill/>
-          <a:ln/>
-        </p:spPr>
-        <p:txBody>
-          <a:bodyPr wrap="square" lIns="0" tIns="0" rIns="0" bIns="0" rtlCol="0" anchor="ctr"/>
-          <a:lstStyle/>
-          <a:p>
-            <a:pPr algn="ctr" indent="0" marL="0">
-              <a:buNone/>
-            </a:pPr>
-            <a:r>
-              <a:rPr lang="en-US" sz="800" dirty="0">
-                <a:solidFill>
-                  <a:srgbClr val="D6D6D6"/>
-                </a:solidFill>
-                <a:latin typeface="Arial" pitchFamily="34" charset="0"/>
-                <a:ea typeface="Arial" pitchFamily="34" charset="-122"/>
-                <a:cs typeface="Arial" pitchFamily="34" charset="-120"/>
-              </a:rPr>
-              <a:t>08–09 oct</a:t>
-            </a:r>
-            <a:endParaRPr lang="en-US" sz="800" dirty="0"/>
-          </a:p>
-        </p:txBody>
-      </p:sp>
-      <p:sp>
-        <p:nvSpPr>
-          <p:cNvPr id="68" name="Shape 65"/>
-          <p:cNvSpPr/>
-          <p:nvPr/>
-        </p:nvSpPr>
-        <p:spPr>
-          <a:xfrm>
             <a:off x="7981696" y="1645920"/>
             <a:ext cx="887984" cy="365760"/>
           </a:xfrm>
@@ -10532,7 +10427,7 @@
       </p:sp>
       <p:sp>
         <p:nvSpPr>
-          <p:cNvPr id="69" name="Text 66"/>
+          <p:cNvPr id="66" name="Text 63"/>
           <p:cNvSpPr/>
           <p:nvPr/>
         </p:nvSpPr>
@@ -10592,7 +10487,7 @@
       </p:sp>
       <p:sp>
         <p:nvSpPr>
-          <p:cNvPr id="70" name="Shape 67"/>
+          <p:cNvPr id="67" name="Shape 64"/>
           <p:cNvSpPr/>
           <p:nvPr/>
         </p:nvSpPr>
@@ -10619,7 +10514,7 @@
       </p:sp>
       <p:sp>
         <p:nvSpPr>
-          <p:cNvPr id="71" name="Text 68"/>
+          <p:cNvPr id="68" name="Text 65"/>
           <p:cNvSpPr/>
           <p:nvPr/>
         </p:nvSpPr>
@@ -10661,7 +10556,7 @@
       </p:sp>
       <p:sp>
         <p:nvSpPr>
-          <p:cNvPr id="72" name="Shape 69"/>
+          <p:cNvPr id="69" name="Shape 66"/>
           <p:cNvSpPr/>
           <p:nvPr/>
         </p:nvSpPr>
@@ -10688,7 +10583,7 @@
       </p:sp>
       <p:sp>
         <p:nvSpPr>
-          <p:cNvPr id="73" name="Text 70"/>
+          <p:cNvPr id="70" name="Text 67"/>
           <p:cNvSpPr/>
           <p:nvPr/>
         </p:nvSpPr>
@@ -10730,7 +10625,7 @@
       </p:sp>
       <p:sp>
         <p:nvSpPr>
-          <p:cNvPr id="74" name="Shape 71"/>
+          <p:cNvPr id="71" name="Shape 68"/>
           <p:cNvSpPr/>
           <p:nvPr/>
         </p:nvSpPr>
@@ -10757,7 +10652,7 @@
       </p:sp>
       <p:sp>
         <p:nvSpPr>
-          <p:cNvPr id="75" name="Text 72"/>
+          <p:cNvPr id="72" name="Text 69"/>
           <p:cNvSpPr/>
           <p:nvPr/>
         </p:nvSpPr>
@@ -10796,7 +10691,7 @@
       </p:sp>
       <p:sp>
         <p:nvSpPr>
-          <p:cNvPr id="76" name="Shape 73"/>
+          <p:cNvPr id="73" name="Shape 70"/>
           <p:cNvSpPr/>
           <p:nvPr/>
         </p:nvSpPr>
@@ -10823,7 +10718,7 @@
       </p:sp>
       <p:sp>
         <p:nvSpPr>
-          <p:cNvPr id="77" name="Text 74"/>
+          <p:cNvPr id="74" name="Text 71"/>
           <p:cNvSpPr/>
           <p:nvPr/>
         </p:nvSpPr>
@@ -10862,7 +10757,7 @@
       </p:sp>
       <p:sp>
         <p:nvSpPr>
-          <p:cNvPr id="78" name="Shape 75"/>
+          <p:cNvPr id="75" name="Shape 72"/>
           <p:cNvSpPr/>
           <p:nvPr/>
         </p:nvSpPr>
@@ -10889,7 +10784,7 @@
       </p:sp>
       <p:sp>
         <p:nvSpPr>
-          <p:cNvPr id="79" name="Text 76"/>
+          <p:cNvPr id="76" name="Text 73"/>
           <p:cNvSpPr/>
           <p:nvPr/>
         </p:nvSpPr>
@@ -10928,7 +10823,7 @@
       </p:sp>
       <p:pic>
         <p:nvPicPr>
-          <p:cNvPr id="80" name="Image 1" descr="preencoded.png">    </p:cNvPr>
+          <p:cNvPr id="77" name="Image 1" descr="preencoded.png">    </p:cNvPr>
           <p:cNvPicPr>
             <a:picLocks noChangeAspect="1"/>
           </p:cNvPicPr>
@@ -10952,7 +10847,7 @@
       </p:pic>
       <p:sp>
         <p:nvSpPr>
-          <p:cNvPr id="81" name="Text 77"/>
+          <p:cNvPr id="78" name="Text 74"/>
           <p:cNvSpPr/>
           <p:nvPr/>
         </p:nvSpPr>
@@ -10991,7 +10886,7 @@
       </p:sp>
       <p:sp>
         <p:nvSpPr>
-          <p:cNvPr id="82" name="Text 78"/>
+          <p:cNvPr id="79" name="Text 75"/>
           <p:cNvSpPr/>
           <p:nvPr/>
         </p:nvSpPr>
@@ -11158,12 +11053,12 @@
         </p:nvSpPr>
         <p:spPr>
           <a:xfrm>
-            <a:off x="365760" y="1417320"/>
-            <a:ext cx="8503920" cy="914400"/>
+            <a:off x="365760" y="1234440"/>
+            <a:ext cx="8503920" cy="960120"/>
           </a:xfrm>
           <a:prstGeom prst="roundRect">
             <a:avLst>
-              <a:gd name="adj" fmla="val 6000"/>
+              <a:gd name="adj" fmla="val 5714"/>
             </a:avLst>
           </a:prstGeom>
           <a:solidFill>
@@ -11185,7 +11080,7 @@
         </p:nvSpPr>
         <p:spPr>
           <a:xfrm>
-            <a:off x="594360" y="1700784"/>
+            <a:off x="594360" y="1540764"/>
             <a:ext cx="347472" cy="347472"/>
           </a:xfrm>
           <a:prstGeom prst="ellipse">
@@ -11210,7 +11105,7 @@
         </p:nvSpPr>
         <p:spPr>
           <a:xfrm>
-            <a:off x="594360" y="1700784"/>
+            <a:off x="594360" y="1540764"/>
             <a:ext cx="347472" cy="347472"/>
           </a:xfrm>
           <a:prstGeom prst="rect">
@@ -11249,8 +11144,8 @@
         </p:nvSpPr>
         <p:spPr>
           <a:xfrm>
-            <a:off x="1143000" y="1545336"/>
-            <a:ext cx="7498080" cy="292608"/>
+            <a:off x="1143000" y="1344168"/>
+            <a:ext cx="7498080" cy="274320"/>
           </a:xfrm>
           <a:prstGeom prst="rect">
             <a:avLst/>
@@ -11266,7 +11161,7 @@
               <a:buNone/>
             </a:pPr>
             <a:r>
-              <a:rPr lang="en-US" sz="1400" b="1" dirty="0">
+              <a:rPr lang="en-US" sz="1350" b="1" dirty="0">
                 <a:solidFill>
                   <a:srgbClr val="00DFED"/>
                 </a:solidFill>
@@ -11274,9 +11169,9 @@
                 <a:ea typeface="Noto Sans" pitchFamily="34" charset="-122"/>
                 <a:cs typeface="Noto Sans" pitchFamily="34" charset="-120"/>
               </a:rPr>
-              <a:t>Iterar los skills en las próximas HUs</a:t>
-            </a:r>
-            <a:endParaRPr lang="en-US" sz="1400" dirty="0"/>
+              <a:t>Skills adicionales: bcv-hexagonal-architecture y bcv-openapi-design</a:t>
+            </a:r>
+            <a:endParaRPr lang="en-US" sz="1350" dirty="0"/>
           </a:p>
         </p:txBody>
       </p:sp>
@@ -11288,8 +11183,8 @@
         </p:nvSpPr>
         <p:spPr>
           <a:xfrm>
-            <a:off x="1143000" y="1874520"/>
-            <a:ext cx="7498080" cy="402336"/>
+            <a:off x="1143000" y="1636776"/>
+            <a:ext cx="7498080" cy="502920"/>
           </a:xfrm>
           <a:prstGeom prst="rect">
             <a:avLst/>
@@ -11302,10 +11197,13 @@
           <a:lstStyle/>
           <a:p>
             <a:pPr algn="l" indent="0" marL="0">
-              <a:buNone/>
-            </a:pPr>
-            <a:r>
-              <a:rPr lang="en-US" sz="1100" dirty="0">
+              <a:lnSpc>
+                <a:spcPct val="108000"/>
+              </a:lnSpc>
+              <a:buNone/>
+            </a:pPr>
+            <a:r>
+              <a:rPr lang="en-US" sz="1000" dirty="0">
                 <a:solidFill>
                   <a:srgbClr val="D6D6D6"/>
                 </a:solidFill>
@@ -11313,9 +11211,9 @@
                 <a:ea typeface="Arial" pitchFamily="34" charset="-122"/>
                 <a:cs typeface="Arial" pitchFamily="34" charset="-120"/>
               </a:rPr>
-              <a:t>Ampliar su cobertura con casos de uso adicionales del banco, sobre Historias de Usuario reales.</a:t>
-            </a:r>
-            <a:endParaRPr lang="en-US" sz="1100" dirty="0"/>
+              <a:t>Complementan el pipeline: hexagonal-architecture define el patrón de todo el código, y openapi-design define lo que se expone y valida la HU contra su contrato. bcv-spring-data-jpa-sql-server (persistencia SQL Server, usada por casi toda HU) se suma como tercer complemento.</a:t>
+            </a:r>
+            <a:endParaRPr lang="en-US" sz="1000" dirty="0"/>
           </a:p>
         </p:txBody>
       </p:sp>
@@ -11327,12 +11225,12 @@
         </p:nvSpPr>
         <p:spPr>
           <a:xfrm>
-            <a:off x="365760" y="2496312"/>
-            <a:ext cx="8503920" cy="914400"/>
+            <a:off x="365760" y="2313432"/>
+            <a:ext cx="8503920" cy="731520"/>
           </a:xfrm>
           <a:prstGeom prst="roundRect">
             <a:avLst>
-              <a:gd name="adj" fmla="val 6000"/>
+              <a:gd name="adj" fmla="val 7500"/>
             </a:avLst>
           </a:prstGeom>
           <a:solidFill>
@@ -11354,7 +11252,7 @@
         </p:nvSpPr>
         <p:spPr>
           <a:xfrm>
-            <a:off x="594360" y="2779776"/>
+            <a:off x="594360" y="2505456"/>
             <a:ext cx="347472" cy="347472"/>
           </a:xfrm>
           <a:prstGeom prst="ellipse">
@@ -11379,7 +11277,7 @@
         </p:nvSpPr>
         <p:spPr>
           <a:xfrm>
-            <a:off x="594360" y="2779776"/>
+            <a:off x="594360" y="2505456"/>
             <a:ext cx="347472" cy="347472"/>
           </a:xfrm>
           <a:prstGeom prst="rect">
@@ -11418,8 +11316,8 @@
         </p:nvSpPr>
         <p:spPr>
           <a:xfrm>
-            <a:off x="1143000" y="2624328"/>
-            <a:ext cx="7498080" cy="292608"/>
+            <a:off x="1143000" y="2423160"/>
+            <a:ext cx="7498080" cy="274320"/>
           </a:xfrm>
           <a:prstGeom prst="rect">
             <a:avLst/>
@@ -11435,7 +11333,7 @@
               <a:buNone/>
             </a:pPr>
             <a:r>
-              <a:rPr lang="en-US" sz="1400" b="1" dirty="0">
+              <a:rPr lang="en-US" sz="1350" b="1" dirty="0">
                 <a:solidFill>
                   <a:srgbClr val="00DFED"/>
                 </a:solidFill>
@@ -11443,9 +11341,9 @@
                 <a:ea typeface="Noto Sans" pitchFamily="34" charset="-122"/>
                 <a:cs typeface="Noto Sans" pitchFamily="34" charset="-120"/>
               </a:rPr>
-              <a:t>Oscar queda a cargo del proyecto</a:t>
-            </a:r>
-            <a:endParaRPr lang="en-US" sz="1400" dirty="0"/>
+              <a:t>Iterar los skills en las próximas HUs</a:t>
+            </a:r>
+            <a:endParaRPr lang="en-US" sz="1350" dirty="0"/>
           </a:p>
         </p:txBody>
       </p:sp>
@@ -11457,8 +11355,8 @@
         </p:nvSpPr>
         <p:spPr>
           <a:xfrm>
-            <a:off x="1143000" y="2953512"/>
-            <a:ext cx="7498080" cy="402336"/>
+            <a:off x="1143000" y="2715768"/>
+            <a:ext cx="7498080" cy="274320"/>
           </a:xfrm>
           <a:prstGeom prst="rect">
             <a:avLst/>
@@ -11471,10 +11369,13 @@
           <a:lstStyle/>
           <a:p>
             <a:pPr algn="l" indent="0" marL="0">
-              <a:buNone/>
-            </a:pPr>
-            <a:r>
-              <a:rPr lang="en-US" sz="1100" dirty="0">
+              <a:lnSpc>
+                <a:spcPct val="108000"/>
+              </a:lnSpc>
+              <a:buNone/>
+            </a:pPr>
+            <a:r>
+              <a:rPr lang="en-US" sz="1000" dirty="0">
                 <a:solidFill>
                   <a:srgbClr val="D6D6D6"/>
                 </a:solidFill>
@@ -11482,9 +11383,9 @@
                 <a:ea typeface="Arial" pitchFamily="34" charset="-122"/>
                 <a:cs typeface="Arial" pitchFamily="34" charset="-120"/>
               </a:rPr>
-              <a:t>Tras el traspaso del Arquitecto IA (10 sep): soporte continuo y afinación de los skills.</a:t>
-            </a:r>
-            <a:endParaRPr lang="en-US" sz="1100" dirty="0"/>
+              <a:t>Ampliar su cobertura con casos de uso adicionales del banco, sobre Historias de Usuario reales.</a:t>
+            </a:r>
+            <a:endParaRPr lang="en-US" sz="1000" dirty="0"/>
           </a:p>
         </p:txBody>
       </p:sp>
@@ -11496,12 +11397,12 @@
         </p:nvSpPr>
         <p:spPr>
           <a:xfrm>
-            <a:off x="365760" y="3575304"/>
-            <a:ext cx="8503920" cy="914400"/>
+            <a:off x="365760" y="3163824"/>
+            <a:ext cx="8503920" cy="731520"/>
           </a:xfrm>
           <a:prstGeom prst="roundRect">
             <a:avLst>
-              <a:gd name="adj" fmla="val 6000"/>
+              <a:gd name="adj" fmla="val 7500"/>
             </a:avLst>
           </a:prstGeom>
           <a:solidFill>
@@ -11523,7 +11424,7 @@
         </p:nvSpPr>
         <p:spPr>
           <a:xfrm>
-            <a:off x="594360" y="3858768"/>
+            <a:off x="594360" y="3355848"/>
             <a:ext cx="347472" cy="347472"/>
           </a:xfrm>
           <a:prstGeom prst="ellipse">
@@ -11548,7 +11449,7 @@
         </p:nvSpPr>
         <p:spPr>
           <a:xfrm>
-            <a:off x="594360" y="3858768"/>
+            <a:off x="594360" y="3355848"/>
             <a:ext cx="347472" cy="347472"/>
           </a:xfrm>
           <a:prstGeom prst="rect">
@@ -11587,8 +11488,8 @@
         </p:nvSpPr>
         <p:spPr>
           <a:xfrm>
-            <a:off x="1143000" y="3703320"/>
-            <a:ext cx="7498080" cy="292608"/>
+            <a:off x="1143000" y="3273552"/>
+            <a:ext cx="7498080" cy="274320"/>
           </a:xfrm>
           <a:prstGeom prst="rect">
             <a:avLst/>
@@ -11604,7 +11505,7 @@
               <a:buNone/>
             </a:pPr>
             <a:r>
-              <a:rPr lang="en-US" sz="1400" b="1" dirty="0">
+              <a:rPr lang="en-US" sz="1350" b="1" dirty="0">
                 <a:solidFill>
                   <a:srgbClr val="00DFED"/>
                 </a:solidFill>
@@ -11612,9 +11513,9 @@
                 <a:ea typeface="Noto Sans" pitchFamily="34" charset="-122"/>
                 <a:cs typeface="Noto Sans" pitchFamily="34" charset="-120"/>
               </a:rPr>
-              <a:t>Refinar los skills</a:t>
-            </a:r>
-            <a:endParaRPr lang="en-US" sz="1400" dirty="0"/>
+              <a:t>Oscar queda a cargo del proyecto</a:t>
+            </a:r>
+            <a:endParaRPr lang="en-US" sz="1350" dirty="0"/>
           </a:p>
         </p:txBody>
       </p:sp>
@@ -11626,8 +11527,8 @@
         </p:nvSpPr>
         <p:spPr>
           <a:xfrm>
-            <a:off x="1143000" y="4032504"/>
-            <a:ext cx="7498080" cy="402336"/>
+            <a:off x="1143000" y="3566160"/>
+            <a:ext cx="7498080" cy="274320"/>
           </a:xfrm>
           <a:prstGeom prst="rect">
             <a:avLst/>
@@ -11640,10 +11541,13 @@
           <a:lstStyle/>
           <a:p>
             <a:pPr algn="l" indent="0" marL="0">
-              <a:buNone/>
-            </a:pPr>
-            <a:r>
-              <a:rPr lang="en-US" sz="1100" dirty="0">
+              <a:lnSpc>
+                <a:spcPct val="108000"/>
+              </a:lnSpc>
+              <a:buNone/>
+            </a:pPr>
+            <a:r>
+              <a:rPr lang="en-US" sz="1000" dirty="0">
                 <a:solidFill>
                   <a:srgbClr val="D6D6D6"/>
                 </a:solidFill>
@@ -11651,15 +11555,187 @@
                 <a:ea typeface="Arial" pitchFamily="34" charset="-122"/>
                 <a:cs typeface="Arial" pitchFamily="34" charset="-120"/>
               </a:rPr>
+              <a:t>Tras el traspaso del Arquitecto IA (10 sep): soporte continuo y afinación de los skills.</a:t>
+            </a:r>
+            <a:endParaRPr lang="en-US" sz="1000" dirty="0"/>
+          </a:p>
+        </p:txBody>
+      </p:sp>
+      <p:sp>
+        <p:nvSpPr>
+          <p:cNvPr id="20" name="Shape 17"/>
+          <p:cNvSpPr/>
+          <p:nvPr/>
+        </p:nvSpPr>
+        <p:spPr>
+          <a:xfrm>
+            <a:off x="365760" y="4014216"/>
+            <a:ext cx="8503920" cy="731520"/>
+          </a:xfrm>
+          <a:prstGeom prst="roundRect">
+            <a:avLst>
+              <a:gd name="adj" fmla="val 7500"/>
+            </a:avLst>
+          </a:prstGeom>
+          <a:solidFill>
+            <a:srgbClr val="0A1A2E"/>
+          </a:solidFill>
+          <a:ln w="12700">
+            <a:solidFill>
+              <a:srgbClr val="1A2B4A"/>
+            </a:solidFill>
+            <a:prstDash val="solid"/>
+          </a:ln>
+        </p:spPr>
+      </p:sp>
+      <p:sp>
+        <p:nvSpPr>
+          <p:cNvPr id="21" name="Shape 18"/>
+          <p:cNvSpPr/>
+          <p:nvPr/>
+        </p:nvSpPr>
+        <p:spPr>
+          <a:xfrm>
+            <a:off x="594360" y="4206240"/>
+            <a:ext cx="347472" cy="347472"/>
+          </a:xfrm>
+          <a:prstGeom prst="ellipse">
+            <a:avLst/>
+          </a:prstGeom>
+          <a:solidFill>
+            <a:srgbClr val="00CB5D"/>
+          </a:solidFill>
+          <a:ln w="12700">
+            <a:solidFill>
+              <a:srgbClr val="333333"/>
+            </a:solidFill>
+            <a:prstDash val="solid"/>
+          </a:ln>
+        </p:spPr>
+      </p:sp>
+      <p:sp>
+        <p:nvSpPr>
+          <p:cNvPr id="22" name="Text 19"/>
+          <p:cNvSpPr/>
+          <p:nvPr/>
+        </p:nvSpPr>
+        <p:spPr>
+          <a:xfrm>
+            <a:off x="594360" y="4206240"/>
+            <a:ext cx="347472" cy="347472"/>
+          </a:xfrm>
+          <a:prstGeom prst="rect">
+            <a:avLst/>
+          </a:prstGeom>
+          <a:noFill/>
+          <a:ln/>
+        </p:spPr>
+        <p:txBody>
+          <a:bodyPr wrap="square" lIns="0" tIns="0" rIns="0" bIns="0" rtlCol="0" anchor="ctr"/>
+          <a:lstStyle/>
+          <a:p>
+            <a:pPr algn="ctr" indent="0" marL="0">
+              <a:buNone/>
+            </a:pPr>
+            <a:r>
+              <a:rPr lang="en-US" sz="1300" b="1" dirty="0">
+                <a:solidFill>
+                  <a:srgbClr val="FFFFFF"/>
+                </a:solidFill>
+                <a:latin typeface="Noto Sans" pitchFamily="34" charset="0"/>
+                <a:ea typeface="Noto Sans" pitchFamily="34" charset="-122"/>
+                <a:cs typeface="Noto Sans" pitchFamily="34" charset="-120"/>
+              </a:rPr>
+              <a:t>4</a:t>
+            </a:r>
+            <a:endParaRPr lang="en-US" sz="1300" dirty="0"/>
+          </a:p>
+        </p:txBody>
+      </p:sp>
+      <p:sp>
+        <p:nvSpPr>
+          <p:cNvPr id="23" name="Text 20"/>
+          <p:cNvSpPr/>
+          <p:nvPr/>
+        </p:nvSpPr>
+        <p:spPr>
+          <a:xfrm>
+            <a:off x="1143000" y="4123944"/>
+            <a:ext cx="7498080" cy="274320"/>
+          </a:xfrm>
+          <a:prstGeom prst="rect">
+            <a:avLst/>
+          </a:prstGeom>
+          <a:noFill/>
+          <a:ln/>
+        </p:spPr>
+        <p:txBody>
+          <a:bodyPr wrap="square" lIns="0" tIns="0" rIns="0" bIns="0" rtlCol="0" anchor="ctr"/>
+          <a:lstStyle/>
+          <a:p>
+            <a:pPr algn="l" indent="0" marL="0">
+              <a:buNone/>
+            </a:pPr>
+            <a:r>
+              <a:rPr lang="en-US" sz="1350" b="1" dirty="0">
+                <a:solidFill>
+                  <a:srgbClr val="00DFED"/>
+                </a:solidFill>
+                <a:latin typeface="Noto Sans" pitchFamily="34" charset="0"/>
+                <a:ea typeface="Noto Sans" pitchFamily="34" charset="-122"/>
+                <a:cs typeface="Noto Sans" pitchFamily="34" charset="-120"/>
+              </a:rPr>
+              <a:t>Refinar los skills</a:t>
+            </a:r>
+            <a:endParaRPr lang="en-US" sz="1350" dirty="0"/>
+          </a:p>
+        </p:txBody>
+      </p:sp>
+      <p:sp>
+        <p:nvSpPr>
+          <p:cNvPr id="24" name="Text 21"/>
+          <p:cNvSpPr/>
+          <p:nvPr/>
+        </p:nvSpPr>
+        <p:spPr>
+          <a:xfrm>
+            <a:off x="1143000" y="4416552"/>
+            <a:ext cx="7498080" cy="274320"/>
+          </a:xfrm>
+          <a:prstGeom prst="rect">
+            <a:avLst/>
+          </a:prstGeom>
+          <a:noFill/>
+          <a:ln/>
+        </p:spPr>
+        <p:txBody>
+          <a:bodyPr wrap="square" lIns="381" tIns="381" rIns="381" bIns="381" rtlCol="0" anchor="ctr"/>
+          <a:lstStyle/>
+          <a:p>
+            <a:pPr algn="l" indent="0" marL="0">
+              <a:lnSpc>
+                <a:spcPct val="108000"/>
+              </a:lnSpc>
+              <a:buNone/>
+            </a:pPr>
+            <a:r>
+              <a:rPr lang="en-US" sz="1000" dirty="0">
+                <a:solidFill>
+                  <a:srgbClr val="D6D6D6"/>
+                </a:solidFill>
+                <a:latin typeface="Arial" pitchFamily="34" charset="0"/>
+                <a:ea typeface="Arial" pitchFamily="34" charset="-122"/>
+                <a:cs typeface="Arial" pitchFamily="34" charset="-120"/>
+              </a:rPr>
               <a:t>Con más código real y el feedback continuo del equipo dev del banco.</a:t>
             </a:r>
-            <a:endParaRPr lang="en-US" sz="1100" dirty="0"/>
+            <a:endParaRPr lang="en-US" sz="1000" dirty="0"/>
           </a:p>
         </p:txBody>
       </p:sp>
       <p:pic>
         <p:nvPicPr>
-          <p:cNvPr id="20" name="Image 1" descr="preencoded.png">    </p:cNvPr>
+          <p:cNvPr id="25" name="Image 1" descr="preencoded.png">    </p:cNvPr>
           <p:cNvPicPr>
             <a:picLocks noChangeAspect="1"/>
           </p:cNvPicPr>
@@ -11683,7 +11759,7 @@
       </p:pic>
       <p:sp>
         <p:nvSpPr>
-          <p:cNvPr id="21" name="Text 17"/>
+          <p:cNvPr id="26" name="Text 22"/>
           <p:cNvSpPr/>
           <p:nvPr/>
         </p:nvSpPr>
@@ -11722,7 +11798,7 @@
       </p:sp>
       <p:sp>
         <p:nvSpPr>
-          <p:cNvPr id="22" name="Text 18"/>
+          <p:cNvPr id="27" name="Text 23"/>
           <p:cNvSpPr/>
           <p:nvPr/>
         </p:nvSpPr>

</xml_diff>

<commit_message>
docs: update executive presentation with revised sprint details and additional skills
</commit_message>
<xml_diff>
--- a/presentations/presentacion-ejecutiva-skills-ia-bcv-resumen.pptx
+++ b/presentations/presentacion-ejecutiva-skills-ia-bcv-resumen.pptx
@@ -8186,12 +8186,12 @@
         </p:nvSpPr>
         <p:spPr>
           <a:xfrm>
-            <a:off x="365760" y="1097280"/>
-            <a:ext cx="1839976" cy="292608"/>
+            <a:off x="365760" y="1060704"/>
+            <a:ext cx="2077974" cy="274320"/>
           </a:xfrm>
           <a:prstGeom prst="roundRect">
             <a:avLst>
-              <a:gd name="adj" fmla="val 50000"/>
+              <a:gd name="adj" fmla="val 53333"/>
             </a:avLst>
           </a:prstGeom>
           <a:solidFill>
@@ -8213,8 +8213,8 @@
         </p:nvSpPr>
         <p:spPr>
           <a:xfrm>
-            <a:off x="365760" y="1097280"/>
-            <a:ext cx="1839976" cy="292608"/>
+            <a:off x="365760" y="1060704"/>
+            <a:ext cx="2077974" cy="274320"/>
           </a:xfrm>
           <a:prstGeom prst="rect">
             <a:avLst/>
@@ -8252,8 +8252,8 @@
         </p:nvSpPr>
         <p:spPr>
           <a:xfrm>
-            <a:off x="365760" y="1408176"/>
-            <a:ext cx="1839976" cy="182880"/>
+            <a:off x="365760" y="1362456"/>
+            <a:ext cx="2077974" cy="182880"/>
           </a:xfrm>
           <a:prstGeom prst="rect">
             <a:avLst/>
@@ -8277,7 +8277,7 @@
                 <a:ea typeface="Arial" pitchFamily="34" charset="-122"/>
                 <a:cs typeface="Arial" pitchFamily="34" charset="-120"/>
               </a:rPr>
-              <a:t>13–26 ago</a:t>
+              <a:t>13–28 ago</a:t>
             </a:r>
             <a:endParaRPr lang="en-US" sz="800" dirty="0"/>
           </a:p>
@@ -8291,12 +8291,327 @@
         </p:nvSpPr>
         <p:spPr>
           <a:xfrm>
-            <a:off x="365760" y="1645920"/>
-            <a:ext cx="887984" cy="365760"/>
+            <a:off x="2507742" y="1060704"/>
+            <a:ext cx="2077974" cy="274320"/>
           </a:xfrm>
           <a:prstGeom prst="roundRect">
             <a:avLst>
-              <a:gd name="adj" fmla="val 35000"/>
+              <a:gd name="adj" fmla="val 53333"/>
+            </a:avLst>
+          </a:prstGeom>
+          <a:solidFill>
+            <a:srgbClr val="005B96"/>
+          </a:solidFill>
+          <a:ln w="12700">
+            <a:solidFill>
+              <a:srgbClr val="333333"/>
+            </a:solidFill>
+            <a:prstDash val="solid"/>
+          </a:ln>
+        </p:spPr>
+      </p:sp>
+      <p:sp>
+        <p:nvSpPr>
+          <p:cNvPr id="9" name="Text 6"/>
+          <p:cNvSpPr/>
+          <p:nvPr/>
+        </p:nvSpPr>
+        <p:spPr>
+          <a:xfrm>
+            <a:off x="2507742" y="1060704"/>
+            <a:ext cx="2077974" cy="274320"/>
+          </a:xfrm>
+          <a:prstGeom prst="rect">
+            <a:avLst/>
+          </a:prstGeom>
+          <a:noFill/>
+          <a:ln/>
+        </p:spPr>
+        <p:txBody>
+          <a:bodyPr wrap="square" lIns="0" tIns="0" rIns="0" bIns="0" rtlCol="0" anchor="ctr"/>
+          <a:lstStyle/>
+          <a:p>
+            <a:pPr algn="ctr" indent="0" marL="0">
+              <a:buNone/>
+            </a:pPr>
+            <a:r>
+              <a:rPr lang="en-US" sz="1050" b="1" dirty="0">
+                <a:solidFill>
+                  <a:srgbClr val="FFFFFF"/>
+                </a:solidFill>
+                <a:latin typeface="Noto Sans" pitchFamily="34" charset="0"/>
+                <a:ea typeface="Noto Sans" pitchFamily="34" charset="-122"/>
+                <a:cs typeface="Noto Sans" pitchFamily="34" charset="-120"/>
+              </a:rPr>
+              <a:t>SPRINT 2</a:t>
+            </a:r>
+            <a:endParaRPr lang="en-US" sz="1050" dirty="0"/>
+          </a:p>
+        </p:txBody>
+      </p:sp>
+      <p:sp>
+        <p:nvSpPr>
+          <p:cNvPr id="10" name="Text 7"/>
+          <p:cNvSpPr/>
+          <p:nvPr/>
+        </p:nvSpPr>
+        <p:spPr>
+          <a:xfrm>
+            <a:off x="2507742" y="1362456"/>
+            <a:ext cx="2077974" cy="182880"/>
+          </a:xfrm>
+          <a:prstGeom prst="rect">
+            <a:avLst/>
+          </a:prstGeom>
+          <a:noFill/>
+          <a:ln/>
+        </p:spPr>
+        <p:txBody>
+          <a:bodyPr wrap="square" lIns="0" tIns="0" rIns="0" bIns="0" rtlCol="0" anchor="ctr"/>
+          <a:lstStyle/>
+          <a:p>
+            <a:pPr algn="ctr" indent="0" marL="0">
+              <a:buNone/>
+            </a:pPr>
+            <a:r>
+              <a:rPr lang="en-US" sz="800" dirty="0">
+                <a:solidFill>
+                  <a:srgbClr val="D6D6D6"/>
+                </a:solidFill>
+                <a:latin typeface="Arial" pitchFamily="34" charset="0"/>
+                <a:ea typeface="Arial" pitchFamily="34" charset="-122"/>
+                <a:cs typeface="Arial" pitchFamily="34" charset="-120"/>
+              </a:rPr>
+              <a:t>31 ago–11 sep</a:t>
+            </a:r>
+            <a:endParaRPr lang="en-US" sz="800" dirty="0"/>
+          </a:p>
+        </p:txBody>
+      </p:sp>
+      <p:sp>
+        <p:nvSpPr>
+          <p:cNvPr id="11" name="Shape 8"/>
+          <p:cNvSpPr/>
+          <p:nvPr/>
+        </p:nvSpPr>
+        <p:spPr>
+          <a:xfrm>
+            <a:off x="4649724" y="1060704"/>
+            <a:ext cx="2077974" cy="274320"/>
+          </a:xfrm>
+          <a:prstGeom prst="roundRect">
+            <a:avLst>
+              <a:gd name="adj" fmla="val 53333"/>
+            </a:avLst>
+          </a:prstGeom>
+          <a:solidFill>
+            <a:srgbClr val="005B96"/>
+          </a:solidFill>
+          <a:ln w="12700">
+            <a:solidFill>
+              <a:srgbClr val="333333"/>
+            </a:solidFill>
+            <a:prstDash val="solid"/>
+          </a:ln>
+        </p:spPr>
+      </p:sp>
+      <p:sp>
+        <p:nvSpPr>
+          <p:cNvPr id="12" name="Text 9"/>
+          <p:cNvSpPr/>
+          <p:nvPr/>
+        </p:nvSpPr>
+        <p:spPr>
+          <a:xfrm>
+            <a:off x="4649724" y="1060704"/>
+            <a:ext cx="2077974" cy="274320"/>
+          </a:xfrm>
+          <a:prstGeom prst="rect">
+            <a:avLst/>
+          </a:prstGeom>
+          <a:noFill/>
+          <a:ln/>
+        </p:spPr>
+        <p:txBody>
+          <a:bodyPr wrap="square" lIns="0" tIns="0" rIns="0" bIns="0" rtlCol="0" anchor="ctr"/>
+          <a:lstStyle/>
+          <a:p>
+            <a:pPr algn="ctr" indent="0" marL="0">
+              <a:buNone/>
+            </a:pPr>
+            <a:r>
+              <a:rPr lang="en-US" sz="1050" b="1" dirty="0">
+                <a:solidFill>
+                  <a:srgbClr val="FFFFFF"/>
+                </a:solidFill>
+                <a:latin typeface="Noto Sans" pitchFamily="34" charset="0"/>
+                <a:ea typeface="Noto Sans" pitchFamily="34" charset="-122"/>
+                <a:cs typeface="Noto Sans" pitchFamily="34" charset="-120"/>
+              </a:rPr>
+              <a:t>SPRINT 3</a:t>
+            </a:r>
+            <a:endParaRPr lang="en-US" sz="1050" dirty="0"/>
+          </a:p>
+        </p:txBody>
+      </p:sp>
+      <p:sp>
+        <p:nvSpPr>
+          <p:cNvPr id="13" name="Text 10"/>
+          <p:cNvSpPr/>
+          <p:nvPr/>
+        </p:nvSpPr>
+        <p:spPr>
+          <a:xfrm>
+            <a:off x="4649724" y="1362456"/>
+            <a:ext cx="2077974" cy="182880"/>
+          </a:xfrm>
+          <a:prstGeom prst="rect">
+            <a:avLst/>
+          </a:prstGeom>
+          <a:noFill/>
+          <a:ln/>
+        </p:spPr>
+        <p:txBody>
+          <a:bodyPr wrap="square" lIns="0" tIns="0" rIns="0" bIns="0" rtlCol="0" anchor="ctr"/>
+          <a:lstStyle/>
+          <a:p>
+            <a:pPr algn="ctr" indent="0" marL="0">
+              <a:buNone/>
+            </a:pPr>
+            <a:r>
+              <a:rPr lang="en-US" sz="800" dirty="0">
+                <a:solidFill>
+                  <a:srgbClr val="D6D6D6"/>
+                </a:solidFill>
+                <a:latin typeface="Arial" pitchFamily="34" charset="0"/>
+                <a:ea typeface="Arial" pitchFamily="34" charset="-122"/>
+                <a:cs typeface="Arial" pitchFamily="34" charset="-120"/>
+              </a:rPr>
+              <a:t>14–25 sep</a:t>
+            </a:r>
+            <a:endParaRPr lang="en-US" sz="800" dirty="0"/>
+          </a:p>
+        </p:txBody>
+      </p:sp>
+      <p:sp>
+        <p:nvSpPr>
+          <p:cNvPr id="14" name="Shape 11"/>
+          <p:cNvSpPr/>
+          <p:nvPr/>
+        </p:nvSpPr>
+        <p:spPr>
+          <a:xfrm>
+            <a:off x="6791706" y="1060704"/>
+            <a:ext cx="2077974" cy="274320"/>
+          </a:xfrm>
+          <a:prstGeom prst="roundRect">
+            <a:avLst>
+              <a:gd name="adj" fmla="val 53333"/>
+            </a:avLst>
+          </a:prstGeom>
+          <a:solidFill>
+            <a:srgbClr val="005B96"/>
+          </a:solidFill>
+          <a:ln w="12700">
+            <a:solidFill>
+              <a:srgbClr val="333333"/>
+            </a:solidFill>
+            <a:prstDash val="solid"/>
+          </a:ln>
+        </p:spPr>
+      </p:sp>
+      <p:sp>
+        <p:nvSpPr>
+          <p:cNvPr id="15" name="Text 12"/>
+          <p:cNvSpPr/>
+          <p:nvPr/>
+        </p:nvSpPr>
+        <p:spPr>
+          <a:xfrm>
+            <a:off x="6791706" y="1060704"/>
+            <a:ext cx="2077974" cy="274320"/>
+          </a:xfrm>
+          <a:prstGeom prst="rect">
+            <a:avLst/>
+          </a:prstGeom>
+          <a:noFill/>
+          <a:ln/>
+        </p:spPr>
+        <p:txBody>
+          <a:bodyPr wrap="square" lIns="0" tIns="0" rIns="0" bIns="0" rtlCol="0" anchor="ctr"/>
+          <a:lstStyle/>
+          <a:p>
+            <a:pPr algn="ctr" indent="0" marL="0">
+              <a:buNone/>
+            </a:pPr>
+            <a:r>
+              <a:rPr lang="en-US" sz="1050" b="1" dirty="0">
+                <a:solidFill>
+                  <a:srgbClr val="FFFFFF"/>
+                </a:solidFill>
+                <a:latin typeface="Noto Sans" pitchFamily="34" charset="0"/>
+                <a:ea typeface="Noto Sans" pitchFamily="34" charset="-122"/>
+                <a:cs typeface="Noto Sans" pitchFamily="34" charset="-120"/>
+              </a:rPr>
+              <a:t>SPRINT 4</a:t>
+            </a:r>
+            <a:endParaRPr lang="en-US" sz="1050" dirty="0"/>
+          </a:p>
+        </p:txBody>
+      </p:sp>
+      <p:sp>
+        <p:nvSpPr>
+          <p:cNvPr id="16" name="Text 13"/>
+          <p:cNvSpPr/>
+          <p:nvPr/>
+        </p:nvSpPr>
+        <p:spPr>
+          <a:xfrm>
+            <a:off x="6791706" y="1362456"/>
+            <a:ext cx="2077974" cy="182880"/>
+          </a:xfrm>
+          <a:prstGeom prst="rect">
+            <a:avLst/>
+          </a:prstGeom>
+          <a:noFill/>
+          <a:ln/>
+        </p:spPr>
+        <p:txBody>
+          <a:bodyPr wrap="square" lIns="0" tIns="0" rIns="0" bIns="0" rtlCol="0" anchor="ctr"/>
+          <a:lstStyle/>
+          <a:p>
+            <a:pPr algn="ctr" indent="0" marL="0">
+              <a:buNone/>
+            </a:pPr>
+            <a:r>
+              <a:rPr lang="en-US" sz="800" dirty="0">
+                <a:solidFill>
+                  <a:srgbClr val="D6D6D6"/>
+                </a:solidFill>
+                <a:latin typeface="Arial" pitchFamily="34" charset="0"/>
+                <a:ea typeface="Arial" pitchFamily="34" charset="-122"/>
+                <a:cs typeface="Arial" pitchFamily="34" charset="-120"/>
+              </a:rPr>
+              <a:t>28 sep–09 oct</a:t>
+            </a:r>
+            <a:endParaRPr lang="en-US" sz="800" dirty="0"/>
+          </a:p>
+        </p:txBody>
+      </p:sp>
+      <p:sp>
+        <p:nvSpPr>
+          <p:cNvPr id="17" name="Shape 14"/>
+          <p:cNvSpPr/>
+          <p:nvPr/>
+        </p:nvSpPr>
+        <p:spPr>
+          <a:xfrm>
+            <a:off x="365760" y="1600200"/>
+            <a:ext cx="1006983" cy="347472"/>
+          </a:xfrm>
+          <a:prstGeom prst="roundRect">
+            <a:avLst>
+              <a:gd name="adj" fmla="val 36842"/>
             </a:avLst>
           </a:prstGeom>
           <a:solidFill>
@@ -8312,14 +8627,14 @@
       </p:sp>
       <p:sp>
         <p:nvSpPr>
-          <p:cNvPr id="9" name="Text 6"/>
-          <p:cNvSpPr/>
-          <p:nvPr/>
-        </p:nvSpPr>
-        <p:spPr>
-          <a:xfrm>
-            <a:off x="365760" y="1645920"/>
-            <a:ext cx="887984" cy="365760"/>
+          <p:cNvPr id="18" name="Text 15"/>
+          <p:cNvSpPr/>
+          <p:nvPr/>
+        </p:nvSpPr>
+        <p:spPr>
+          <a:xfrm>
+            <a:off x="365760" y="1600200"/>
+            <a:ext cx="1006983" cy="347472"/>
           </a:xfrm>
           <a:prstGeom prst="rect">
             <a:avLst/>
@@ -8364,7 +8679,7 @@
                 <a:ea typeface="Arial" pitchFamily="34" charset="-122"/>
                 <a:cs typeface="Arial" pitchFamily="34" charset="-120"/>
               </a:rPr>
-              <a:t>13–19 ago</a:t>
+              <a:t>13–21 ago</a:t>
             </a:r>
             <a:endParaRPr lang="en-US" sz="1000" dirty="0"/>
           </a:p>
@@ -8372,18 +8687,627 @@
       </p:sp>
       <p:sp>
         <p:nvSpPr>
-          <p:cNvPr id="10" name="Shape 7"/>
-          <p:cNvSpPr/>
-          <p:nvPr/>
-        </p:nvSpPr>
-        <p:spPr>
-          <a:xfrm>
-            <a:off x="365760" y="2103120"/>
-            <a:ext cx="887984" cy="1078992"/>
+          <p:cNvPr id="19" name="Shape 16"/>
+          <p:cNvSpPr/>
+          <p:nvPr/>
+        </p:nvSpPr>
+        <p:spPr>
+          <a:xfrm>
+            <a:off x="1436751" y="1600200"/>
+            <a:ext cx="1006983" cy="347472"/>
           </a:xfrm>
           <a:prstGeom prst="roundRect">
             <a:avLst>
-              <a:gd name="adj" fmla="val 8238"/>
+              <a:gd name="adj" fmla="val 36842"/>
+            </a:avLst>
+          </a:prstGeom>
+          <a:solidFill>
+            <a:srgbClr val="00CB5D"/>
+          </a:solidFill>
+          <a:ln w="12700">
+            <a:solidFill>
+              <a:srgbClr val="333333"/>
+            </a:solidFill>
+            <a:prstDash val="solid"/>
+          </a:ln>
+        </p:spPr>
+      </p:sp>
+      <p:sp>
+        <p:nvSpPr>
+          <p:cNvPr id="20" name="Text 17"/>
+          <p:cNvSpPr/>
+          <p:nvPr/>
+        </p:nvSpPr>
+        <p:spPr>
+          <a:xfrm>
+            <a:off x="1436751" y="1600200"/>
+            <a:ext cx="1006983" cy="347472"/>
+          </a:xfrm>
+          <a:prstGeom prst="rect">
+            <a:avLst/>
+          </a:prstGeom>
+          <a:noFill/>
+          <a:ln/>
+        </p:spPr>
+        <p:txBody>
+          <a:bodyPr wrap="square" lIns="0" tIns="0" rIns="0" bIns="0" rtlCol="0" anchor="ctr"/>
+          <a:lstStyle/>
+          <a:p>
+            <a:pPr algn="ctr" indent="0" marL="0">
+              <a:lnSpc>
+                <a:spcPct val="100000"/>
+              </a:lnSpc>
+              <a:buNone/>
+            </a:pPr>
+            <a:r>
+              <a:rPr lang="en-US" sz="1000" b="1" dirty="0">
+                <a:solidFill>
+                  <a:srgbClr val="070F26"/>
+                </a:solidFill>
+                <a:latin typeface="Arial" pitchFamily="34" charset="0"/>
+                <a:ea typeface="Arial" pitchFamily="34" charset="-122"/>
+                <a:cs typeface="Arial" pitchFamily="34" charset="-120"/>
+              </a:rPr>
+              <a:t>SEM 2
+</a:t>
+            </a:r>
+            <a:pPr algn="ctr" indent="0" marL="0">
+              <a:lnSpc>
+                <a:spcPct val="100000"/>
+              </a:lnSpc>
+              <a:buNone/>
+            </a:pPr>
+            <a:r>
+              <a:rPr lang="en-US" sz="700" dirty="0">
+                <a:solidFill>
+                  <a:srgbClr val="1E3A2A"/>
+                </a:solidFill>
+                <a:latin typeface="Arial" pitchFamily="34" charset="0"/>
+                <a:ea typeface="Arial" pitchFamily="34" charset="-122"/>
+                <a:cs typeface="Arial" pitchFamily="34" charset="-120"/>
+              </a:rPr>
+              <a:t>24–28 ago</a:t>
+            </a:r>
+            <a:endParaRPr lang="en-US" sz="1000" dirty="0"/>
+          </a:p>
+        </p:txBody>
+      </p:sp>
+      <p:sp>
+        <p:nvSpPr>
+          <p:cNvPr id="21" name="Shape 18"/>
+          <p:cNvSpPr/>
+          <p:nvPr/>
+        </p:nvSpPr>
+        <p:spPr>
+          <a:xfrm>
+            <a:off x="2507742" y="1600200"/>
+            <a:ext cx="1006983" cy="347472"/>
+          </a:xfrm>
+          <a:prstGeom prst="roundRect">
+            <a:avLst>
+              <a:gd name="adj" fmla="val 36842"/>
+            </a:avLst>
+          </a:prstGeom>
+          <a:solidFill>
+            <a:srgbClr val="00CB5D"/>
+          </a:solidFill>
+          <a:ln w="12700">
+            <a:solidFill>
+              <a:srgbClr val="333333"/>
+            </a:solidFill>
+            <a:prstDash val="solid"/>
+          </a:ln>
+        </p:spPr>
+      </p:sp>
+      <p:sp>
+        <p:nvSpPr>
+          <p:cNvPr id="22" name="Text 19"/>
+          <p:cNvSpPr/>
+          <p:nvPr/>
+        </p:nvSpPr>
+        <p:spPr>
+          <a:xfrm>
+            <a:off x="2507742" y="1600200"/>
+            <a:ext cx="1006983" cy="347472"/>
+          </a:xfrm>
+          <a:prstGeom prst="rect">
+            <a:avLst/>
+          </a:prstGeom>
+          <a:noFill/>
+          <a:ln/>
+        </p:spPr>
+        <p:txBody>
+          <a:bodyPr wrap="square" lIns="0" tIns="0" rIns="0" bIns="0" rtlCol="0" anchor="ctr"/>
+          <a:lstStyle/>
+          <a:p>
+            <a:pPr algn="ctr" indent="0" marL="0">
+              <a:lnSpc>
+                <a:spcPct val="100000"/>
+              </a:lnSpc>
+              <a:buNone/>
+            </a:pPr>
+            <a:r>
+              <a:rPr lang="en-US" sz="1000" b="1" dirty="0">
+                <a:solidFill>
+                  <a:srgbClr val="070F26"/>
+                </a:solidFill>
+                <a:latin typeface="Arial" pitchFamily="34" charset="0"/>
+                <a:ea typeface="Arial" pitchFamily="34" charset="-122"/>
+                <a:cs typeface="Arial" pitchFamily="34" charset="-120"/>
+              </a:rPr>
+              <a:t>SEM 3
+</a:t>
+            </a:r>
+            <a:pPr algn="ctr" indent="0" marL="0">
+              <a:lnSpc>
+                <a:spcPct val="100000"/>
+              </a:lnSpc>
+              <a:buNone/>
+            </a:pPr>
+            <a:r>
+              <a:rPr lang="en-US" sz="700" dirty="0">
+                <a:solidFill>
+                  <a:srgbClr val="1E3A2A"/>
+                </a:solidFill>
+                <a:latin typeface="Arial" pitchFamily="34" charset="0"/>
+                <a:ea typeface="Arial" pitchFamily="34" charset="-122"/>
+                <a:cs typeface="Arial" pitchFamily="34" charset="-120"/>
+              </a:rPr>
+              <a:t>31 ago–04 sep</a:t>
+            </a:r>
+            <a:endParaRPr lang="en-US" sz="1000" dirty="0"/>
+          </a:p>
+        </p:txBody>
+      </p:sp>
+      <p:sp>
+        <p:nvSpPr>
+          <p:cNvPr id="23" name="Shape 20"/>
+          <p:cNvSpPr/>
+          <p:nvPr/>
+        </p:nvSpPr>
+        <p:spPr>
+          <a:xfrm>
+            <a:off x="3578733" y="1600200"/>
+            <a:ext cx="1006983" cy="347472"/>
+          </a:xfrm>
+          <a:prstGeom prst="roundRect">
+            <a:avLst>
+              <a:gd name="adj" fmla="val 36842"/>
+            </a:avLst>
+          </a:prstGeom>
+          <a:solidFill>
+            <a:srgbClr val="F9E795"/>
+          </a:solidFill>
+          <a:ln w="12700">
+            <a:solidFill>
+              <a:srgbClr val="333333"/>
+            </a:solidFill>
+            <a:prstDash val="solid"/>
+          </a:ln>
+        </p:spPr>
+      </p:sp>
+      <p:sp>
+        <p:nvSpPr>
+          <p:cNvPr id="24" name="Text 21"/>
+          <p:cNvSpPr/>
+          <p:nvPr/>
+        </p:nvSpPr>
+        <p:spPr>
+          <a:xfrm>
+            <a:off x="3578733" y="1600200"/>
+            <a:ext cx="1006983" cy="347472"/>
+          </a:xfrm>
+          <a:prstGeom prst="rect">
+            <a:avLst/>
+          </a:prstGeom>
+          <a:noFill/>
+          <a:ln/>
+        </p:spPr>
+        <p:txBody>
+          <a:bodyPr wrap="square" lIns="0" tIns="0" rIns="0" bIns="0" rtlCol="0" anchor="ctr"/>
+          <a:lstStyle/>
+          <a:p>
+            <a:pPr algn="ctr" indent="0" marL="0">
+              <a:lnSpc>
+                <a:spcPct val="100000"/>
+              </a:lnSpc>
+              <a:buNone/>
+            </a:pPr>
+            <a:r>
+              <a:rPr lang="en-US" sz="1000" b="1" dirty="0">
+                <a:solidFill>
+                  <a:srgbClr val="070F26"/>
+                </a:solidFill>
+                <a:latin typeface="Arial" pitchFamily="34" charset="0"/>
+                <a:ea typeface="Arial" pitchFamily="34" charset="-122"/>
+                <a:cs typeface="Arial" pitchFamily="34" charset="-120"/>
+              </a:rPr>
+              <a:t>SEM 4
+</a:t>
+            </a:r>
+            <a:pPr algn="ctr" indent="0" marL="0">
+              <a:lnSpc>
+                <a:spcPct val="100000"/>
+              </a:lnSpc>
+              <a:buNone/>
+            </a:pPr>
+            <a:r>
+              <a:rPr lang="en-US" sz="700" dirty="0">
+                <a:solidFill>
+                  <a:srgbClr val="4A3A10"/>
+                </a:solidFill>
+                <a:latin typeface="Arial" pitchFamily="34" charset="0"/>
+                <a:ea typeface="Arial" pitchFamily="34" charset="-122"/>
+                <a:cs typeface="Arial" pitchFamily="34" charset="-120"/>
+              </a:rPr>
+              <a:t>07–11 sep</a:t>
+            </a:r>
+            <a:endParaRPr lang="en-US" sz="1000" dirty="0"/>
+          </a:p>
+        </p:txBody>
+      </p:sp>
+      <p:sp>
+        <p:nvSpPr>
+          <p:cNvPr id="25" name="Shape 22"/>
+          <p:cNvSpPr/>
+          <p:nvPr/>
+        </p:nvSpPr>
+        <p:spPr>
+          <a:xfrm>
+            <a:off x="4649724" y="1600200"/>
+            <a:ext cx="1006983" cy="347472"/>
+          </a:xfrm>
+          <a:prstGeom prst="roundRect">
+            <a:avLst>
+              <a:gd name="adj" fmla="val 36842"/>
+            </a:avLst>
+          </a:prstGeom>
+          <a:solidFill>
+            <a:srgbClr val="1A2B4A"/>
+          </a:solidFill>
+          <a:ln w="12700">
+            <a:solidFill>
+              <a:srgbClr val="333333"/>
+            </a:solidFill>
+            <a:prstDash val="solid"/>
+          </a:ln>
+        </p:spPr>
+      </p:sp>
+      <p:sp>
+        <p:nvSpPr>
+          <p:cNvPr id="26" name="Text 23"/>
+          <p:cNvSpPr/>
+          <p:nvPr/>
+        </p:nvSpPr>
+        <p:spPr>
+          <a:xfrm>
+            <a:off x="4649724" y="1600200"/>
+            <a:ext cx="1006983" cy="347472"/>
+          </a:xfrm>
+          <a:prstGeom prst="rect">
+            <a:avLst/>
+          </a:prstGeom>
+          <a:noFill/>
+          <a:ln/>
+        </p:spPr>
+        <p:txBody>
+          <a:bodyPr wrap="square" lIns="0" tIns="0" rIns="0" bIns="0" rtlCol="0" anchor="ctr"/>
+          <a:lstStyle/>
+          <a:p>
+            <a:pPr algn="ctr" indent="0" marL="0">
+              <a:lnSpc>
+                <a:spcPct val="100000"/>
+              </a:lnSpc>
+              <a:buNone/>
+            </a:pPr>
+            <a:r>
+              <a:rPr lang="en-US" sz="1000" b="1" dirty="0">
+                <a:solidFill>
+                  <a:srgbClr val="FFFFFF"/>
+                </a:solidFill>
+                <a:latin typeface="Arial" pitchFamily="34" charset="0"/>
+                <a:ea typeface="Arial" pitchFamily="34" charset="-122"/>
+                <a:cs typeface="Arial" pitchFamily="34" charset="-120"/>
+              </a:rPr>
+              <a:t>SEM 5
+</a:t>
+            </a:r>
+            <a:pPr algn="ctr" indent="0" marL="0">
+              <a:lnSpc>
+                <a:spcPct val="100000"/>
+              </a:lnSpc>
+              <a:buNone/>
+            </a:pPr>
+            <a:r>
+              <a:rPr lang="en-US" sz="700" dirty="0">
+                <a:solidFill>
+                  <a:srgbClr val="D6D6D6"/>
+                </a:solidFill>
+                <a:latin typeface="Arial" pitchFamily="34" charset="0"/>
+                <a:ea typeface="Arial" pitchFamily="34" charset="-122"/>
+                <a:cs typeface="Arial" pitchFamily="34" charset="-120"/>
+              </a:rPr>
+              <a:t>14–18 sep</a:t>
+            </a:r>
+            <a:endParaRPr lang="en-US" sz="1000" dirty="0"/>
+          </a:p>
+        </p:txBody>
+      </p:sp>
+      <p:sp>
+        <p:nvSpPr>
+          <p:cNvPr id="27" name="Shape 24"/>
+          <p:cNvSpPr/>
+          <p:nvPr/>
+        </p:nvSpPr>
+        <p:spPr>
+          <a:xfrm>
+            <a:off x="5720715" y="1600200"/>
+            <a:ext cx="1006983" cy="347472"/>
+          </a:xfrm>
+          <a:prstGeom prst="roundRect">
+            <a:avLst>
+              <a:gd name="adj" fmla="val 36842"/>
+            </a:avLst>
+          </a:prstGeom>
+          <a:solidFill>
+            <a:srgbClr val="1A2B4A"/>
+          </a:solidFill>
+          <a:ln w="12700">
+            <a:solidFill>
+              <a:srgbClr val="333333"/>
+            </a:solidFill>
+            <a:prstDash val="solid"/>
+          </a:ln>
+        </p:spPr>
+      </p:sp>
+      <p:sp>
+        <p:nvSpPr>
+          <p:cNvPr id="28" name="Text 25"/>
+          <p:cNvSpPr/>
+          <p:nvPr/>
+        </p:nvSpPr>
+        <p:spPr>
+          <a:xfrm>
+            <a:off x="5720715" y="1600200"/>
+            <a:ext cx="1006983" cy="347472"/>
+          </a:xfrm>
+          <a:prstGeom prst="rect">
+            <a:avLst/>
+          </a:prstGeom>
+          <a:noFill/>
+          <a:ln/>
+        </p:spPr>
+        <p:txBody>
+          <a:bodyPr wrap="square" lIns="0" tIns="0" rIns="0" bIns="0" rtlCol="0" anchor="ctr"/>
+          <a:lstStyle/>
+          <a:p>
+            <a:pPr algn="ctr" indent="0" marL="0">
+              <a:lnSpc>
+                <a:spcPct val="100000"/>
+              </a:lnSpc>
+              <a:buNone/>
+            </a:pPr>
+            <a:r>
+              <a:rPr lang="en-US" sz="1000" b="1" dirty="0">
+                <a:solidFill>
+                  <a:srgbClr val="FFFFFF"/>
+                </a:solidFill>
+                <a:latin typeface="Arial" pitchFamily="34" charset="0"/>
+                <a:ea typeface="Arial" pitchFamily="34" charset="-122"/>
+                <a:cs typeface="Arial" pitchFamily="34" charset="-120"/>
+              </a:rPr>
+              <a:t>SEM 6
+</a:t>
+            </a:r>
+            <a:pPr algn="ctr" indent="0" marL="0">
+              <a:lnSpc>
+                <a:spcPct val="100000"/>
+              </a:lnSpc>
+              <a:buNone/>
+            </a:pPr>
+            <a:r>
+              <a:rPr lang="en-US" sz="700" dirty="0">
+                <a:solidFill>
+                  <a:srgbClr val="D6D6D6"/>
+                </a:solidFill>
+                <a:latin typeface="Arial" pitchFamily="34" charset="0"/>
+                <a:ea typeface="Arial" pitchFamily="34" charset="-122"/>
+                <a:cs typeface="Arial" pitchFamily="34" charset="-120"/>
+              </a:rPr>
+              <a:t>21–25 sep</a:t>
+            </a:r>
+            <a:endParaRPr lang="en-US" sz="1000" dirty="0"/>
+          </a:p>
+        </p:txBody>
+      </p:sp>
+      <p:sp>
+        <p:nvSpPr>
+          <p:cNvPr id="29" name="Shape 26"/>
+          <p:cNvSpPr/>
+          <p:nvPr/>
+        </p:nvSpPr>
+        <p:spPr>
+          <a:xfrm>
+            <a:off x="6791706" y="1600200"/>
+            <a:ext cx="1006983" cy="347472"/>
+          </a:xfrm>
+          <a:prstGeom prst="roundRect">
+            <a:avLst>
+              <a:gd name="adj" fmla="val 36842"/>
+            </a:avLst>
+          </a:prstGeom>
+          <a:solidFill>
+            <a:srgbClr val="1A2B4A"/>
+          </a:solidFill>
+          <a:ln w="12700">
+            <a:solidFill>
+              <a:srgbClr val="333333"/>
+            </a:solidFill>
+            <a:prstDash val="solid"/>
+          </a:ln>
+        </p:spPr>
+      </p:sp>
+      <p:sp>
+        <p:nvSpPr>
+          <p:cNvPr id="30" name="Text 27"/>
+          <p:cNvSpPr/>
+          <p:nvPr/>
+        </p:nvSpPr>
+        <p:spPr>
+          <a:xfrm>
+            <a:off x="6791706" y="1600200"/>
+            <a:ext cx="1006983" cy="347472"/>
+          </a:xfrm>
+          <a:prstGeom prst="rect">
+            <a:avLst/>
+          </a:prstGeom>
+          <a:noFill/>
+          <a:ln/>
+        </p:spPr>
+        <p:txBody>
+          <a:bodyPr wrap="square" lIns="0" tIns="0" rIns="0" bIns="0" rtlCol="0" anchor="ctr"/>
+          <a:lstStyle/>
+          <a:p>
+            <a:pPr algn="ctr" indent="0" marL="0">
+              <a:lnSpc>
+                <a:spcPct val="100000"/>
+              </a:lnSpc>
+              <a:buNone/>
+            </a:pPr>
+            <a:r>
+              <a:rPr lang="en-US" sz="1000" b="1" dirty="0">
+                <a:solidFill>
+                  <a:srgbClr val="FFFFFF"/>
+                </a:solidFill>
+                <a:latin typeface="Arial" pitchFamily="34" charset="0"/>
+                <a:ea typeface="Arial" pitchFamily="34" charset="-122"/>
+                <a:cs typeface="Arial" pitchFamily="34" charset="-120"/>
+              </a:rPr>
+              <a:t>SEM 7
+</a:t>
+            </a:r>
+            <a:pPr algn="ctr" indent="0" marL="0">
+              <a:lnSpc>
+                <a:spcPct val="100000"/>
+              </a:lnSpc>
+              <a:buNone/>
+            </a:pPr>
+            <a:r>
+              <a:rPr lang="en-US" sz="700" dirty="0">
+                <a:solidFill>
+                  <a:srgbClr val="D6D6D6"/>
+                </a:solidFill>
+                <a:latin typeface="Arial" pitchFamily="34" charset="0"/>
+                <a:ea typeface="Arial" pitchFamily="34" charset="-122"/>
+                <a:cs typeface="Arial" pitchFamily="34" charset="-120"/>
+              </a:rPr>
+              <a:t>28 sep–02 oct</a:t>
+            </a:r>
+            <a:endParaRPr lang="en-US" sz="1000" dirty="0"/>
+          </a:p>
+        </p:txBody>
+      </p:sp>
+      <p:sp>
+        <p:nvSpPr>
+          <p:cNvPr id="31" name="Shape 28"/>
+          <p:cNvSpPr/>
+          <p:nvPr/>
+        </p:nvSpPr>
+        <p:spPr>
+          <a:xfrm>
+            <a:off x="7862697" y="1600200"/>
+            <a:ext cx="1006983" cy="347472"/>
+          </a:xfrm>
+          <a:prstGeom prst="roundRect">
+            <a:avLst>
+              <a:gd name="adj" fmla="val 36842"/>
+            </a:avLst>
+          </a:prstGeom>
+          <a:solidFill>
+            <a:srgbClr val="1A2B4A"/>
+          </a:solidFill>
+          <a:ln w="12700">
+            <a:solidFill>
+              <a:srgbClr val="333333"/>
+            </a:solidFill>
+            <a:prstDash val="solid"/>
+          </a:ln>
+        </p:spPr>
+      </p:sp>
+      <p:sp>
+        <p:nvSpPr>
+          <p:cNvPr id="32" name="Text 29"/>
+          <p:cNvSpPr/>
+          <p:nvPr/>
+        </p:nvSpPr>
+        <p:spPr>
+          <a:xfrm>
+            <a:off x="7862697" y="1600200"/>
+            <a:ext cx="1006983" cy="347472"/>
+          </a:xfrm>
+          <a:prstGeom prst="rect">
+            <a:avLst/>
+          </a:prstGeom>
+          <a:noFill/>
+          <a:ln/>
+        </p:spPr>
+        <p:txBody>
+          <a:bodyPr wrap="square" lIns="0" tIns="0" rIns="0" bIns="0" rtlCol="0" anchor="ctr"/>
+          <a:lstStyle/>
+          <a:p>
+            <a:pPr algn="ctr" indent="0" marL="0">
+              <a:lnSpc>
+                <a:spcPct val="100000"/>
+              </a:lnSpc>
+              <a:buNone/>
+            </a:pPr>
+            <a:r>
+              <a:rPr lang="en-US" sz="1000" b="1" dirty="0">
+                <a:solidFill>
+                  <a:srgbClr val="FFFFFF"/>
+                </a:solidFill>
+                <a:latin typeface="Arial" pitchFamily="34" charset="0"/>
+                <a:ea typeface="Arial" pitchFamily="34" charset="-122"/>
+                <a:cs typeface="Arial" pitchFamily="34" charset="-120"/>
+              </a:rPr>
+              <a:t>SEM 8
+</a:t>
+            </a:r>
+            <a:pPr algn="ctr" indent="0" marL="0">
+              <a:lnSpc>
+                <a:spcPct val="100000"/>
+              </a:lnSpc>
+              <a:buNone/>
+            </a:pPr>
+            <a:r>
+              <a:rPr lang="en-US" sz="700" dirty="0">
+                <a:solidFill>
+                  <a:srgbClr val="D6D6D6"/>
+                </a:solidFill>
+                <a:latin typeface="Arial" pitchFamily="34" charset="0"/>
+                <a:ea typeface="Arial" pitchFamily="34" charset="-122"/>
+                <a:cs typeface="Arial" pitchFamily="34" charset="-120"/>
+              </a:rPr>
+              <a:t>05–09 oct</a:t>
+            </a:r>
+            <a:endParaRPr lang="en-US" sz="1000" dirty="0"/>
+          </a:p>
+        </p:txBody>
+      </p:sp>
+      <p:sp>
+        <p:nvSpPr>
+          <p:cNvPr id="33" name="Shape 30"/>
+          <p:cNvSpPr/>
+          <p:nvPr/>
+        </p:nvSpPr>
+        <p:spPr>
+          <a:xfrm>
+            <a:off x="365760" y="2020824"/>
+            <a:ext cx="1006983" cy="1376172"/>
+          </a:xfrm>
+          <a:prstGeom prst="roundRect">
+            <a:avLst>
+              <a:gd name="adj" fmla="val 7264"/>
             </a:avLst>
           </a:prstGeom>
           <a:solidFill>
@@ -8399,14 +9323,14 @@
       </p:sp>
       <p:sp>
         <p:nvSpPr>
-          <p:cNvPr id="11" name="Text 8"/>
-          <p:cNvSpPr/>
-          <p:nvPr/>
-        </p:nvSpPr>
-        <p:spPr>
-          <a:xfrm>
-            <a:off x="420624" y="2157984"/>
-            <a:ext cx="778256" cy="969264"/>
+          <p:cNvPr id="34" name="Text 31"/>
+          <p:cNvSpPr/>
+          <p:nvPr/>
+        </p:nvSpPr>
+        <p:spPr>
+          <a:xfrm>
+            <a:off x="420624" y="2075688"/>
+            <a:ext cx="897255" cy="1266444"/>
           </a:xfrm>
           <a:prstGeom prst="rect">
             <a:avLst/>
@@ -8441,18 +9365,18 @@
       </p:sp>
       <p:sp>
         <p:nvSpPr>
-          <p:cNvPr id="12" name="Shape 9"/>
-          <p:cNvSpPr/>
-          <p:nvPr/>
-        </p:nvSpPr>
-        <p:spPr>
-          <a:xfrm>
-            <a:off x="365760" y="3255264"/>
-            <a:ext cx="887984" cy="1078992"/>
+          <p:cNvPr id="35" name="Shape 32"/>
+          <p:cNvSpPr/>
+          <p:nvPr/>
+        </p:nvSpPr>
+        <p:spPr>
+          <a:xfrm>
+            <a:off x="365760" y="3470148"/>
+            <a:ext cx="1006983" cy="1376172"/>
           </a:xfrm>
           <a:prstGeom prst="roundRect">
             <a:avLst>
-              <a:gd name="adj" fmla="val 8238"/>
+              <a:gd name="adj" fmla="val 7264"/>
             </a:avLst>
           </a:prstGeom>
           <a:solidFill>
@@ -8468,14 +9392,14 @@
       </p:sp>
       <p:sp>
         <p:nvSpPr>
-          <p:cNvPr id="13" name="Text 10"/>
-          <p:cNvSpPr/>
-          <p:nvPr/>
-        </p:nvSpPr>
-        <p:spPr>
-          <a:xfrm>
-            <a:off x="420624" y="3310128"/>
-            <a:ext cx="778256" cy="969264"/>
+          <p:cNvPr id="36" name="Text 33"/>
+          <p:cNvSpPr/>
+          <p:nvPr/>
+        </p:nvSpPr>
+        <p:spPr>
+          <a:xfrm>
+            <a:off x="420624" y="3525012"/>
+            <a:ext cx="897255" cy="1266444"/>
           </a:xfrm>
           <a:prstGeom prst="rect">
             <a:avLst/>
@@ -8502,7 +9426,7 @@
                 <a:ea typeface="Arial" pitchFamily="34" charset="-122"/>
                 <a:cs typeface="Arial" pitchFamily="34" charset="-120"/>
               </a:rPr>
-              <a:t>Arranque de los 3 skills del pipeline</a:t>
+              <a:t>Arranque de los 3 skills, el flujo de generación DHU</a:t>
             </a:r>
             <a:endParaRPr lang="en-US" sz="800" dirty="0"/>
           </a:p>
@@ -8510,105 +9434,18 @@
       </p:sp>
       <p:sp>
         <p:nvSpPr>
-          <p:cNvPr id="14" name="Shape 11"/>
-          <p:cNvSpPr/>
-          <p:nvPr/>
-        </p:nvSpPr>
-        <p:spPr>
-          <a:xfrm>
-            <a:off x="1317752" y="1645920"/>
-            <a:ext cx="887984" cy="365760"/>
+          <p:cNvPr id="37" name="Shape 34"/>
+          <p:cNvSpPr/>
+          <p:nvPr/>
+        </p:nvSpPr>
+        <p:spPr>
+          <a:xfrm>
+            <a:off x="1436751" y="2020824"/>
+            <a:ext cx="1006983" cy="1376172"/>
           </a:xfrm>
           <a:prstGeom prst="roundRect">
             <a:avLst>
-              <a:gd name="adj" fmla="val 35000"/>
-            </a:avLst>
-          </a:prstGeom>
-          <a:solidFill>
-            <a:srgbClr val="00CB5D"/>
-          </a:solidFill>
-          <a:ln w="12700">
-            <a:solidFill>
-              <a:srgbClr val="333333"/>
-            </a:solidFill>
-            <a:prstDash val="solid"/>
-          </a:ln>
-        </p:spPr>
-      </p:sp>
-      <p:sp>
-        <p:nvSpPr>
-          <p:cNvPr id="15" name="Text 12"/>
-          <p:cNvSpPr/>
-          <p:nvPr/>
-        </p:nvSpPr>
-        <p:spPr>
-          <a:xfrm>
-            <a:off x="1317752" y="1645920"/>
-            <a:ext cx="887984" cy="365760"/>
-          </a:xfrm>
-          <a:prstGeom prst="rect">
-            <a:avLst/>
-          </a:prstGeom>
-          <a:noFill/>
-          <a:ln/>
-        </p:spPr>
-        <p:txBody>
-          <a:bodyPr wrap="square" lIns="0" tIns="0" rIns="0" bIns="0" rtlCol="0" anchor="ctr"/>
-          <a:lstStyle/>
-          <a:p>
-            <a:pPr algn="ctr" indent="0" marL="0">
-              <a:lnSpc>
-                <a:spcPct val="100000"/>
-              </a:lnSpc>
-              <a:buNone/>
-            </a:pPr>
-            <a:r>
-              <a:rPr lang="en-US" sz="1000" b="1" dirty="0">
-                <a:solidFill>
-                  <a:srgbClr val="070F26"/>
-                </a:solidFill>
-                <a:latin typeface="Arial" pitchFamily="34" charset="0"/>
-                <a:ea typeface="Arial" pitchFamily="34" charset="-122"/>
-                <a:cs typeface="Arial" pitchFamily="34" charset="-120"/>
-              </a:rPr>
-              <a:t>SEM 2
-</a:t>
-            </a:r>
-            <a:pPr algn="ctr" indent="0" marL="0">
-              <a:lnSpc>
-                <a:spcPct val="100000"/>
-              </a:lnSpc>
-              <a:buNone/>
-            </a:pPr>
-            <a:r>
-              <a:rPr lang="en-US" sz="700" dirty="0">
-                <a:solidFill>
-                  <a:srgbClr val="1E3A2A"/>
-                </a:solidFill>
-                <a:latin typeface="Arial" pitchFamily="34" charset="0"/>
-                <a:ea typeface="Arial" pitchFamily="34" charset="-122"/>
-                <a:cs typeface="Arial" pitchFamily="34" charset="-120"/>
-              </a:rPr>
-              <a:t>20–26 ago</a:t>
-            </a:r>
-            <a:endParaRPr lang="en-US" sz="1000" dirty="0"/>
-          </a:p>
-        </p:txBody>
-      </p:sp>
-      <p:sp>
-        <p:nvSpPr>
-          <p:cNvPr id="16" name="Shape 13"/>
-          <p:cNvSpPr/>
-          <p:nvPr/>
-        </p:nvSpPr>
-        <p:spPr>
-          <a:xfrm>
-            <a:off x="1317752" y="2103120"/>
-            <a:ext cx="887984" cy="1078992"/>
-          </a:xfrm>
-          <a:prstGeom prst="roundRect">
-            <a:avLst>
-              <a:gd name="adj" fmla="val 8238"/>
+              <a:gd name="adj" fmla="val 7264"/>
             </a:avLst>
           </a:prstGeom>
           <a:solidFill>
@@ -8624,14 +9461,14 @@
       </p:sp>
       <p:sp>
         <p:nvSpPr>
-          <p:cNvPr id="17" name="Text 14"/>
-          <p:cNvSpPr/>
-          <p:nvPr/>
-        </p:nvSpPr>
-        <p:spPr>
-          <a:xfrm>
-            <a:off x="1372616" y="2157984"/>
-            <a:ext cx="778256" cy="969264"/>
+          <p:cNvPr id="38" name="Text 35"/>
+          <p:cNvSpPr/>
+          <p:nvPr/>
+        </p:nvSpPr>
+        <p:spPr>
+          <a:xfrm>
+            <a:off x="1491615" y="2075688"/>
+            <a:ext cx="897255" cy="1266444"/>
           </a:xfrm>
           <a:prstGeom prst="rect">
             <a:avLst/>
@@ -8666,18 +9503,18 @@
       </p:sp>
       <p:sp>
         <p:nvSpPr>
-          <p:cNvPr id="18" name="Shape 15"/>
-          <p:cNvSpPr/>
-          <p:nvPr/>
-        </p:nvSpPr>
-        <p:spPr>
-          <a:xfrm>
-            <a:off x="1317752" y="3255264"/>
-            <a:ext cx="887984" cy="1078992"/>
+          <p:cNvPr id="39" name="Shape 36"/>
+          <p:cNvSpPr/>
+          <p:nvPr/>
+        </p:nvSpPr>
+        <p:spPr>
+          <a:xfrm>
+            <a:off x="1436751" y="3470148"/>
+            <a:ext cx="1006983" cy="1376172"/>
           </a:xfrm>
           <a:prstGeom prst="roundRect">
             <a:avLst>
-              <a:gd name="adj" fmla="val 8238"/>
+              <a:gd name="adj" fmla="val 7264"/>
             </a:avLst>
           </a:prstGeom>
           <a:solidFill>
@@ -8693,14 +9530,14 @@
       </p:sp>
       <p:sp>
         <p:nvSpPr>
-          <p:cNvPr id="19" name="Text 16"/>
-          <p:cNvSpPr/>
-          <p:nvPr/>
-        </p:nvSpPr>
-        <p:spPr>
-          <a:xfrm>
-            <a:off x="1372616" y="3310128"/>
-            <a:ext cx="778256" cy="969264"/>
+          <p:cNvPr id="40" name="Text 37"/>
+          <p:cNvSpPr/>
+          <p:nvPr/>
+        </p:nvSpPr>
+        <p:spPr>
+          <a:xfrm>
+            <a:off x="1491615" y="3525012"/>
+            <a:ext cx="897255" cy="1266444"/>
           </a:xfrm>
           <a:prstGeom prst="rect">
             <a:avLst/>
@@ -8735,210 +9572,18 @@
       </p:sp>
       <p:sp>
         <p:nvSpPr>
-          <p:cNvPr id="20" name="Shape 17"/>
-          <p:cNvSpPr/>
-          <p:nvPr/>
-        </p:nvSpPr>
-        <p:spPr>
-          <a:xfrm>
-            <a:off x="2269744" y="1097280"/>
-            <a:ext cx="1839976" cy="292608"/>
+          <p:cNvPr id="41" name="Shape 38"/>
+          <p:cNvSpPr/>
+          <p:nvPr/>
+        </p:nvSpPr>
+        <p:spPr>
+          <a:xfrm>
+            <a:off x="2507742" y="2020824"/>
+            <a:ext cx="1006983" cy="893064"/>
           </a:xfrm>
           <a:prstGeom prst="roundRect">
             <a:avLst>
-              <a:gd name="adj" fmla="val 50000"/>
-            </a:avLst>
-          </a:prstGeom>
-          <a:solidFill>
-            <a:srgbClr val="005B96"/>
-          </a:solidFill>
-          <a:ln w="12700">
-            <a:solidFill>
-              <a:srgbClr val="333333"/>
-            </a:solidFill>
-            <a:prstDash val="solid"/>
-          </a:ln>
-        </p:spPr>
-      </p:sp>
-      <p:sp>
-        <p:nvSpPr>
-          <p:cNvPr id="21" name="Text 18"/>
-          <p:cNvSpPr/>
-          <p:nvPr/>
-        </p:nvSpPr>
-        <p:spPr>
-          <a:xfrm>
-            <a:off x="2269744" y="1097280"/>
-            <a:ext cx="1839976" cy="292608"/>
-          </a:xfrm>
-          <a:prstGeom prst="rect">
-            <a:avLst/>
-          </a:prstGeom>
-          <a:noFill/>
-          <a:ln/>
-        </p:spPr>
-        <p:txBody>
-          <a:bodyPr wrap="square" lIns="0" tIns="0" rIns="0" bIns="0" rtlCol="0" anchor="ctr"/>
-          <a:lstStyle/>
-          <a:p>
-            <a:pPr algn="ctr" indent="0" marL="0">
-              <a:buNone/>
-            </a:pPr>
-            <a:r>
-              <a:rPr lang="en-US" sz="1050" b="1" dirty="0">
-                <a:solidFill>
-                  <a:srgbClr val="FFFFFF"/>
-                </a:solidFill>
-                <a:latin typeface="Noto Sans" pitchFamily="34" charset="0"/>
-                <a:ea typeface="Noto Sans" pitchFamily="34" charset="-122"/>
-                <a:cs typeface="Noto Sans" pitchFamily="34" charset="-120"/>
-              </a:rPr>
-              <a:t>SPRINT 2</a:t>
-            </a:r>
-            <a:endParaRPr lang="en-US" sz="1050" dirty="0"/>
-          </a:p>
-        </p:txBody>
-      </p:sp>
-      <p:sp>
-        <p:nvSpPr>
-          <p:cNvPr id="22" name="Text 19"/>
-          <p:cNvSpPr/>
-          <p:nvPr/>
-        </p:nvSpPr>
-        <p:spPr>
-          <a:xfrm>
-            <a:off x="2269744" y="1408176"/>
-            <a:ext cx="1839976" cy="182880"/>
-          </a:xfrm>
-          <a:prstGeom prst="rect">
-            <a:avLst/>
-          </a:prstGeom>
-          <a:noFill/>
-          <a:ln/>
-        </p:spPr>
-        <p:txBody>
-          <a:bodyPr wrap="square" lIns="0" tIns="0" rIns="0" bIns="0" rtlCol="0" anchor="ctr"/>
-          <a:lstStyle/>
-          <a:p>
-            <a:pPr algn="ctr" indent="0" marL="0">
-              <a:buNone/>
-            </a:pPr>
-            <a:r>
-              <a:rPr lang="en-US" sz="800" dirty="0">
-                <a:solidFill>
-                  <a:srgbClr val="D6D6D6"/>
-                </a:solidFill>
-                <a:latin typeface="Arial" pitchFamily="34" charset="0"/>
-                <a:ea typeface="Arial" pitchFamily="34" charset="-122"/>
-                <a:cs typeface="Arial" pitchFamily="34" charset="-120"/>
-              </a:rPr>
-              <a:t>27 ago–09 sep</a:t>
-            </a:r>
-            <a:endParaRPr lang="en-US" sz="800" dirty="0"/>
-          </a:p>
-        </p:txBody>
-      </p:sp>
-      <p:sp>
-        <p:nvSpPr>
-          <p:cNvPr id="23" name="Shape 20"/>
-          <p:cNvSpPr/>
-          <p:nvPr/>
-        </p:nvSpPr>
-        <p:spPr>
-          <a:xfrm>
-            <a:off x="2269744" y="1645920"/>
-            <a:ext cx="887984" cy="365760"/>
-          </a:xfrm>
-          <a:prstGeom prst="roundRect">
-            <a:avLst>
-              <a:gd name="adj" fmla="val 35000"/>
-            </a:avLst>
-          </a:prstGeom>
-          <a:solidFill>
-            <a:srgbClr val="00CB5D"/>
-          </a:solidFill>
-          <a:ln w="12700">
-            <a:solidFill>
-              <a:srgbClr val="333333"/>
-            </a:solidFill>
-            <a:prstDash val="solid"/>
-          </a:ln>
-        </p:spPr>
-      </p:sp>
-      <p:sp>
-        <p:nvSpPr>
-          <p:cNvPr id="24" name="Text 21"/>
-          <p:cNvSpPr/>
-          <p:nvPr/>
-        </p:nvSpPr>
-        <p:spPr>
-          <a:xfrm>
-            <a:off x="2269744" y="1645920"/>
-            <a:ext cx="887984" cy="365760"/>
-          </a:xfrm>
-          <a:prstGeom prst="rect">
-            <a:avLst/>
-          </a:prstGeom>
-          <a:noFill/>
-          <a:ln/>
-        </p:spPr>
-        <p:txBody>
-          <a:bodyPr wrap="square" lIns="0" tIns="0" rIns="0" bIns="0" rtlCol="0" anchor="ctr"/>
-          <a:lstStyle/>
-          <a:p>
-            <a:pPr algn="ctr" indent="0" marL="0">
-              <a:lnSpc>
-                <a:spcPct val="100000"/>
-              </a:lnSpc>
-              <a:buNone/>
-            </a:pPr>
-            <a:r>
-              <a:rPr lang="en-US" sz="1000" b="1" dirty="0">
-                <a:solidFill>
-                  <a:srgbClr val="070F26"/>
-                </a:solidFill>
-                <a:latin typeface="Arial" pitchFamily="34" charset="0"/>
-                <a:ea typeface="Arial" pitchFamily="34" charset="-122"/>
-                <a:cs typeface="Arial" pitchFamily="34" charset="-120"/>
-              </a:rPr>
-              <a:t>SEM 3
-</a:t>
-            </a:r>
-            <a:pPr algn="ctr" indent="0" marL="0">
-              <a:lnSpc>
-                <a:spcPct val="100000"/>
-              </a:lnSpc>
-              <a:buNone/>
-            </a:pPr>
-            <a:r>
-              <a:rPr lang="en-US" sz="700" dirty="0">
-                <a:solidFill>
-                  <a:srgbClr val="1E3A2A"/>
-                </a:solidFill>
-                <a:latin typeface="Arial" pitchFamily="34" charset="0"/>
-                <a:ea typeface="Arial" pitchFamily="34" charset="-122"/>
-                <a:cs typeface="Arial" pitchFamily="34" charset="-120"/>
-              </a:rPr>
-              <a:t>27 ago–02 sep</a:t>
-            </a:r>
-            <a:endParaRPr lang="en-US" sz="1000" dirty="0"/>
-          </a:p>
-        </p:txBody>
-      </p:sp>
-      <p:sp>
-        <p:nvSpPr>
-          <p:cNvPr id="25" name="Shape 22"/>
-          <p:cNvSpPr/>
-          <p:nvPr/>
-        </p:nvSpPr>
-        <p:spPr>
-          <a:xfrm>
-            <a:off x="2269744" y="2103120"/>
-            <a:ext cx="887984" cy="1078992"/>
-          </a:xfrm>
-          <a:prstGeom prst="roundRect">
-            <a:avLst>
-              <a:gd name="adj" fmla="val 8238"/>
+              <a:gd name="adj" fmla="val 8191"/>
             </a:avLst>
           </a:prstGeom>
           <a:solidFill>
@@ -8954,14 +9599,14 @@
       </p:sp>
       <p:sp>
         <p:nvSpPr>
-          <p:cNvPr id="26" name="Text 23"/>
-          <p:cNvSpPr/>
-          <p:nvPr/>
-        </p:nvSpPr>
-        <p:spPr>
-          <a:xfrm>
-            <a:off x="2324608" y="2157984"/>
-            <a:ext cx="778256" cy="969264"/>
+          <p:cNvPr id="42" name="Text 39"/>
+          <p:cNvSpPr/>
+          <p:nvPr/>
+        </p:nvSpPr>
+        <p:spPr>
+          <a:xfrm>
+            <a:off x="2562606" y="2075688"/>
+            <a:ext cx="897255" cy="783336"/>
           </a:xfrm>
           <a:prstGeom prst="rect">
             <a:avLst/>
@@ -8980,7 +9625,7 @@
               <a:buNone/>
             </a:pPr>
             <a:r>
-              <a:rPr lang="en-US" sz="800" dirty="0">
+              <a:rPr lang="en-US" sz="750" dirty="0">
                 <a:solidFill>
                   <a:srgbClr val="FFFFFF"/>
                 </a:solidFill>
@@ -8990,24 +9635,24 @@
               </a:rPr>
               <a:t>Iteración de los skills del pipeline</a:t>
             </a:r>
-            <a:endParaRPr lang="en-US" sz="800" dirty="0"/>
-          </a:p>
-        </p:txBody>
-      </p:sp>
-      <p:sp>
-        <p:nvSpPr>
-          <p:cNvPr id="27" name="Shape 24"/>
-          <p:cNvSpPr/>
-          <p:nvPr/>
-        </p:nvSpPr>
-        <p:spPr>
-          <a:xfrm>
-            <a:off x="2269744" y="3255264"/>
-            <a:ext cx="887984" cy="1078992"/>
+            <a:endParaRPr lang="en-US" sz="750" dirty="0"/>
+          </a:p>
+        </p:txBody>
+      </p:sp>
+      <p:sp>
+        <p:nvSpPr>
+          <p:cNvPr id="43" name="Shape 40"/>
+          <p:cNvSpPr/>
+          <p:nvPr/>
+        </p:nvSpPr>
+        <p:spPr>
+          <a:xfrm>
+            <a:off x="2507742" y="2987040"/>
+            <a:ext cx="1006983" cy="893064"/>
           </a:xfrm>
           <a:prstGeom prst="roundRect">
             <a:avLst>
-              <a:gd name="adj" fmla="val 8238"/>
+              <a:gd name="adj" fmla="val 8191"/>
             </a:avLst>
           </a:prstGeom>
           <a:solidFill>
@@ -9023,14 +9668,14 @@
       </p:sp>
       <p:sp>
         <p:nvSpPr>
-          <p:cNvPr id="28" name="Text 25"/>
-          <p:cNvSpPr/>
-          <p:nvPr/>
-        </p:nvSpPr>
-        <p:spPr>
-          <a:xfrm>
-            <a:off x="2324608" y="3310128"/>
-            <a:ext cx="778256" cy="969264"/>
+          <p:cNvPr id="44" name="Text 41"/>
+          <p:cNvSpPr/>
+          <p:nvPr/>
+        </p:nvSpPr>
+        <p:spPr>
+          <a:xfrm>
+            <a:off x="2562606" y="3041904"/>
+            <a:ext cx="897255" cy="783336"/>
           </a:xfrm>
           <a:prstGeom prst="rect">
             <a:avLst/>
@@ -9049,7 +9694,7 @@
               <a:buNone/>
             </a:pPr>
             <a:r>
-              <a:rPr lang="en-US" sz="800" dirty="0">
+              <a:rPr lang="en-US" sz="750" dirty="0">
                 <a:solidFill>
                   <a:srgbClr val="FFFFFF"/>
                 </a:solidFill>
@@ -9059,111 +9704,24 @@
               </a:rPr>
               <a:t>Ejecución EVT con equipo dev (context-analyzer → DHU → código)</a:t>
             </a:r>
-            <a:endParaRPr lang="en-US" sz="800" dirty="0"/>
-          </a:p>
-        </p:txBody>
-      </p:sp>
-      <p:sp>
-        <p:nvSpPr>
-          <p:cNvPr id="29" name="Shape 26"/>
-          <p:cNvSpPr/>
-          <p:nvPr/>
-        </p:nvSpPr>
-        <p:spPr>
-          <a:xfrm>
-            <a:off x="3221736" y="1645920"/>
-            <a:ext cx="887984" cy="365760"/>
+            <a:endParaRPr lang="en-US" sz="750" dirty="0"/>
+          </a:p>
+        </p:txBody>
+      </p:sp>
+      <p:sp>
+        <p:nvSpPr>
+          <p:cNvPr id="45" name="Shape 42"/>
+          <p:cNvSpPr/>
+          <p:nvPr/>
+        </p:nvSpPr>
+        <p:spPr>
+          <a:xfrm>
+            <a:off x="3578733" y="2020824"/>
+            <a:ext cx="1006983" cy="893064"/>
           </a:xfrm>
           <a:prstGeom prst="roundRect">
             <a:avLst>
-              <a:gd name="adj" fmla="val 35000"/>
-            </a:avLst>
-          </a:prstGeom>
-          <a:solidFill>
-            <a:srgbClr val="00CB5D"/>
-          </a:solidFill>
-          <a:ln w="12700">
-            <a:solidFill>
-              <a:srgbClr val="333333"/>
-            </a:solidFill>
-            <a:prstDash val="solid"/>
-          </a:ln>
-        </p:spPr>
-      </p:sp>
-      <p:sp>
-        <p:nvSpPr>
-          <p:cNvPr id="30" name="Text 27"/>
-          <p:cNvSpPr/>
-          <p:nvPr/>
-        </p:nvSpPr>
-        <p:spPr>
-          <a:xfrm>
-            <a:off x="3221736" y="1645920"/>
-            <a:ext cx="887984" cy="365760"/>
-          </a:xfrm>
-          <a:prstGeom prst="rect">
-            <a:avLst/>
-          </a:prstGeom>
-          <a:noFill/>
-          <a:ln/>
-        </p:spPr>
-        <p:txBody>
-          <a:bodyPr wrap="square" lIns="0" tIns="0" rIns="0" bIns="0" rtlCol="0" anchor="ctr"/>
-          <a:lstStyle/>
-          <a:p>
-            <a:pPr algn="ctr" indent="0" marL="0">
-              <a:lnSpc>
-                <a:spcPct val="100000"/>
-              </a:lnSpc>
-              <a:buNone/>
-            </a:pPr>
-            <a:r>
-              <a:rPr lang="en-US" sz="1000" b="1" dirty="0">
-                <a:solidFill>
-                  <a:srgbClr val="070F26"/>
-                </a:solidFill>
-                <a:latin typeface="Arial" pitchFamily="34" charset="0"/>
-                <a:ea typeface="Arial" pitchFamily="34" charset="-122"/>
-                <a:cs typeface="Arial" pitchFamily="34" charset="-120"/>
-              </a:rPr>
-              <a:t>SEM 4
-</a:t>
-            </a:r>
-            <a:pPr algn="ctr" indent="0" marL="0">
-              <a:lnSpc>
-                <a:spcPct val="100000"/>
-              </a:lnSpc>
-              <a:buNone/>
-            </a:pPr>
-            <a:r>
-              <a:rPr lang="en-US" sz="700" dirty="0">
-                <a:solidFill>
-                  <a:srgbClr val="1E3A2A"/>
-                </a:solidFill>
-                <a:latin typeface="Arial" pitchFamily="34" charset="0"/>
-                <a:ea typeface="Arial" pitchFamily="34" charset="-122"/>
-                <a:cs typeface="Arial" pitchFamily="34" charset="-120"/>
-              </a:rPr>
-              <a:t>03–09 sep</a:t>
-            </a:r>
-            <a:endParaRPr lang="en-US" sz="1000" dirty="0"/>
-          </a:p>
-        </p:txBody>
-      </p:sp>
-      <p:sp>
-        <p:nvSpPr>
-          <p:cNvPr id="31" name="Shape 28"/>
-          <p:cNvSpPr/>
-          <p:nvPr/>
-        </p:nvSpPr>
-        <p:spPr>
-          <a:xfrm>
-            <a:off x="3221736" y="2103120"/>
-            <a:ext cx="887984" cy="1078992"/>
-          </a:xfrm>
-          <a:prstGeom prst="roundRect">
-            <a:avLst>
-              <a:gd name="adj" fmla="val 8238"/>
+              <a:gd name="adj" fmla="val 8191"/>
             </a:avLst>
           </a:prstGeom>
           <a:solidFill>
@@ -9171,7 +9729,7 @@
           </a:solidFill>
           <a:ln w="15875">
             <a:solidFill>
-              <a:srgbClr val="00CB5D"/>
+              <a:srgbClr val="F9E795"/>
             </a:solidFill>
             <a:prstDash val="solid"/>
           </a:ln>
@@ -9179,14 +9737,14 @@
       </p:sp>
       <p:sp>
         <p:nvSpPr>
-          <p:cNvPr id="32" name="Text 29"/>
-          <p:cNvSpPr/>
-          <p:nvPr/>
-        </p:nvSpPr>
-        <p:spPr>
-          <a:xfrm>
-            <a:off x="3276600" y="2157984"/>
-            <a:ext cx="778256" cy="969264"/>
+          <p:cNvPr id="46" name="Text 43"/>
+          <p:cNvSpPr/>
+          <p:nvPr/>
+        </p:nvSpPr>
+        <p:spPr>
+          <a:xfrm>
+            <a:off x="3633597" y="2075688"/>
+            <a:ext cx="897255" cy="783336"/>
           </a:xfrm>
           <a:prstGeom prst="rect">
             <a:avLst/>
@@ -9205,7 +9763,7 @@
               <a:buNone/>
             </a:pPr>
             <a:r>
-              <a:rPr lang="en-US" sz="800" dirty="0">
+              <a:rPr lang="en-US" sz="750" dirty="0">
                 <a:solidFill>
                   <a:srgbClr val="FFFFFF"/>
                 </a:solidFill>
@@ -9215,24 +9773,24 @@
               </a:rPr>
               <a:t>Consolidar feedback de la ejecución EVT</a:t>
             </a:r>
-            <a:endParaRPr lang="en-US" sz="800" dirty="0"/>
-          </a:p>
-        </p:txBody>
-      </p:sp>
-      <p:sp>
-        <p:nvSpPr>
-          <p:cNvPr id="33" name="Shape 30"/>
-          <p:cNvSpPr/>
-          <p:nvPr/>
-        </p:nvSpPr>
-        <p:spPr>
-          <a:xfrm>
-            <a:off x="3221736" y="3255264"/>
-            <a:ext cx="887984" cy="1078992"/>
+            <a:endParaRPr lang="en-US" sz="750" dirty="0"/>
+          </a:p>
+        </p:txBody>
+      </p:sp>
+      <p:sp>
+        <p:nvSpPr>
+          <p:cNvPr id="47" name="Shape 44"/>
+          <p:cNvSpPr/>
+          <p:nvPr/>
+        </p:nvSpPr>
+        <p:spPr>
+          <a:xfrm>
+            <a:off x="3578733" y="2987040"/>
+            <a:ext cx="1006983" cy="893064"/>
           </a:xfrm>
           <a:prstGeom prst="roundRect">
             <a:avLst>
-              <a:gd name="adj" fmla="val 8238"/>
+              <a:gd name="adj" fmla="val 8191"/>
             </a:avLst>
           </a:prstGeom>
           <a:solidFill>
@@ -9240,7 +9798,7 @@
           </a:solidFill>
           <a:ln w="15875">
             <a:solidFill>
-              <a:srgbClr val="00CB5D"/>
+              <a:srgbClr val="F9E795"/>
             </a:solidFill>
             <a:prstDash val="solid"/>
           </a:ln>
@@ -9248,14 +9806,14 @@
       </p:sp>
       <p:sp>
         <p:nvSpPr>
-          <p:cNvPr id="34" name="Text 31"/>
-          <p:cNvSpPr/>
-          <p:nvPr/>
-        </p:nvSpPr>
-        <p:spPr>
-          <a:xfrm>
-            <a:off x="3276600" y="3310128"/>
-            <a:ext cx="778256" cy="969264"/>
+          <p:cNvPr id="48" name="Text 45"/>
+          <p:cNvSpPr/>
+          <p:nvPr/>
+        </p:nvSpPr>
+        <p:spPr>
+          <a:xfrm>
+            <a:off x="3633597" y="3041904"/>
+            <a:ext cx="897255" cy="783336"/>
           </a:xfrm>
           <a:prstGeom prst="rect">
             <a:avLst/>
@@ -9274,7 +9832,7 @@
               <a:buNone/>
             </a:pPr>
             <a:r>
-              <a:rPr lang="en-US" sz="800" dirty="0">
+              <a:rPr lang="en-US" sz="750" dirty="0">
                 <a:solidFill>
                   <a:srgbClr val="FFFFFF"/>
                 </a:solidFill>
@@ -9284,32 +9842,32 @@
               </a:rPr>
               <a:t>Iterar skills del pipeline con código real</a:t>
             </a:r>
-            <a:endParaRPr lang="en-US" sz="800" dirty="0"/>
-          </a:p>
-        </p:txBody>
-      </p:sp>
-      <p:sp>
-        <p:nvSpPr>
-          <p:cNvPr id="35" name="Shape 32"/>
-          <p:cNvSpPr/>
-          <p:nvPr/>
-        </p:nvSpPr>
-        <p:spPr>
-          <a:xfrm>
-            <a:off x="4173728" y="1097280"/>
-            <a:ext cx="1839976" cy="292608"/>
+            <a:endParaRPr lang="en-US" sz="750" dirty="0"/>
+          </a:p>
+        </p:txBody>
+      </p:sp>
+      <p:sp>
+        <p:nvSpPr>
+          <p:cNvPr id="49" name="Shape 46"/>
+          <p:cNvSpPr/>
+          <p:nvPr/>
+        </p:nvSpPr>
+        <p:spPr>
+          <a:xfrm>
+            <a:off x="2507742" y="3953256"/>
+            <a:ext cx="2077974" cy="893064"/>
           </a:xfrm>
           <a:prstGeom prst="roundRect">
             <a:avLst>
-              <a:gd name="adj" fmla="val 50000"/>
+              <a:gd name="adj" fmla="val 8191"/>
             </a:avLst>
           </a:prstGeom>
           <a:solidFill>
-            <a:srgbClr val="005B96"/>
+            <a:srgbClr val="0A1A2E"/>
           </a:solidFill>
-          <a:ln w="12700">
+          <a:ln w="15875">
             <a:solidFill>
-              <a:srgbClr val="333333"/>
+              <a:srgbClr val="005B96"/>
             </a:solidFill>
             <a:prstDash val="solid"/>
           </a:ln>
@@ -9317,14 +9875,14 @@
       </p:sp>
       <p:sp>
         <p:nvSpPr>
-          <p:cNvPr id="36" name="Text 33"/>
-          <p:cNvSpPr/>
-          <p:nvPr/>
-        </p:nvSpPr>
-        <p:spPr>
-          <a:xfrm>
-            <a:off x="4173728" y="1097280"/>
-            <a:ext cx="1839976" cy="292608"/>
+          <p:cNvPr id="50" name="Text 47"/>
+          <p:cNvSpPr/>
+          <p:nvPr/>
+        </p:nvSpPr>
+        <p:spPr>
+          <a:xfrm>
+            <a:off x="2562606" y="4008120"/>
+            <a:ext cx="1968246" cy="783336"/>
           </a:xfrm>
           <a:prstGeom prst="rect">
             <a:avLst/>
@@ -9336,164 +9894,41 @@
           <a:bodyPr wrap="square" lIns="0" tIns="0" rIns="0" bIns="0" rtlCol="0" anchor="ctr"/>
           <a:lstStyle/>
           <a:p>
-            <a:pPr algn="ctr" indent="0" marL="0">
-              <a:buNone/>
-            </a:pPr>
-            <a:r>
-              <a:rPr lang="en-US" sz="1050" b="1" dirty="0">
+            <a:pPr algn="l" indent="0" marL="0">
+              <a:lnSpc>
+                <a:spcPct val="105000"/>
+              </a:lnSpc>
+              <a:buNone/>
+            </a:pPr>
+            <a:r>
+              <a:rPr lang="en-US" sz="900" dirty="0">
                 <a:solidFill>
                   <a:srgbClr val="FFFFFF"/>
-                </a:solidFill>
-                <a:latin typeface="Noto Sans" pitchFamily="34" charset="0"/>
-                <a:ea typeface="Noto Sans" pitchFamily="34" charset="-122"/>
-                <a:cs typeface="Noto Sans" pitchFamily="34" charset="-120"/>
-              </a:rPr>
-              <a:t>SPRINT 3</a:t>
-            </a:r>
-            <a:endParaRPr lang="en-US" sz="1050" dirty="0"/>
-          </a:p>
-        </p:txBody>
-      </p:sp>
-      <p:sp>
-        <p:nvSpPr>
-          <p:cNvPr id="37" name="Text 34"/>
-          <p:cNvSpPr/>
-          <p:nvPr/>
-        </p:nvSpPr>
-        <p:spPr>
-          <a:xfrm>
-            <a:off x="4173728" y="1408176"/>
-            <a:ext cx="1839976" cy="182880"/>
-          </a:xfrm>
-          <a:prstGeom prst="rect">
-            <a:avLst/>
-          </a:prstGeom>
-          <a:noFill/>
-          <a:ln/>
-        </p:spPr>
-        <p:txBody>
-          <a:bodyPr wrap="square" lIns="0" tIns="0" rIns="0" bIns="0" rtlCol="0" anchor="ctr"/>
-          <a:lstStyle/>
-          <a:p>
-            <a:pPr algn="ctr" indent="0" marL="0">
-              <a:buNone/>
-            </a:pPr>
-            <a:r>
-              <a:rPr lang="en-US" sz="800" dirty="0">
-                <a:solidFill>
-                  <a:srgbClr val="D6D6D6"/>
                 </a:solidFill>
                 <a:latin typeface="Arial" pitchFamily="34" charset="0"/>
                 <a:ea typeface="Arial" pitchFamily="34" charset="-122"/>
                 <a:cs typeface="Arial" pitchFamily="34" charset="-120"/>
               </a:rPr>
-              <a:t>10–23 sep</a:t>
-            </a:r>
-            <a:endParaRPr lang="en-US" sz="800" dirty="0"/>
-          </a:p>
-        </p:txBody>
-      </p:sp>
-      <p:sp>
-        <p:nvSpPr>
-          <p:cNvPr id="38" name="Shape 35"/>
-          <p:cNvSpPr/>
-          <p:nvPr/>
-        </p:nvSpPr>
-        <p:spPr>
-          <a:xfrm>
-            <a:off x="4173728" y="1645920"/>
-            <a:ext cx="887984" cy="365760"/>
+              <a:t>Skills adicionales (3)</a:t>
+            </a:r>
+            <a:endParaRPr lang="en-US" sz="900" dirty="0"/>
+          </a:p>
+        </p:txBody>
+      </p:sp>
+      <p:sp>
+        <p:nvSpPr>
+          <p:cNvPr id="51" name="Shape 48"/>
+          <p:cNvSpPr/>
+          <p:nvPr/>
+        </p:nvSpPr>
+        <p:spPr>
+          <a:xfrm>
+            <a:off x="4649724" y="2020824"/>
+            <a:ext cx="3148965" cy="1376172"/>
           </a:xfrm>
           <a:prstGeom prst="roundRect">
             <a:avLst>
-              <a:gd name="adj" fmla="val 35000"/>
-            </a:avLst>
-          </a:prstGeom>
-          <a:solidFill>
-            <a:srgbClr val="1A2B4A"/>
-          </a:solidFill>
-          <a:ln w="12700">
-            <a:solidFill>
-              <a:srgbClr val="333333"/>
-            </a:solidFill>
-            <a:prstDash val="solid"/>
-          </a:ln>
-        </p:spPr>
-      </p:sp>
-      <p:sp>
-        <p:nvSpPr>
-          <p:cNvPr id="39" name="Text 36"/>
-          <p:cNvSpPr/>
-          <p:nvPr/>
-        </p:nvSpPr>
-        <p:spPr>
-          <a:xfrm>
-            <a:off x="4173728" y="1645920"/>
-            <a:ext cx="887984" cy="365760"/>
-          </a:xfrm>
-          <a:prstGeom prst="rect">
-            <a:avLst/>
-          </a:prstGeom>
-          <a:noFill/>
-          <a:ln/>
-        </p:spPr>
-        <p:txBody>
-          <a:bodyPr wrap="square" lIns="0" tIns="0" rIns="0" bIns="0" rtlCol="0" anchor="ctr"/>
-          <a:lstStyle/>
-          <a:p>
-            <a:pPr algn="ctr" indent="0" marL="0">
-              <a:lnSpc>
-                <a:spcPct val="100000"/>
-              </a:lnSpc>
-              <a:buNone/>
-            </a:pPr>
-            <a:r>
-              <a:rPr lang="en-US" sz="1000" b="1" dirty="0">
-                <a:solidFill>
-                  <a:srgbClr val="FFFFFF"/>
-                </a:solidFill>
-                <a:latin typeface="Arial" pitchFamily="34" charset="0"/>
-                <a:ea typeface="Arial" pitchFamily="34" charset="-122"/>
-                <a:cs typeface="Arial" pitchFamily="34" charset="-120"/>
-              </a:rPr>
-              <a:t>SEM 5
-</a:t>
-            </a:r>
-            <a:pPr algn="ctr" indent="0" marL="0">
-              <a:lnSpc>
-                <a:spcPct val="100000"/>
-              </a:lnSpc>
-              <a:buNone/>
-            </a:pPr>
-            <a:r>
-              <a:rPr lang="en-US" sz="700" dirty="0">
-                <a:solidFill>
-                  <a:srgbClr val="D6D6D6"/>
-                </a:solidFill>
-                <a:latin typeface="Arial" pitchFamily="34" charset="0"/>
-                <a:ea typeface="Arial" pitchFamily="34" charset="-122"/>
-                <a:cs typeface="Arial" pitchFamily="34" charset="-120"/>
-              </a:rPr>
-              <a:t>10–16 sep</a:t>
-            </a:r>
-            <a:endParaRPr lang="en-US" sz="1000" dirty="0"/>
-          </a:p>
-        </p:txBody>
-      </p:sp>
-      <p:sp>
-        <p:nvSpPr>
-          <p:cNvPr id="40" name="Shape 37"/>
-          <p:cNvSpPr/>
-          <p:nvPr/>
-        </p:nvSpPr>
-        <p:spPr>
-          <a:xfrm>
-            <a:off x="4173728" y="2103120"/>
-            <a:ext cx="887984" cy="1078992"/>
-          </a:xfrm>
-          <a:prstGeom prst="roundRect">
-            <a:avLst>
-              <a:gd name="adj" fmla="val 8238"/>
+              <a:gd name="adj" fmla="val 5316"/>
             </a:avLst>
           </a:prstGeom>
           <a:solidFill>
@@ -9509,14 +9944,14 @@
       </p:sp>
       <p:sp>
         <p:nvSpPr>
-          <p:cNvPr id="41" name="Text 38"/>
-          <p:cNvSpPr/>
-          <p:nvPr/>
-        </p:nvSpPr>
-        <p:spPr>
-          <a:xfrm>
-            <a:off x="4228592" y="2157984"/>
-            <a:ext cx="778256" cy="969264"/>
+          <p:cNvPr id="52" name="Text 49"/>
+          <p:cNvSpPr/>
+          <p:nvPr/>
+        </p:nvSpPr>
+        <p:spPr>
+          <a:xfrm>
+            <a:off x="4704588" y="2075688"/>
+            <a:ext cx="3039237" cy="1266444"/>
           </a:xfrm>
           <a:prstGeom prst="rect">
             <a:avLst/>
@@ -9535,7 +9970,7 @@
               <a:buNone/>
             </a:pPr>
             <a:r>
-              <a:rPr lang="en-US" sz="800" dirty="0">
+              <a:rPr lang="en-US" sz="900" dirty="0">
                 <a:solidFill>
                   <a:srgbClr val="FFFFFF"/>
                 </a:solidFill>
@@ -9543,26 +9978,26 @@
                 <a:ea typeface="Arial" pitchFamily="34" charset="-122"/>
                 <a:cs typeface="Arial" pitchFamily="34" charset="-120"/>
               </a:rPr>
-              <a:t>Skills adicionales: bcv-hexagonal-architecture y bcv-openapi-design</a:t>
-            </a:r>
-            <a:endParaRPr lang="en-US" sz="800" dirty="0"/>
-          </a:p>
-        </p:txBody>
-      </p:sp>
-      <p:sp>
-        <p:nvSpPr>
-          <p:cNvPr id="42" name="Shape 39"/>
-          <p:cNvSpPr/>
-          <p:nvPr/>
-        </p:nvSpPr>
-        <p:spPr>
-          <a:xfrm>
-            <a:off x="4173728" y="3255264"/>
-            <a:ext cx="887984" cy="1078992"/>
+              <a:t>Iteración y ajustes de skills definidos con HUs/EVTs</a:t>
+            </a:r>
+            <a:endParaRPr lang="en-US" sz="900" dirty="0"/>
+          </a:p>
+        </p:txBody>
+      </p:sp>
+      <p:sp>
+        <p:nvSpPr>
+          <p:cNvPr id="53" name="Shape 50"/>
+          <p:cNvSpPr/>
+          <p:nvPr/>
+        </p:nvSpPr>
+        <p:spPr>
+          <a:xfrm>
+            <a:off x="4649724" y="3470148"/>
+            <a:ext cx="3148965" cy="1376172"/>
           </a:xfrm>
           <a:prstGeom prst="roundRect">
             <a:avLst>
-              <a:gd name="adj" fmla="val 8238"/>
+              <a:gd name="adj" fmla="val 5316"/>
             </a:avLst>
           </a:prstGeom>
           <a:solidFill>
@@ -9578,14 +10013,14 @@
       </p:sp>
       <p:sp>
         <p:nvSpPr>
-          <p:cNvPr id="43" name="Text 40"/>
-          <p:cNvSpPr/>
-          <p:nvPr/>
-        </p:nvSpPr>
-        <p:spPr>
-          <a:xfrm>
-            <a:off x="4228592" y="3310128"/>
-            <a:ext cx="778256" cy="969264"/>
+          <p:cNvPr id="54" name="Text 51"/>
+          <p:cNvSpPr/>
+          <p:nvPr/>
+        </p:nvSpPr>
+        <p:spPr>
+          <a:xfrm>
+            <a:off x="4704588" y="3525012"/>
+            <a:ext cx="3039237" cy="1266444"/>
           </a:xfrm>
           <a:prstGeom prst="rect">
             <a:avLst/>
@@ -9604,7 +10039,7 @@
               <a:buNone/>
             </a:pPr>
             <a:r>
-              <a:rPr lang="en-US" sz="800" dirty="0">
+              <a:rPr lang="en-US" sz="900" dirty="0">
                 <a:solidFill>
                   <a:srgbClr val="FFFFFF"/>
                 </a:solidFill>
@@ -9612,113 +10047,26 @@
                 <a:ea typeface="Arial" pitchFamily="34" charset="-122"/>
                 <a:cs typeface="Arial" pitchFamily="34" charset="-120"/>
               </a:rPr>
-              <a:t>Sumar bcv-spring-data-jpa-sql-server (persistencia SQL Server)</a:t>
-            </a:r>
-            <a:endParaRPr lang="en-US" sz="800" dirty="0"/>
-          </a:p>
-        </p:txBody>
-      </p:sp>
-      <p:sp>
-        <p:nvSpPr>
-          <p:cNvPr id="44" name="Shape 41"/>
-          <p:cNvSpPr/>
-          <p:nvPr/>
-        </p:nvSpPr>
-        <p:spPr>
-          <a:xfrm>
-            <a:off x="5125720" y="1645920"/>
-            <a:ext cx="887984" cy="365760"/>
+              <a:t>Métricas obtenidas de ejecución</a:t>
+            </a:r>
+            <a:endParaRPr lang="en-US" sz="900" dirty="0"/>
+          </a:p>
+        </p:txBody>
+      </p:sp>
+      <p:sp>
+        <p:nvSpPr>
+          <p:cNvPr id="55" name="Shape 52"/>
+          <p:cNvSpPr/>
+          <p:nvPr/>
+        </p:nvSpPr>
+        <p:spPr>
+          <a:xfrm>
+            <a:off x="7862697" y="2020824"/>
+            <a:ext cx="1006983" cy="1376172"/>
           </a:xfrm>
           <a:prstGeom prst="roundRect">
             <a:avLst>
-              <a:gd name="adj" fmla="val 35000"/>
-            </a:avLst>
-          </a:prstGeom>
-          <a:solidFill>
-            <a:srgbClr val="1A2B4A"/>
-          </a:solidFill>
-          <a:ln w="12700">
-            <a:solidFill>
-              <a:srgbClr val="333333"/>
-            </a:solidFill>
-            <a:prstDash val="solid"/>
-          </a:ln>
-        </p:spPr>
-      </p:sp>
-      <p:sp>
-        <p:nvSpPr>
-          <p:cNvPr id="45" name="Text 42"/>
-          <p:cNvSpPr/>
-          <p:nvPr/>
-        </p:nvSpPr>
-        <p:spPr>
-          <a:xfrm>
-            <a:off x="5125720" y="1645920"/>
-            <a:ext cx="887984" cy="365760"/>
-          </a:xfrm>
-          <a:prstGeom prst="rect">
-            <a:avLst/>
-          </a:prstGeom>
-          <a:noFill/>
-          <a:ln/>
-        </p:spPr>
-        <p:txBody>
-          <a:bodyPr wrap="square" lIns="0" tIns="0" rIns="0" bIns="0" rtlCol="0" anchor="ctr"/>
-          <a:lstStyle/>
-          <a:p>
-            <a:pPr algn="ctr" indent="0" marL="0">
-              <a:lnSpc>
-                <a:spcPct val="100000"/>
-              </a:lnSpc>
-              <a:buNone/>
-            </a:pPr>
-            <a:r>
-              <a:rPr lang="en-US" sz="1000" b="1" dirty="0">
-                <a:solidFill>
-                  <a:srgbClr val="FFFFFF"/>
-                </a:solidFill>
-                <a:latin typeface="Arial" pitchFamily="34" charset="0"/>
-                <a:ea typeface="Arial" pitchFamily="34" charset="-122"/>
-                <a:cs typeface="Arial" pitchFamily="34" charset="-120"/>
-              </a:rPr>
-              <a:t>SEM 6
-</a:t>
-            </a:r>
-            <a:pPr algn="ctr" indent="0" marL="0">
-              <a:lnSpc>
-                <a:spcPct val="100000"/>
-              </a:lnSpc>
-              <a:buNone/>
-            </a:pPr>
-            <a:r>
-              <a:rPr lang="en-US" sz="700" dirty="0">
-                <a:solidFill>
-                  <a:srgbClr val="D6D6D6"/>
-                </a:solidFill>
-                <a:latin typeface="Arial" pitchFamily="34" charset="0"/>
-                <a:ea typeface="Arial" pitchFamily="34" charset="-122"/>
-                <a:cs typeface="Arial" pitchFamily="34" charset="-120"/>
-              </a:rPr>
-              <a:t>17–23 sep</a:t>
-            </a:r>
-            <a:endParaRPr lang="en-US" sz="1000" dirty="0"/>
-          </a:p>
-        </p:txBody>
-      </p:sp>
-      <p:sp>
-        <p:nvSpPr>
-          <p:cNvPr id="46" name="Shape 43"/>
-          <p:cNvSpPr/>
-          <p:nvPr/>
-        </p:nvSpPr>
-        <p:spPr>
-          <a:xfrm>
-            <a:off x="5125720" y="2103120"/>
-            <a:ext cx="887984" cy="1078992"/>
-          </a:xfrm>
-          <a:prstGeom prst="roundRect">
-            <a:avLst>
-              <a:gd name="adj" fmla="val 8238"/>
+              <a:gd name="adj" fmla="val 7264"/>
             </a:avLst>
           </a:prstGeom>
           <a:solidFill>
@@ -9734,14 +10082,14 @@
       </p:sp>
       <p:sp>
         <p:nvSpPr>
-          <p:cNvPr id="47" name="Text 44"/>
-          <p:cNvSpPr/>
-          <p:nvPr/>
-        </p:nvSpPr>
-        <p:spPr>
-          <a:xfrm>
-            <a:off x="5180584" y="2157984"/>
-            <a:ext cx="778256" cy="969264"/>
+          <p:cNvPr id="56" name="Text 53"/>
+          <p:cNvSpPr/>
+          <p:nvPr/>
+        </p:nvSpPr>
+        <p:spPr>
+          <a:xfrm>
+            <a:off x="7917561" y="2075688"/>
+            <a:ext cx="897255" cy="1266444"/>
           </a:xfrm>
           <a:prstGeom prst="rect">
             <a:avLst/>
@@ -9768,7 +10116,7 @@
                 <a:ea typeface="Arial" pitchFamily="34" charset="-122"/>
                 <a:cs typeface="Arial" pitchFamily="34" charset="-120"/>
               </a:rPr>
-              <a:t>Consolidar el pipeline completo</a:t>
+              <a:t>Elaboración de informe final</a:t>
             </a:r>
             <a:endParaRPr lang="en-US" sz="800" dirty="0"/>
           </a:p>
@@ -9776,18 +10124,18 @@
       </p:sp>
       <p:sp>
         <p:nvSpPr>
-          <p:cNvPr id="48" name="Shape 45"/>
-          <p:cNvSpPr/>
-          <p:nvPr/>
-        </p:nvSpPr>
-        <p:spPr>
-          <a:xfrm>
-            <a:off x="5125720" y="3255264"/>
-            <a:ext cx="887984" cy="1078992"/>
+          <p:cNvPr id="57" name="Shape 54"/>
+          <p:cNvSpPr/>
+          <p:nvPr/>
+        </p:nvSpPr>
+        <p:spPr>
+          <a:xfrm>
+            <a:off x="7862697" y="3470148"/>
+            <a:ext cx="1006983" cy="1376172"/>
           </a:xfrm>
           <a:prstGeom prst="roundRect">
             <a:avLst>
-              <a:gd name="adj" fmla="val 8238"/>
+              <a:gd name="adj" fmla="val 7264"/>
             </a:avLst>
           </a:prstGeom>
           <a:solidFill>
@@ -9803,14 +10151,14 @@
       </p:sp>
       <p:sp>
         <p:nvSpPr>
-          <p:cNvPr id="49" name="Text 46"/>
-          <p:cNvSpPr/>
-          <p:nvPr/>
-        </p:nvSpPr>
-        <p:spPr>
-          <a:xfrm>
-            <a:off x="5180584" y="3310128"/>
-            <a:ext cx="778256" cy="969264"/>
+          <p:cNvPr id="58" name="Text 55"/>
+          <p:cNvSpPr/>
+          <p:nvPr/>
+        </p:nvSpPr>
+        <p:spPr>
+          <a:xfrm>
+            <a:off x="7917561" y="3525012"/>
+            <a:ext cx="897255" cy="1266444"/>
           </a:xfrm>
           <a:prstGeom prst="rect">
             <a:avLst/>
@@ -9837,7 +10185,7 @@
                 <a:ea typeface="Arial" pitchFamily="34" charset="-122"/>
                 <a:cs typeface="Arial" pitchFamily="34" charset="-120"/>
               </a:rPr>
-              <a:t>Ejecutar bcv-hu-implementer (dry-run → apply)</a:t>
+              <a:t>Recomendaciones y lecciones aprendidas</a:t>
             </a:r>
             <a:endParaRPr lang="en-US" sz="800" dirty="0"/>
           </a:p>
@@ -9845,787 +10193,7 @@
       </p:sp>
       <p:sp>
         <p:nvSpPr>
-          <p:cNvPr id="50" name="Shape 47"/>
-          <p:cNvSpPr/>
-          <p:nvPr/>
-        </p:nvSpPr>
-        <p:spPr>
-          <a:xfrm>
-            <a:off x="6077712" y="1097280"/>
-            <a:ext cx="2791968" cy="292608"/>
-          </a:xfrm>
-          <a:prstGeom prst="roundRect">
-            <a:avLst>
-              <a:gd name="adj" fmla="val 50000"/>
-            </a:avLst>
-          </a:prstGeom>
-          <a:solidFill>
-            <a:srgbClr val="005B96"/>
-          </a:solidFill>
-          <a:ln w="12700">
-            <a:solidFill>
-              <a:srgbClr val="333333"/>
-            </a:solidFill>
-            <a:prstDash val="solid"/>
-          </a:ln>
-        </p:spPr>
-      </p:sp>
-      <p:sp>
-        <p:nvSpPr>
-          <p:cNvPr id="51" name="Text 48"/>
-          <p:cNvSpPr/>
-          <p:nvPr/>
-        </p:nvSpPr>
-        <p:spPr>
-          <a:xfrm>
-            <a:off x="6077712" y="1097280"/>
-            <a:ext cx="2791968" cy="292608"/>
-          </a:xfrm>
-          <a:prstGeom prst="rect">
-            <a:avLst/>
-          </a:prstGeom>
-          <a:noFill/>
-          <a:ln/>
-        </p:spPr>
-        <p:txBody>
-          <a:bodyPr wrap="square" lIns="0" tIns="0" rIns="0" bIns="0" rtlCol="0" anchor="ctr"/>
-          <a:lstStyle/>
-          <a:p>
-            <a:pPr algn="ctr" indent="0" marL="0">
-              <a:buNone/>
-            </a:pPr>
-            <a:r>
-              <a:rPr lang="en-US" sz="1050" b="1" dirty="0">
-                <a:solidFill>
-                  <a:srgbClr val="FFFFFF"/>
-                </a:solidFill>
-                <a:latin typeface="Noto Sans" pitchFamily="34" charset="0"/>
-                <a:ea typeface="Noto Sans" pitchFamily="34" charset="-122"/>
-                <a:cs typeface="Noto Sans" pitchFamily="34" charset="-120"/>
-              </a:rPr>
-              <a:t>SPRINT 4</a:t>
-            </a:r>
-            <a:endParaRPr lang="en-US" sz="1050" dirty="0"/>
-          </a:p>
-        </p:txBody>
-      </p:sp>
-      <p:sp>
-        <p:nvSpPr>
-          <p:cNvPr id="52" name="Text 49"/>
-          <p:cNvSpPr/>
-          <p:nvPr/>
-        </p:nvSpPr>
-        <p:spPr>
-          <a:xfrm>
-            <a:off x="6077712" y="1408176"/>
-            <a:ext cx="2791968" cy="182880"/>
-          </a:xfrm>
-          <a:prstGeom prst="rect">
-            <a:avLst/>
-          </a:prstGeom>
-          <a:noFill/>
-          <a:ln/>
-        </p:spPr>
-        <p:txBody>
-          <a:bodyPr wrap="square" lIns="0" tIns="0" rIns="0" bIns="0" rtlCol="0" anchor="ctr"/>
-          <a:lstStyle/>
-          <a:p>
-            <a:pPr algn="ctr" indent="0" marL="0">
-              <a:buNone/>
-            </a:pPr>
-            <a:r>
-              <a:rPr lang="en-US" sz="800" dirty="0">
-                <a:solidFill>
-                  <a:srgbClr val="D6D6D6"/>
-                </a:solidFill>
-                <a:latin typeface="Arial" pitchFamily="34" charset="0"/>
-                <a:ea typeface="Arial" pitchFamily="34" charset="-122"/>
-                <a:cs typeface="Arial" pitchFamily="34" charset="-120"/>
-              </a:rPr>
-              <a:t>24 sep–09 oct</a:t>
-            </a:r>
-            <a:endParaRPr lang="en-US" sz="800" dirty="0"/>
-          </a:p>
-        </p:txBody>
-      </p:sp>
-      <p:sp>
-        <p:nvSpPr>
-          <p:cNvPr id="53" name="Shape 50"/>
-          <p:cNvSpPr/>
-          <p:nvPr/>
-        </p:nvSpPr>
-        <p:spPr>
-          <a:xfrm>
-            <a:off x="6077712" y="1645920"/>
-            <a:ext cx="887984" cy="365760"/>
-          </a:xfrm>
-          <a:prstGeom prst="roundRect">
-            <a:avLst>
-              <a:gd name="adj" fmla="val 35000"/>
-            </a:avLst>
-          </a:prstGeom>
-          <a:solidFill>
-            <a:srgbClr val="1A2B4A"/>
-          </a:solidFill>
-          <a:ln w="12700">
-            <a:solidFill>
-              <a:srgbClr val="333333"/>
-            </a:solidFill>
-            <a:prstDash val="solid"/>
-          </a:ln>
-        </p:spPr>
-      </p:sp>
-      <p:sp>
-        <p:nvSpPr>
-          <p:cNvPr id="54" name="Text 51"/>
-          <p:cNvSpPr/>
-          <p:nvPr/>
-        </p:nvSpPr>
-        <p:spPr>
-          <a:xfrm>
-            <a:off x="6077712" y="1645920"/>
-            <a:ext cx="887984" cy="365760"/>
-          </a:xfrm>
-          <a:prstGeom prst="rect">
-            <a:avLst/>
-          </a:prstGeom>
-          <a:noFill/>
-          <a:ln/>
-        </p:spPr>
-        <p:txBody>
-          <a:bodyPr wrap="square" lIns="0" tIns="0" rIns="0" bIns="0" rtlCol="0" anchor="ctr"/>
-          <a:lstStyle/>
-          <a:p>
-            <a:pPr algn="ctr" indent="0" marL="0">
-              <a:lnSpc>
-                <a:spcPct val="100000"/>
-              </a:lnSpc>
-              <a:buNone/>
-            </a:pPr>
-            <a:r>
-              <a:rPr lang="en-US" sz="1000" b="1" dirty="0">
-                <a:solidFill>
-                  <a:srgbClr val="FFFFFF"/>
-                </a:solidFill>
-                <a:latin typeface="Arial" pitchFamily="34" charset="0"/>
-                <a:ea typeface="Arial" pitchFamily="34" charset="-122"/>
-                <a:cs typeface="Arial" pitchFamily="34" charset="-120"/>
-              </a:rPr>
-              <a:t>SEM 7
-</a:t>
-            </a:r>
-            <a:pPr algn="ctr" indent="0" marL="0">
-              <a:lnSpc>
-                <a:spcPct val="100000"/>
-              </a:lnSpc>
-              <a:buNone/>
-            </a:pPr>
-            <a:r>
-              <a:rPr lang="en-US" sz="700" dirty="0">
-                <a:solidFill>
-                  <a:srgbClr val="D6D6D6"/>
-                </a:solidFill>
-                <a:latin typeface="Arial" pitchFamily="34" charset="0"/>
-                <a:ea typeface="Arial" pitchFamily="34" charset="-122"/>
-                <a:cs typeface="Arial" pitchFamily="34" charset="-120"/>
-              </a:rPr>
-              <a:t>24–30 sep</a:t>
-            </a:r>
-            <a:endParaRPr lang="en-US" sz="1000" dirty="0"/>
-          </a:p>
-        </p:txBody>
-      </p:sp>
-      <p:sp>
-        <p:nvSpPr>
-          <p:cNvPr id="55" name="Shape 52"/>
-          <p:cNvSpPr/>
-          <p:nvPr/>
-        </p:nvSpPr>
-        <p:spPr>
-          <a:xfrm>
-            <a:off x="6077712" y="2103120"/>
-            <a:ext cx="887984" cy="1078992"/>
-          </a:xfrm>
-          <a:prstGeom prst="roundRect">
-            <a:avLst>
-              <a:gd name="adj" fmla="val 8238"/>
-            </a:avLst>
-          </a:prstGeom>
-          <a:solidFill>
-            <a:srgbClr val="0A1A2E"/>
-          </a:solidFill>
-          <a:ln w="15875">
-            <a:solidFill>
-              <a:srgbClr val="1A2B4A"/>
-            </a:solidFill>
-            <a:prstDash val="solid"/>
-          </a:ln>
-        </p:spPr>
-      </p:sp>
-      <p:sp>
-        <p:nvSpPr>
-          <p:cNvPr id="56" name="Text 53"/>
-          <p:cNvSpPr/>
-          <p:nvPr/>
-        </p:nvSpPr>
-        <p:spPr>
-          <a:xfrm>
-            <a:off x="6132576" y="2157984"/>
-            <a:ext cx="778256" cy="969264"/>
-          </a:xfrm>
-          <a:prstGeom prst="rect">
-            <a:avLst/>
-          </a:prstGeom>
-          <a:noFill/>
-          <a:ln/>
-        </p:spPr>
-        <p:txBody>
-          <a:bodyPr wrap="square" lIns="0" tIns="0" rIns="0" bIns="0" rtlCol="0" anchor="ctr"/>
-          <a:lstStyle/>
-          <a:p>
-            <a:pPr algn="l" indent="0" marL="0">
-              <a:lnSpc>
-                <a:spcPct val="105000"/>
-              </a:lnSpc>
-              <a:buNone/>
-            </a:pPr>
-            <a:r>
-              <a:rPr lang="en-US" sz="800" dirty="0">
-                <a:solidFill>
-                  <a:srgbClr val="FFFFFF"/>
-                </a:solidFill>
-                <a:latin typeface="Arial" pitchFamily="34" charset="0"/>
-                <a:ea typeface="Arial" pitchFamily="34" charset="-122"/>
-                <a:cs typeface="Arial" pitchFamily="34" charset="-120"/>
-              </a:rPr>
-              <a:t>Validación con equipo dev del banco (entorno propio)</a:t>
-            </a:r>
-            <a:endParaRPr lang="en-US" sz="800" dirty="0"/>
-          </a:p>
-        </p:txBody>
-      </p:sp>
-      <p:sp>
-        <p:nvSpPr>
-          <p:cNvPr id="57" name="Shape 54"/>
-          <p:cNvSpPr/>
-          <p:nvPr/>
-        </p:nvSpPr>
-        <p:spPr>
-          <a:xfrm>
-            <a:off x="6077712" y="3255264"/>
-            <a:ext cx="887984" cy="1078992"/>
-          </a:xfrm>
-          <a:prstGeom prst="roundRect">
-            <a:avLst>
-              <a:gd name="adj" fmla="val 8238"/>
-            </a:avLst>
-          </a:prstGeom>
-          <a:solidFill>
-            <a:srgbClr val="0A1A2E"/>
-          </a:solidFill>
-          <a:ln w="15875">
-            <a:solidFill>
-              <a:srgbClr val="1A2B4A"/>
-            </a:solidFill>
-            <a:prstDash val="solid"/>
-          </a:ln>
-        </p:spPr>
-      </p:sp>
-      <p:sp>
-        <p:nvSpPr>
-          <p:cNvPr id="58" name="Text 55"/>
-          <p:cNvSpPr/>
-          <p:nvPr/>
-        </p:nvSpPr>
-        <p:spPr>
-          <a:xfrm>
-            <a:off x="6132576" y="3310128"/>
-            <a:ext cx="778256" cy="969264"/>
-          </a:xfrm>
-          <a:prstGeom prst="rect">
-            <a:avLst/>
-          </a:prstGeom>
-          <a:noFill/>
-          <a:ln/>
-        </p:spPr>
-        <p:txBody>
-          <a:bodyPr wrap="square" lIns="0" tIns="0" rIns="0" bIns="0" rtlCol="0" anchor="ctr"/>
-          <a:lstStyle/>
-          <a:p>
-            <a:pPr algn="l" indent="0" marL="0">
-              <a:lnSpc>
-                <a:spcPct val="105000"/>
-              </a:lnSpc>
-              <a:buNone/>
-            </a:pPr>
-            <a:r>
-              <a:rPr lang="en-US" sz="800" dirty="0">
-                <a:solidFill>
-                  <a:srgbClr val="FFFFFF"/>
-                </a:solidFill>
-                <a:latin typeface="Arial" pitchFamily="34" charset="0"/>
-                <a:ea typeface="Arial" pitchFamily="34" charset="-122"/>
-                <a:cs typeface="Arial" pitchFamily="34" charset="-120"/>
-              </a:rPr>
-              <a:t>Ciclo: ajustar → regenerar → revalidar</a:t>
-            </a:r>
-            <a:endParaRPr lang="en-US" sz="800" dirty="0"/>
-          </a:p>
-        </p:txBody>
-      </p:sp>
-      <p:sp>
-        <p:nvSpPr>
           <p:cNvPr id="59" name="Shape 56"/>
-          <p:cNvSpPr/>
-          <p:nvPr/>
-        </p:nvSpPr>
-        <p:spPr>
-          <a:xfrm>
-            <a:off x="7029704" y="1645920"/>
-            <a:ext cx="887984" cy="365760"/>
-          </a:xfrm>
-          <a:prstGeom prst="roundRect">
-            <a:avLst>
-              <a:gd name="adj" fmla="val 35000"/>
-            </a:avLst>
-          </a:prstGeom>
-          <a:solidFill>
-            <a:srgbClr val="1A2B4A"/>
-          </a:solidFill>
-          <a:ln w="12700">
-            <a:solidFill>
-              <a:srgbClr val="333333"/>
-            </a:solidFill>
-            <a:prstDash val="solid"/>
-          </a:ln>
-        </p:spPr>
-      </p:sp>
-      <p:sp>
-        <p:nvSpPr>
-          <p:cNvPr id="60" name="Text 57"/>
-          <p:cNvSpPr/>
-          <p:nvPr/>
-        </p:nvSpPr>
-        <p:spPr>
-          <a:xfrm>
-            <a:off x="7029704" y="1645920"/>
-            <a:ext cx="887984" cy="365760"/>
-          </a:xfrm>
-          <a:prstGeom prst="rect">
-            <a:avLst/>
-          </a:prstGeom>
-          <a:noFill/>
-          <a:ln/>
-        </p:spPr>
-        <p:txBody>
-          <a:bodyPr wrap="square" lIns="0" tIns="0" rIns="0" bIns="0" rtlCol="0" anchor="ctr"/>
-          <a:lstStyle/>
-          <a:p>
-            <a:pPr algn="ctr" indent="0" marL="0">
-              <a:lnSpc>
-                <a:spcPct val="100000"/>
-              </a:lnSpc>
-              <a:buNone/>
-            </a:pPr>
-            <a:r>
-              <a:rPr lang="en-US" sz="1000" b="1" dirty="0">
-                <a:solidFill>
-                  <a:srgbClr val="FFFFFF"/>
-                </a:solidFill>
-                <a:latin typeface="Arial" pitchFamily="34" charset="0"/>
-                <a:ea typeface="Arial" pitchFamily="34" charset="-122"/>
-                <a:cs typeface="Arial" pitchFamily="34" charset="-120"/>
-              </a:rPr>
-              <a:t>SEM 8
-</a:t>
-            </a:r>
-            <a:pPr algn="ctr" indent="0" marL="0">
-              <a:lnSpc>
-                <a:spcPct val="100000"/>
-              </a:lnSpc>
-              <a:buNone/>
-            </a:pPr>
-            <a:r>
-              <a:rPr lang="en-US" sz="700" dirty="0">
-                <a:solidFill>
-                  <a:srgbClr val="D6D6D6"/>
-                </a:solidFill>
-                <a:latin typeface="Arial" pitchFamily="34" charset="0"/>
-                <a:ea typeface="Arial" pitchFamily="34" charset="-122"/>
-                <a:cs typeface="Arial" pitchFamily="34" charset="-120"/>
-              </a:rPr>
-              <a:t>01–07 oct</a:t>
-            </a:r>
-            <a:endParaRPr lang="en-US" sz="1000" dirty="0"/>
-          </a:p>
-        </p:txBody>
-      </p:sp>
-      <p:sp>
-        <p:nvSpPr>
-          <p:cNvPr id="61" name="Shape 58"/>
-          <p:cNvSpPr/>
-          <p:nvPr/>
-        </p:nvSpPr>
-        <p:spPr>
-          <a:xfrm>
-            <a:off x="7029704" y="2103120"/>
-            <a:ext cx="887984" cy="1078992"/>
-          </a:xfrm>
-          <a:prstGeom prst="roundRect">
-            <a:avLst>
-              <a:gd name="adj" fmla="val 8238"/>
-            </a:avLst>
-          </a:prstGeom>
-          <a:solidFill>
-            <a:srgbClr val="0A1A2E"/>
-          </a:solidFill>
-          <a:ln w="15875">
-            <a:solidFill>
-              <a:srgbClr val="1A2B4A"/>
-            </a:solidFill>
-            <a:prstDash val="solid"/>
-          </a:ln>
-        </p:spPr>
-      </p:sp>
-      <p:sp>
-        <p:nvSpPr>
-          <p:cNvPr id="62" name="Text 59"/>
-          <p:cNvSpPr/>
-          <p:nvPr/>
-        </p:nvSpPr>
-        <p:spPr>
-          <a:xfrm>
-            <a:off x="7084568" y="2157984"/>
-            <a:ext cx="778256" cy="969264"/>
-          </a:xfrm>
-          <a:prstGeom prst="rect">
-            <a:avLst/>
-          </a:prstGeom>
-          <a:noFill/>
-          <a:ln/>
-        </p:spPr>
-        <p:txBody>
-          <a:bodyPr wrap="square" lIns="0" tIns="0" rIns="0" bIns="0" rtlCol="0" anchor="ctr"/>
-          <a:lstStyle/>
-          <a:p>
-            <a:pPr algn="l" indent="0" marL="0">
-              <a:lnSpc>
-                <a:spcPct val="105000"/>
-              </a:lnSpc>
-              <a:buNone/>
-            </a:pPr>
-            <a:r>
-              <a:rPr lang="en-US" sz="800" dirty="0">
-                <a:solidFill>
-                  <a:srgbClr val="FFFFFF"/>
-                </a:solidFill>
-                <a:latin typeface="Arial" pitchFamily="34" charset="0"/>
-                <a:ea typeface="Arial" pitchFamily="34" charset="-122"/>
-                <a:cs typeface="Arial" pitchFamily="34" charset="-120"/>
-              </a:rPr>
-              <a:t>Estabilización final de skills</a:t>
-            </a:r>
-            <a:endParaRPr lang="en-US" sz="800" dirty="0"/>
-          </a:p>
-        </p:txBody>
-      </p:sp>
-      <p:sp>
-        <p:nvSpPr>
-          <p:cNvPr id="63" name="Shape 60"/>
-          <p:cNvSpPr/>
-          <p:nvPr/>
-        </p:nvSpPr>
-        <p:spPr>
-          <a:xfrm>
-            <a:off x="7029704" y="3255264"/>
-            <a:ext cx="887984" cy="1078992"/>
-          </a:xfrm>
-          <a:prstGeom prst="roundRect">
-            <a:avLst>
-              <a:gd name="adj" fmla="val 8238"/>
-            </a:avLst>
-          </a:prstGeom>
-          <a:solidFill>
-            <a:srgbClr val="0A1A2E"/>
-          </a:solidFill>
-          <a:ln w="15875">
-            <a:solidFill>
-              <a:srgbClr val="1A2B4A"/>
-            </a:solidFill>
-            <a:prstDash val="solid"/>
-          </a:ln>
-        </p:spPr>
-      </p:sp>
-      <p:sp>
-        <p:nvSpPr>
-          <p:cNvPr id="64" name="Text 61"/>
-          <p:cNvSpPr/>
-          <p:nvPr/>
-        </p:nvSpPr>
-        <p:spPr>
-          <a:xfrm>
-            <a:off x="7084568" y="3310128"/>
-            <a:ext cx="778256" cy="969264"/>
-          </a:xfrm>
-          <a:prstGeom prst="rect">
-            <a:avLst/>
-          </a:prstGeom>
-          <a:noFill/>
-          <a:ln/>
-        </p:spPr>
-        <p:txBody>
-          <a:bodyPr wrap="square" lIns="0" tIns="0" rIns="0" bIns="0" rtlCol="0" anchor="ctr"/>
-          <a:lstStyle/>
-          <a:p>
-            <a:pPr algn="l" indent="0" marL="0">
-              <a:lnSpc>
-                <a:spcPct val="105000"/>
-              </a:lnSpc>
-              <a:buNone/>
-            </a:pPr>
-            <a:r>
-              <a:rPr lang="en-US" sz="800" dirty="0">
-                <a:solidFill>
-                  <a:srgbClr val="FFFFFF"/>
-                </a:solidFill>
-                <a:latin typeface="Arial" pitchFamily="34" charset="0"/>
-                <a:ea typeface="Arial" pitchFamily="34" charset="-122"/>
-                <a:cs typeface="Arial" pitchFamily="34" charset="-120"/>
-              </a:rPr>
-              <a:t>Documentación, onboarding y demo al cliente</a:t>
-            </a:r>
-            <a:endParaRPr lang="en-US" sz="800" dirty="0"/>
-          </a:p>
-        </p:txBody>
-      </p:sp>
-      <p:sp>
-        <p:nvSpPr>
-          <p:cNvPr id="65" name="Shape 62"/>
-          <p:cNvSpPr/>
-          <p:nvPr/>
-        </p:nvSpPr>
-        <p:spPr>
-          <a:xfrm>
-            <a:off x="7981696" y="1645920"/>
-            <a:ext cx="887984" cy="365760"/>
-          </a:xfrm>
-          <a:prstGeom prst="roundRect">
-            <a:avLst>
-              <a:gd name="adj" fmla="val 35000"/>
-            </a:avLst>
-          </a:prstGeom>
-          <a:solidFill>
-            <a:srgbClr val="1A2B4A"/>
-          </a:solidFill>
-          <a:ln w="12700">
-            <a:solidFill>
-              <a:srgbClr val="333333"/>
-            </a:solidFill>
-            <a:prstDash val="solid"/>
-          </a:ln>
-        </p:spPr>
-      </p:sp>
-      <p:sp>
-        <p:nvSpPr>
-          <p:cNvPr id="66" name="Text 63"/>
-          <p:cNvSpPr/>
-          <p:nvPr/>
-        </p:nvSpPr>
-        <p:spPr>
-          <a:xfrm>
-            <a:off x="7981696" y="1645920"/>
-            <a:ext cx="887984" cy="365760"/>
-          </a:xfrm>
-          <a:prstGeom prst="rect">
-            <a:avLst/>
-          </a:prstGeom>
-          <a:noFill/>
-          <a:ln/>
-        </p:spPr>
-        <p:txBody>
-          <a:bodyPr wrap="square" lIns="0" tIns="0" rIns="0" bIns="0" rtlCol="0" anchor="ctr"/>
-          <a:lstStyle/>
-          <a:p>
-            <a:pPr algn="ctr" indent="0" marL="0">
-              <a:lnSpc>
-                <a:spcPct val="100000"/>
-              </a:lnSpc>
-              <a:buNone/>
-            </a:pPr>
-            <a:r>
-              <a:rPr lang="en-US" sz="1000" b="1" dirty="0">
-                <a:solidFill>
-                  <a:srgbClr val="FFFFFF"/>
-                </a:solidFill>
-                <a:latin typeface="Arial" pitchFamily="34" charset="0"/>
-                <a:ea typeface="Arial" pitchFamily="34" charset="-122"/>
-                <a:cs typeface="Arial" pitchFamily="34" charset="-120"/>
-              </a:rPr>
-              <a:t>SEM C
-</a:t>
-            </a:r>
-            <a:pPr algn="ctr" indent="0" marL="0">
-              <a:lnSpc>
-                <a:spcPct val="100000"/>
-              </a:lnSpc>
-              <a:buNone/>
-            </a:pPr>
-            <a:r>
-              <a:rPr lang="en-US" sz="700" dirty="0">
-                <a:solidFill>
-                  <a:srgbClr val="D6D6D6"/>
-                </a:solidFill>
-                <a:latin typeface="Arial" pitchFamily="34" charset="0"/>
-                <a:ea typeface="Arial" pitchFamily="34" charset="-122"/>
-                <a:cs typeface="Arial" pitchFamily="34" charset="-120"/>
-              </a:rPr>
-              <a:t>08–09 oct</a:t>
-            </a:r>
-            <a:endParaRPr lang="en-US" sz="1000" dirty="0"/>
-          </a:p>
-        </p:txBody>
-      </p:sp>
-      <p:sp>
-        <p:nvSpPr>
-          <p:cNvPr id="67" name="Shape 64"/>
-          <p:cNvSpPr/>
-          <p:nvPr/>
-        </p:nvSpPr>
-        <p:spPr>
-          <a:xfrm>
-            <a:off x="7981696" y="2103120"/>
-            <a:ext cx="887984" cy="1078992"/>
-          </a:xfrm>
-          <a:prstGeom prst="roundRect">
-            <a:avLst>
-              <a:gd name="adj" fmla="val 8238"/>
-            </a:avLst>
-          </a:prstGeom>
-          <a:solidFill>
-            <a:srgbClr val="0A1A2E"/>
-          </a:solidFill>
-          <a:ln w="15875">
-            <a:solidFill>
-              <a:srgbClr val="1A2B4A"/>
-            </a:solidFill>
-            <a:prstDash val="solid"/>
-          </a:ln>
-        </p:spPr>
-      </p:sp>
-      <p:sp>
-        <p:nvSpPr>
-          <p:cNvPr id="68" name="Text 65"/>
-          <p:cNvSpPr/>
-          <p:nvPr/>
-        </p:nvSpPr>
-        <p:spPr>
-          <a:xfrm>
-            <a:off x="8036560" y="2157984"/>
-            <a:ext cx="778256" cy="969264"/>
-          </a:xfrm>
-          <a:prstGeom prst="rect">
-            <a:avLst/>
-          </a:prstGeom>
-          <a:noFill/>
-          <a:ln/>
-        </p:spPr>
-        <p:txBody>
-          <a:bodyPr wrap="square" lIns="0" tIns="0" rIns="0" bIns="0" rtlCol="0" anchor="ctr"/>
-          <a:lstStyle/>
-          <a:p>
-            <a:pPr algn="l" indent="0" marL="0">
-              <a:lnSpc>
-                <a:spcPct val="105000"/>
-              </a:lnSpc>
-              <a:buNone/>
-            </a:pPr>
-            <a:r>
-              <a:rPr lang="en-US" sz="800" dirty="0">
-                <a:solidFill>
-                  <a:srgbClr val="FFFFFF"/>
-                </a:solidFill>
-                <a:latin typeface="Arial" pitchFamily="34" charset="0"/>
-                <a:ea typeface="Arial" pitchFamily="34" charset="-122"/>
-                <a:cs typeface="Arial" pitchFamily="34" charset="-120"/>
-              </a:rPr>
-              <a:t>Cierre final de entregables</a:t>
-            </a:r>
-            <a:endParaRPr lang="en-US" sz="800" dirty="0"/>
-          </a:p>
-        </p:txBody>
-      </p:sp>
-      <p:sp>
-        <p:nvSpPr>
-          <p:cNvPr id="69" name="Shape 66"/>
-          <p:cNvSpPr/>
-          <p:nvPr/>
-        </p:nvSpPr>
-        <p:spPr>
-          <a:xfrm>
-            <a:off x="7981696" y="3255264"/>
-            <a:ext cx="887984" cy="1078992"/>
-          </a:xfrm>
-          <a:prstGeom prst="roundRect">
-            <a:avLst>
-              <a:gd name="adj" fmla="val 8238"/>
-            </a:avLst>
-          </a:prstGeom>
-          <a:solidFill>
-            <a:srgbClr val="0A1A2E"/>
-          </a:solidFill>
-          <a:ln w="15875">
-            <a:solidFill>
-              <a:srgbClr val="1A2B4A"/>
-            </a:solidFill>
-            <a:prstDash val="solid"/>
-          </a:ln>
-        </p:spPr>
-      </p:sp>
-      <p:sp>
-        <p:nvSpPr>
-          <p:cNvPr id="70" name="Text 67"/>
-          <p:cNvSpPr/>
-          <p:nvPr/>
-        </p:nvSpPr>
-        <p:spPr>
-          <a:xfrm>
-            <a:off x="8036560" y="3310128"/>
-            <a:ext cx="778256" cy="969264"/>
-          </a:xfrm>
-          <a:prstGeom prst="rect">
-            <a:avLst/>
-          </a:prstGeom>
-          <a:noFill/>
-          <a:ln/>
-        </p:spPr>
-        <p:txBody>
-          <a:bodyPr wrap="square" lIns="0" tIns="0" rIns="0" bIns="0" rtlCol="0" anchor="ctr"/>
-          <a:lstStyle/>
-          <a:p>
-            <a:pPr algn="l" indent="0" marL="0">
-              <a:lnSpc>
-                <a:spcPct val="105000"/>
-              </a:lnSpc>
-              <a:buNone/>
-            </a:pPr>
-            <a:r>
-              <a:rPr lang="en-US" sz="800" dirty="0">
-                <a:solidFill>
-                  <a:srgbClr val="FFFFFF"/>
-                </a:solidFill>
-                <a:latin typeface="Arial" pitchFamily="34" charset="0"/>
-                <a:ea typeface="Arial" pitchFamily="34" charset="-122"/>
-                <a:cs typeface="Arial" pitchFamily="34" charset="-120"/>
-              </a:rPr>
-              <a:t>Traspaso a cargo de Oscar</a:t>
-            </a:r>
-            <a:endParaRPr lang="en-US" sz="800" dirty="0"/>
-          </a:p>
-        </p:txBody>
-      </p:sp>
-      <p:sp>
-        <p:nvSpPr>
-          <p:cNvPr id="71" name="Shape 68"/>
           <p:cNvSpPr/>
           <p:nvPr/>
         </p:nvSpPr>
@@ -10652,7 +10220,7 @@
       </p:sp>
       <p:sp>
         <p:nvSpPr>
-          <p:cNvPr id="72" name="Text 69"/>
+          <p:cNvPr id="60" name="Text 57"/>
           <p:cNvSpPr/>
           <p:nvPr/>
         </p:nvSpPr>
@@ -10691,7 +10259,7 @@
       </p:sp>
       <p:sp>
         <p:nvSpPr>
-          <p:cNvPr id="73" name="Shape 70"/>
+          <p:cNvPr id="61" name="Shape 58"/>
           <p:cNvSpPr/>
           <p:nvPr/>
         </p:nvSpPr>
@@ -10718,7 +10286,7 @@
       </p:sp>
       <p:sp>
         <p:nvSpPr>
-          <p:cNvPr id="74" name="Text 71"/>
+          <p:cNvPr id="62" name="Text 59"/>
           <p:cNvSpPr/>
           <p:nvPr/>
         </p:nvSpPr>
@@ -10757,7 +10325,7 @@
       </p:sp>
       <p:sp>
         <p:nvSpPr>
-          <p:cNvPr id="75" name="Shape 72"/>
+          <p:cNvPr id="63" name="Shape 60"/>
           <p:cNvSpPr/>
           <p:nvPr/>
         </p:nvSpPr>
@@ -10784,7 +10352,7 @@
       </p:sp>
       <p:sp>
         <p:nvSpPr>
-          <p:cNvPr id="76" name="Text 73"/>
+          <p:cNvPr id="64" name="Text 61"/>
           <p:cNvSpPr/>
           <p:nvPr/>
         </p:nvSpPr>
@@ -10823,7 +10391,7 @@
       </p:sp>
       <p:pic>
         <p:nvPicPr>
-          <p:cNvPr id="77" name="Image 1" descr="preencoded.png">    </p:cNvPr>
+          <p:cNvPr id="65" name="Image 1" descr="preencoded.png">    </p:cNvPr>
           <p:cNvPicPr>
             <a:picLocks noChangeAspect="1"/>
           </p:cNvPicPr>
@@ -10847,7 +10415,7 @@
       </p:pic>
       <p:sp>
         <p:nvSpPr>
-          <p:cNvPr id="78" name="Text 74"/>
+          <p:cNvPr id="66" name="Text 62"/>
           <p:cNvSpPr/>
           <p:nvPr/>
         </p:nvSpPr>
@@ -10886,7 +10454,7 @@
       </p:sp>
       <p:sp>
         <p:nvSpPr>
-          <p:cNvPr id="79" name="Text 75"/>
+          <p:cNvPr id="67" name="Text 63"/>
           <p:cNvSpPr/>
           <p:nvPr/>
         </p:nvSpPr>

</xml_diff>

<commit_message>
docs: update executive presentation with revised content and additional insights
</commit_message>
<xml_diff>
--- a/presentations/presentacion-ejecutiva-skills-ia-bcv-resumen.pptx
+++ b/presentations/presentacion-ejecutiva-skills-ia-bcv-resumen.pptx
@@ -4,6 +4,9 @@
   <p:sldMasterIdLst>
     <p:sldMasterId id="2147483648" r:id="rId1"/>
   </p:sldMasterIdLst>
+  <p:notesMasterIdLst>
+    <p:notesMasterId r:id="rId10"/>
+  </p:notesMasterIdLst>
   <p:sldIdLst>
     <p:sldId id="256" r:id="rId2"/>
     <p:sldId id="257" r:id="rId3"/>
@@ -14,10 +17,7 @@
     <p:sldId id="262" r:id="rId8"/>
     <p:sldId id="263" r:id="rId9"/>
   </p:sldIdLst>
-  <p:notesMasterIdLst>
-    <p:notesMasterId r:id="rId10"/>
-  </p:notesMasterIdLst>
-  <p:sldSz cx="9144000" cy="5143500"/>
+  <p:sldSz cx="9144000" cy="5143500" type="screen16x9"/>
   <p:notesSz cx="5143500" cy="9144000"/>
   <p:defaultTextStyle>
     <a:lvl1pPr marL="0" algn="l" defTabSz="914400" rtl="0" eaLnBrk="1" latinLnBrk="0" hangingPunct="1">
@@ -111,13 +111,20 @@
       </a:defRPr>
     </a:lvl9pPr>
   </p:defaultTextStyle>
+  <p:extLst>
+    <p:ext uri="{EFAFB233-063F-42B5-8137-9DF3F51BA10A}">
+      <p15:sldGuideLst xmlns:p15="http://schemas.microsoft.com/office/powerpoint/2012/main"/>
+    </p:ext>
+  </p:extLst>
 </p:presentation>
 </file>
 
 <file path=ppt/charts/chart1.xml><?xml version="1.0" encoding="utf-8"?>
-<c:chartSpace xmlns:c="http://schemas.openxmlformats.org/drawingml/2006/chart" xmlns:a="http://schemas.openxmlformats.org/drawingml/2006/main" xmlns:r="http://schemas.openxmlformats.org/officeDocument/2006/relationships">
+<c:chartSpace xmlns:c="http://schemas.openxmlformats.org/drawingml/2006/chart" xmlns:a="http://schemas.openxmlformats.org/drawingml/2006/main" xmlns:r="http://schemas.openxmlformats.org/officeDocument/2006/relationships" xmlns:c16r2="http://schemas.microsoft.com/office/drawing/2015/06/chart">
   <c:date1904 val="0"/>
+  <c:lang val="es-ES"/>
   <c:roundedCorners val="1"/>
+  <c:style val="2"/>
   <c:chart>
     <c:autoTitleDeleted val="1"/>
     <c:plotArea>
@@ -147,40 +154,15 @@
             <a:effectLst/>
           </c:spPr>
           <c:invertIfNegative val="0"/>
-          <c:dLbls>
-            <c:numFmt formatCode="0&quot;h&quot;" sourceLinked="0"/>
-            <c:txPr>
-              <a:bodyPr/>
-              <a:lstStyle/>
-              <a:p>
-                <a:pPr>
-                  <a:defRPr b="1" i="0" strike="noStrike" sz="950" u="none">
-                    <a:solidFill>
-                      <a:srgbClr val="FFFFFF"/>
-                    </a:solidFill>
-                    <a:latin typeface="Arial"/>
-                  </a:defRPr>
-                </a:pPr>
-              </a:p>
-            </c:txPr>
-            <c:showLegendKey val="0"/>
-            <c:showVal val="1"/>
-            <c:showCatName val="0"/>
-            <c:showSerName val="0"/>
-            <c:showPercent val="0"/>
-            <c:showBubbleSize val="0"/>
-            <c:showLeaderLines val="0"/>
-          </c:dLbls>
           <c:dPt>
             <c:idx val="0"/>
             <c:invertIfNegative val="0"/>
             <c:bubble3D val="0"/>
-            <c:spPr>
-              <a:solidFill>
-                <a:srgbClr val="F96167"/>
-              </a:solidFill>
-              <a:effectLst/>
-            </c:spPr>
+            <c:extLst>
+              <c:ext xmlns:c16="http://schemas.microsoft.com/office/drawing/2014/chart" uri="{C3380CC4-5D6E-409C-BE32-E72D297353CC}">
+                <c16:uniqueId val="{00000001-1758-41F7-B1EF-0B92D542BB5A}"/>
+              </c:ext>
+            </c:extLst>
           </c:dPt>
           <c:dPt>
             <c:idx val="1"/>
@@ -192,6 +174,11 @@
               </a:solidFill>
               <a:effectLst/>
             </c:spPr>
+            <c:extLst>
+              <c:ext xmlns:c16="http://schemas.microsoft.com/office/drawing/2014/chart" uri="{C3380CC4-5D6E-409C-BE32-E72D297353CC}">
+                <c16:uniqueId val="{00000003-1758-41F7-B1EF-0B92D542BB5A}"/>
+              </c:ext>
+            </c:extLst>
           </c:dPt>
           <c:dPt>
             <c:idx val="2"/>
@@ -203,26 +190,66 @@
               </a:solidFill>
               <a:effectLst/>
             </c:spPr>
+            <c:extLst>
+              <c:ext xmlns:c16="http://schemas.microsoft.com/office/drawing/2014/chart" uri="{C3380CC4-5D6E-409C-BE32-E72D297353CC}">
+                <c16:uniqueId val="{00000005-1758-41F7-B1EF-0B92D542BB5A}"/>
+              </c:ext>
+            </c:extLst>
           </c:dPt>
+          <c:dLbls>
+            <c:numFmt formatCode="0&quot;h&quot;" sourceLinked="0"/>
+            <c:spPr>
+              <a:noFill/>
+              <a:ln>
+                <a:noFill/>
+              </a:ln>
+              <a:effectLst/>
+            </c:spPr>
+            <c:txPr>
+              <a:bodyPr/>
+              <a:lstStyle/>
+              <a:p>
+                <a:pPr>
+                  <a:defRPr sz="950" b="1" i="0" u="none" strike="noStrike">
+                    <a:solidFill>
+                      <a:srgbClr val="FFFFFF"/>
+                    </a:solidFill>
+                    <a:latin typeface="Arial"/>
+                  </a:defRPr>
+                </a:pPr>
+                <a:endParaRPr lang="es-PE"/>
+              </a:p>
+            </c:txPr>
+            <c:showLegendKey val="0"/>
+            <c:showVal val="1"/>
+            <c:showCatName val="0"/>
+            <c:showSerName val="0"/>
+            <c:showPercent val="0"/>
+            <c:showBubbleSize val="0"/>
+            <c:showLeaderLines val="0"/>
+            <c:extLst>
+              <c:ext xmlns:c15="http://schemas.microsoft.com/office/drawing/2012/chart" uri="{CE6537A1-D6FC-4f65-9D91-7224C49458BB}">
+                <c15:showLeaderLines val="0"/>
+              </c:ext>
+            </c:extLst>
+          </c:dLbls>
           <c:cat>
-            <c:multiLvlStrRef>
+            <c:strRef>
               <c:f>Sheet1!$A$2:$A$4</c:f>
-              <c:multiLvlStrCache>
+              <c:strCache>
                 <c:ptCount val="3"/>
-                <c:lvl>
-                  <c:pt idx="0">
-                    <c:v>Tradicional</c:v>
-                  </c:pt>
-                  <c:pt idx="1">
-                    <c:v>Copilot</c:v>
-                  </c:pt>
-                  <c:pt idx="2">
-                    <c:v>Skill +
+                <c:pt idx="0">
+                  <c:v>Tradicional</c:v>
+                </c:pt>
+                <c:pt idx="1">
+                  <c:v>Copilot</c:v>
+                </c:pt>
+                <c:pt idx="2">
+                  <c:v>Skill +
 Graphify</c:v>
-                  </c:pt>
-                </c:lvl>
-              </c:multiLvlStrCache>
-            </c:multiLvlStrRef>
+                </c:pt>
+              </c:strCache>
+            </c:strRef>
           </c:cat>
           <c:val>
             <c:numRef>
@@ -242,36 +269,23 @@
               </c:numCache>
             </c:numRef>
           </c:val>
+          <c:extLst>
+            <c:ext xmlns:c16="http://schemas.microsoft.com/office/drawing/2014/chart" uri="{C3380CC4-5D6E-409C-BE32-E72D297353CC}">
+              <c16:uniqueId val="{00000006-1758-41F7-B1EF-0B92D542BB5A}"/>
+            </c:ext>
+          </c:extLst>
         </c:ser>
         <c:dLbls>
-          <c:numFmt formatCode="0&quot;h&quot;" sourceLinked="0"/>
-          <c:txPr>
-            <a:bodyPr/>
-            <a:lstStyle/>
-            <a:p>
-              <a:pPr>
-                <a:defRPr b="1" i="0" strike="noStrike" sz="950" u="none">
-                  <a:solidFill>
-                    <a:srgbClr val="FFFFFF"/>
-                  </a:solidFill>
-                  <a:latin typeface="Arial"/>
-                </a:defRPr>
-              </a:pPr>
-            </a:p>
-          </c:txPr>
           <c:showLegendKey val="0"/>
           <c:showVal val="1"/>
           <c:showCatName val="0"/>
           <c:showSerName val="0"/>
           <c:showPercent val="0"/>
           <c:showBubbleSize val="0"/>
-          <c:showLeaderLines val="0"/>
         </c:dLbls>
         <c:gapWidth val="35"/>
-        <c:overlap val="0"/>
         <c:axId val="2094734554"/>
         <c:axId val="2094734552"/>
-        <c:axId val="2094734556"/>
       </c:barChart>
       <c:catAx>
         <c:axId val="2094734554"/>
@@ -312,6 +326,7 @@
         <c:crosses val="autoZero"/>
         <c:auto val="1"/>
         <c:lblAlgn val="ctr"/>
+        <c:lblOffset val="100"/>
         <c:noMultiLvlLbl val="1"/>
       </c:catAx>
       <c:valAx>
@@ -338,30 +353,6 @@
         <c:majorTickMark val="out"/>
         <c:minorTickMark val="none"/>
         <c:tickLblPos val="nextTo"/>
-        <c:spPr>
-          <a:ln w="12700" cap="flat">
-            <a:solidFill>
-              <a:srgbClr val="888888"/>
-            </a:solidFill>
-            <a:prstDash val="solid"/>
-            <a:round/>
-          </a:ln>
-        </c:spPr>
-        <c:txPr>
-          <a:bodyPr/>
-          <a:lstStyle/>
-          <a:p>
-            <a:pPr>
-              <a:defRPr sz="1200" b="0" i="0" u="none" strike="noStrike">
-                <a:solidFill>
-                  <a:srgbClr val="000000"/>
-                </a:solidFill>
-                <a:latin typeface="Arial"/>
-              </a:defRPr>
-            </a:pPr>
-            <a:endParaRPr lang="en-US"/>
-          </a:p>
-        </c:txPr>
         <c:crossAx val="2094734554"/>
         <c:crosses val="autoZero"/>
         <c:crossBetween val="between"/>
@@ -376,6 +367,7 @@
     </c:plotArea>
     <c:plotVisOnly val="1"/>
     <c:dispBlanksAs val="span"/>
+    <c:showDLblsOverMax val="1"/>
   </c:chart>
   <c:spPr>
     <a:noFill/>
@@ -391,9 +383,11 @@
 </file>
 
 <file path=ppt/charts/chart2.xml><?xml version="1.0" encoding="utf-8"?>
-<c:chartSpace xmlns:c="http://schemas.openxmlformats.org/drawingml/2006/chart" xmlns:a="http://schemas.openxmlformats.org/drawingml/2006/main" xmlns:r="http://schemas.openxmlformats.org/officeDocument/2006/relationships">
+<c:chartSpace xmlns:c="http://schemas.openxmlformats.org/drawingml/2006/chart" xmlns:a="http://schemas.openxmlformats.org/drawingml/2006/main" xmlns:r="http://schemas.openxmlformats.org/officeDocument/2006/relationships" xmlns:c16r2="http://schemas.microsoft.com/office/drawing/2015/06/chart">
   <c:date1904 val="0"/>
+  <c:lang val="es-ES"/>
   <c:roundedCorners val="1"/>
+  <c:style val="2"/>
   <c:chart>
     <c:autoTitleDeleted val="1"/>
     <c:plotArea>
@@ -423,40 +417,15 @@
             <a:effectLst/>
           </c:spPr>
           <c:invertIfNegative val="0"/>
-          <c:dLbls>
-            <c:numFmt formatCode="0&quot;h&quot;" sourceLinked="0"/>
-            <c:txPr>
-              <a:bodyPr/>
-              <a:lstStyle/>
-              <a:p>
-                <a:pPr>
-                  <a:defRPr b="1" i="0" strike="noStrike" sz="950" u="none">
-                    <a:solidFill>
-                      <a:srgbClr val="FFFFFF"/>
-                    </a:solidFill>
-                    <a:latin typeface="Arial"/>
-                  </a:defRPr>
-                </a:pPr>
-              </a:p>
-            </c:txPr>
-            <c:showLegendKey val="0"/>
-            <c:showVal val="1"/>
-            <c:showCatName val="0"/>
-            <c:showSerName val="0"/>
-            <c:showPercent val="0"/>
-            <c:showBubbleSize val="0"/>
-            <c:showLeaderLines val="0"/>
-          </c:dLbls>
           <c:dPt>
             <c:idx val="0"/>
             <c:invertIfNegative val="0"/>
             <c:bubble3D val="0"/>
-            <c:spPr>
-              <a:solidFill>
-                <a:srgbClr val="F96167"/>
-              </a:solidFill>
-              <a:effectLst/>
-            </c:spPr>
+            <c:extLst>
+              <c:ext xmlns:c16="http://schemas.microsoft.com/office/drawing/2014/chart" uri="{C3380CC4-5D6E-409C-BE32-E72D297353CC}">
+                <c16:uniqueId val="{00000001-47FC-4C9D-BF22-473D4480D323}"/>
+              </c:ext>
+            </c:extLst>
           </c:dPt>
           <c:dPt>
             <c:idx val="1"/>
@@ -468,6 +437,11 @@
               </a:solidFill>
               <a:effectLst/>
             </c:spPr>
+            <c:extLst>
+              <c:ext xmlns:c16="http://schemas.microsoft.com/office/drawing/2014/chart" uri="{C3380CC4-5D6E-409C-BE32-E72D297353CC}">
+                <c16:uniqueId val="{00000003-47FC-4C9D-BF22-473D4480D323}"/>
+              </c:ext>
+            </c:extLst>
           </c:dPt>
           <c:dPt>
             <c:idx val="2"/>
@@ -479,26 +453,66 @@
               </a:solidFill>
               <a:effectLst/>
             </c:spPr>
+            <c:extLst>
+              <c:ext xmlns:c16="http://schemas.microsoft.com/office/drawing/2014/chart" uri="{C3380CC4-5D6E-409C-BE32-E72D297353CC}">
+                <c16:uniqueId val="{00000005-47FC-4C9D-BF22-473D4480D323}"/>
+              </c:ext>
+            </c:extLst>
           </c:dPt>
+          <c:dLbls>
+            <c:numFmt formatCode="0&quot;h&quot;" sourceLinked="0"/>
+            <c:spPr>
+              <a:noFill/>
+              <a:ln>
+                <a:noFill/>
+              </a:ln>
+              <a:effectLst/>
+            </c:spPr>
+            <c:txPr>
+              <a:bodyPr/>
+              <a:lstStyle/>
+              <a:p>
+                <a:pPr>
+                  <a:defRPr sz="950" b="1" i="0" u="none" strike="noStrike">
+                    <a:solidFill>
+                      <a:srgbClr val="FFFFFF"/>
+                    </a:solidFill>
+                    <a:latin typeface="Arial"/>
+                  </a:defRPr>
+                </a:pPr>
+                <a:endParaRPr lang="es-PE"/>
+              </a:p>
+            </c:txPr>
+            <c:showLegendKey val="0"/>
+            <c:showVal val="1"/>
+            <c:showCatName val="0"/>
+            <c:showSerName val="0"/>
+            <c:showPercent val="0"/>
+            <c:showBubbleSize val="0"/>
+            <c:showLeaderLines val="0"/>
+            <c:extLst>
+              <c:ext xmlns:c15="http://schemas.microsoft.com/office/drawing/2012/chart" uri="{CE6537A1-D6FC-4f65-9D91-7224C49458BB}">
+                <c15:showLeaderLines val="0"/>
+              </c:ext>
+            </c:extLst>
+          </c:dLbls>
           <c:cat>
-            <c:multiLvlStrRef>
+            <c:strRef>
               <c:f>Sheet1!$A$2:$A$4</c:f>
-              <c:multiLvlStrCache>
+              <c:strCache>
                 <c:ptCount val="3"/>
-                <c:lvl>
-                  <c:pt idx="0">
-                    <c:v>Tradicional</c:v>
-                  </c:pt>
-                  <c:pt idx="1">
-                    <c:v>Copilot</c:v>
-                  </c:pt>
-                  <c:pt idx="2">
-                    <c:v>Skill +
+                <c:pt idx="0">
+                  <c:v>Tradicional</c:v>
+                </c:pt>
+                <c:pt idx="1">
+                  <c:v>Copilot</c:v>
+                </c:pt>
+                <c:pt idx="2">
+                  <c:v>Skill +
 Graphify</c:v>
-                  </c:pt>
-                </c:lvl>
-              </c:multiLvlStrCache>
-            </c:multiLvlStrRef>
+                </c:pt>
+              </c:strCache>
+            </c:strRef>
           </c:cat>
           <c:val>
             <c:numRef>
@@ -518,36 +532,23 @@
               </c:numCache>
             </c:numRef>
           </c:val>
+          <c:extLst>
+            <c:ext xmlns:c16="http://schemas.microsoft.com/office/drawing/2014/chart" uri="{C3380CC4-5D6E-409C-BE32-E72D297353CC}">
+              <c16:uniqueId val="{00000006-47FC-4C9D-BF22-473D4480D323}"/>
+            </c:ext>
+          </c:extLst>
         </c:ser>
         <c:dLbls>
-          <c:numFmt formatCode="0&quot;h&quot;" sourceLinked="0"/>
-          <c:txPr>
-            <a:bodyPr/>
-            <a:lstStyle/>
-            <a:p>
-              <a:pPr>
-                <a:defRPr b="1" i="0" strike="noStrike" sz="950" u="none">
-                  <a:solidFill>
-                    <a:srgbClr val="FFFFFF"/>
-                  </a:solidFill>
-                  <a:latin typeface="Arial"/>
-                </a:defRPr>
-              </a:pPr>
-            </a:p>
-          </c:txPr>
           <c:showLegendKey val="0"/>
           <c:showVal val="1"/>
           <c:showCatName val="0"/>
           <c:showSerName val="0"/>
           <c:showPercent val="0"/>
           <c:showBubbleSize val="0"/>
-          <c:showLeaderLines val="0"/>
         </c:dLbls>
         <c:gapWidth val="35"/>
-        <c:overlap val="0"/>
         <c:axId val="2094734554"/>
         <c:axId val="2094734552"/>
-        <c:axId val="2094734556"/>
       </c:barChart>
       <c:catAx>
         <c:axId val="2094734554"/>
@@ -588,6 +589,7 @@
         <c:crosses val="autoZero"/>
         <c:auto val="1"/>
         <c:lblAlgn val="ctr"/>
+        <c:lblOffset val="100"/>
         <c:noMultiLvlLbl val="1"/>
       </c:catAx>
       <c:valAx>
@@ -614,30 +616,6 @@
         <c:majorTickMark val="out"/>
         <c:minorTickMark val="none"/>
         <c:tickLblPos val="nextTo"/>
-        <c:spPr>
-          <a:ln w="12700" cap="flat">
-            <a:solidFill>
-              <a:srgbClr val="888888"/>
-            </a:solidFill>
-            <a:prstDash val="solid"/>
-            <a:round/>
-          </a:ln>
-        </c:spPr>
-        <c:txPr>
-          <a:bodyPr/>
-          <a:lstStyle/>
-          <a:p>
-            <a:pPr>
-              <a:defRPr sz="1200" b="0" i="0" u="none" strike="noStrike">
-                <a:solidFill>
-                  <a:srgbClr val="000000"/>
-                </a:solidFill>
-                <a:latin typeface="Arial"/>
-              </a:defRPr>
-            </a:pPr>
-            <a:endParaRPr lang="en-US"/>
-          </a:p>
-        </c:txPr>
         <c:crossAx val="2094734554"/>
         <c:crosses val="autoZero"/>
         <c:crossBetween val="between"/>
@@ -652,6 +630,7 @@
     </c:plotArea>
     <c:plotVisOnly val="1"/>
     <c:dispBlanksAs val="span"/>
+    <c:showDLblsOverMax val="1"/>
   </c:chart>
   <c:spPr>
     <a:noFill/>
@@ -688,234 +667,10 @@
           <a:chExt cx="0" cy="0"/>
         </a:xfrm>
       </p:grpSpPr>
-      <p:sp>
-        <p:nvSpPr>
-          <p:cNvPr id="2" name="Header Placeholder 1"/>
-          <p:cNvSpPr>
-            <a:spLocks noGrp="1"/>
-          </p:cNvSpPr>
-          <p:nvPr>
-            <p:ph type="hdr" sz="quarter"/>
-          </p:nvPr>
-        </p:nvSpPr>
-        <p:spPr>
-          <a:xfrm>
-            <a:off x="0" y="0"/>
-            <a:ext cx="2971800" cy="458788"/>
-          </a:xfrm>
-          <a:prstGeom prst="rect">
-            <a:avLst/>
-          </a:prstGeom>
-        </p:spPr>
-        <p:txBody>
-          <a:bodyPr vert="horz" lIns="91440" tIns="45720" rIns="91440" bIns="45720" rtlCol="0"/>
-          <a:lstStyle>
-            <a:lvl1pPr algn="l">
-              <a:defRPr sz="1200"/>
-            </a:lvl1pPr>
-          </a:lstStyle>
-          <a:p>
-            <a:endParaRPr lang="en-US"/>
-          </a:p>
-        </p:txBody>
-      </p:sp>
-      <p:sp>
-        <p:nvSpPr>
-          <p:cNvPr id="3" name="Date Placeholder 2"/>
-          <p:cNvSpPr>
-            <a:spLocks noGrp="1"/>
-          </p:cNvSpPr>
-          <p:nvPr>
-            <p:ph type="dt" idx="1"/>
-          </p:nvPr>
-        </p:nvSpPr>
-        <p:spPr>
-          <a:xfrm>
-            <a:off x="3884613" y="0"/>
-            <a:ext cx="2971800" cy="458788"/>
-          </a:xfrm>
-          <a:prstGeom prst="rect">
-            <a:avLst/>
-          </a:prstGeom>
-        </p:spPr>
-        <p:txBody>
-          <a:bodyPr vert="horz" lIns="91440" tIns="45720" rIns="91440" bIns="45720" rtlCol="0"/>
-          <a:lstStyle>
-            <a:lvl1pPr algn="r">
-              <a:defRPr sz="1200"/>
-            </a:lvl1pPr>
-          </a:lstStyle>
-          <a:p>
-            <a:fld id="{5282F153-3F37-0F45-9E97-73ACFA13230C}" type="datetimeFigureOut">
-              <a:rPr lang="en-US"/>
-              <a:t>7/23/19</a:t>
-            </a:fld>
-            <a:endParaRPr lang="en-US"/>
-          </a:p>
-        </p:txBody>
-      </p:sp>
-      <p:sp>
-        <p:nvSpPr>
-          <p:cNvPr id="4" name="Slide Image Placeholder 3"/>
-          <p:cNvSpPr>
-            <a:spLocks noGrp="1" noRot="1" noChangeAspect="1"/>
-          </p:cNvSpPr>
-          <p:nvPr>
-            <p:ph type="sldImg" idx="2"/>
-          </p:nvPr>
-        </p:nvSpPr>
-        <p:spPr>
-          <a:xfrm>
-            <a:off x="685800" y="1143000"/>
-            <a:ext cx="5486400" cy="3086100"/>
-          </a:xfrm>
-          <a:prstGeom prst="rect">
-            <a:avLst/>
-          </a:prstGeom>
-          <a:noFill/>
-          <a:ln w="12700">
-            <a:solidFill>
-              <a:prstClr val="black"/>
-            </a:solidFill>
-          </a:ln>
-        </p:spPr>
-        <p:txBody>
-          <a:bodyPr vert="horz" lIns="91440" tIns="45720" rIns="91440" bIns="45720" rtlCol="0" anchor="ctr"/>
-          <a:lstStyle/>
-          <a:p>
-            <a:endParaRPr lang="en-US"/>
-          </a:p>
-        </p:txBody>
-      </p:sp>
-      <p:sp>
-        <p:nvSpPr>
-          <p:cNvPr id="5" name="Notes Placeholder 4"/>
-          <p:cNvSpPr>
-            <a:spLocks noGrp="1"/>
-          </p:cNvSpPr>
-          <p:nvPr>
-            <p:ph type="body" sz="quarter" idx="3"/>
-          </p:nvPr>
-        </p:nvSpPr>
-        <p:spPr>
-          <a:xfrm>
-            <a:off x="685800" y="4400550"/>
-            <a:ext cx="5486400" cy="3600450"/>
-          </a:xfrm>
-          <a:prstGeom prst="rect">
-            <a:avLst/>
-          </a:prstGeom>
-        </p:spPr>
-        <p:txBody>
-          <a:bodyPr vert="horz" lIns="91440" tIns="45720" rIns="91440" bIns="45720" rtlCol="0"/>
-          <a:lstStyle/>
-          <a:p>
-            <a:pPr lvl="0"/>
-            <a:r>
-              <a:rPr lang="en-US"/>
-              <a:t>Click to edit Master text styles</a:t>
-            </a:r>
-          </a:p>
-          <a:p>
-            <a:pPr lvl="1"/>
-            <a:r>
-              <a:rPr lang="en-US"/>
-              <a:t>Second level</a:t>
-            </a:r>
-          </a:p>
-          <a:p>
-            <a:pPr lvl="2"/>
-            <a:r>
-              <a:rPr lang="en-US"/>
-              <a:t>Third level</a:t>
-            </a:r>
-          </a:p>
-          <a:p>
-            <a:pPr lvl="3"/>
-            <a:r>
-              <a:rPr lang="en-US"/>
-              <a:t>Fourth level</a:t>
-            </a:r>
-          </a:p>
-          <a:p>
-            <a:pPr lvl="4"/>
-            <a:r>
-              <a:rPr lang="en-US"/>
-              <a:t>Fifth level</a:t>
-            </a:r>
-          </a:p>
-        </p:txBody>
-      </p:sp>
-      <p:sp>
-        <p:nvSpPr>
-          <p:cNvPr id="6" name="Footer Placeholder 5"/>
-          <p:cNvSpPr>
-            <a:spLocks noGrp="1"/>
-          </p:cNvSpPr>
-          <p:nvPr>
-            <p:ph type="ftr" sz="quarter" idx="4"/>
-          </p:nvPr>
-        </p:nvSpPr>
-        <p:spPr>
-          <a:xfrm>
-            <a:off x="0" y="8685213"/>
-            <a:ext cx="2971800" cy="458787"/>
-          </a:xfrm>
-          <a:prstGeom prst="rect">
-            <a:avLst/>
-          </a:prstGeom>
-        </p:spPr>
-        <p:txBody>
-          <a:bodyPr vert="horz" lIns="91440" tIns="45720" rIns="91440" bIns="45720" rtlCol="0" anchor="b"/>
-          <a:lstStyle>
-            <a:lvl1pPr algn="l">
-              <a:defRPr sz="1200"/>
-            </a:lvl1pPr>
-          </a:lstStyle>
-          <a:p>
-            <a:endParaRPr lang="en-US"/>
-          </a:p>
-        </p:txBody>
-      </p:sp>
-      <p:sp>
-        <p:nvSpPr>
-          <p:cNvPr id="7" name="Slide Number Placeholder 6"/>
-          <p:cNvSpPr>
-            <a:spLocks noGrp="1"/>
-          </p:cNvSpPr>
-          <p:nvPr>
-            <p:ph type="sldNum" sz="quarter" idx="5"/>
-          </p:nvPr>
-        </p:nvSpPr>
-        <p:spPr>
-          <a:xfrm>
-            <a:off x="3884613" y="8685213"/>
-            <a:ext cx="2971800" cy="458787"/>
-          </a:xfrm>
-          <a:prstGeom prst="rect">
-            <a:avLst/>
-          </a:prstGeom>
-        </p:spPr>
-        <p:txBody>
-          <a:bodyPr vert="horz" lIns="91440" tIns="45720" rIns="91440" bIns="45720" rtlCol="0" anchor="b"/>
-          <a:lstStyle>
-            <a:lvl1pPr algn="r">
-              <a:defRPr sz="1200"/>
-            </a:lvl1pPr>
-          </a:lstStyle>
-          <a:p>
-            <a:fld id="{CE5E9CC1-C706-0F49-92D6-E571CC5EEA8F}" type="slidenum">
-              <a:rPr lang="en-US"/>
-              <a:t>‹#›</a:t>
-            </a:fld>
-            <a:endParaRPr lang="en-US"/>
-          </a:p>
-        </p:txBody>
-      </p:sp>
     </p:spTree>
     <p:extLst>
       <p:ext uri="{BB962C8B-B14F-4D97-AF65-F5344CB8AC3E}">
-        <p14:creationId xmlns:p14="http://schemas.microsoft.com/office/powerpoint/2010/main" val="1024086991"/>
+        <p14:creationId xmlns:p14="http://schemas.microsoft.com/office/powerpoint/2010/main" val="3561504972"/>
       </p:ext>
     </p:extLst>
   </p:cSld>
@@ -1059,10 +814,6 @@
           <a:bodyPr/>
           <a:lstStyle/>
           <a:p>
-            <a:r>
-              <a:rPr lang="en-US" dirty="0"/>
-              <a:t/>
-            </a:r>
             <a:endParaRPr lang="en-US" dirty="0"/>
           </a:p>
         </p:txBody>
@@ -1147,10 +898,6 @@
           <a:bodyPr/>
           <a:lstStyle/>
           <a:p>
-            <a:r>
-              <a:rPr lang="en-US" dirty="0"/>
-              <a:t/>
-            </a:r>
             <a:endParaRPr lang="en-US" dirty="0"/>
           </a:p>
         </p:txBody>
@@ -1235,10 +982,6 @@
           <a:bodyPr/>
           <a:lstStyle/>
           <a:p>
-            <a:r>
-              <a:rPr lang="en-US" dirty="0"/>
-              <a:t/>
-            </a:r>
             <a:endParaRPr lang="en-US" dirty="0"/>
           </a:p>
         </p:txBody>
@@ -1323,10 +1066,6 @@
           <a:bodyPr/>
           <a:lstStyle/>
           <a:p>
-            <a:r>
-              <a:rPr lang="en-US" dirty="0"/>
-              <a:t/>
-            </a:r>
             <a:endParaRPr lang="en-US" dirty="0"/>
           </a:p>
         </p:txBody>
@@ -1411,10 +1150,6 @@
           <a:bodyPr/>
           <a:lstStyle/>
           <a:p>
-            <a:r>
-              <a:rPr lang="en-US" dirty="0"/>
-              <a:t/>
-            </a:r>
             <a:endParaRPr lang="en-US" dirty="0"/>
           </a:p>
         </p:txBody>
@@ -1499,10 +1234,6 @@
           <a:bodyPr/>
           <a:lstStyle/>
           <a:p>
-            <a:r>
-              <a:rPr lang="en-US" dirty="0"/>
-              <a:t/>
-            </a:r>
             <a:endParaRPr lang="en-US" dirty="0"/>
           </a:p>
         </p:txBody>
@@ -1587,10 +1318,6 @@
           <a:bodyPr/>
           <a:lstStyle/>
           <a:p>
-            <a:r>
-              <a:rPr lang="en-US" dirty="0"/>
-              <a:t/>
-            </a:r>
             <a:endParaRPr lang="en-US" dirty="0"/>
           </a:p>
         </p:txBody>
@@ -1675,10 +1402,6 @@
           <a:bodyPr/>
           <a:lstStyle/>
           <a:p>
-            <a:r>
-              <a:rPr lang="en-US" dirty="0"/>
-              <a:t/>
-            </a:r>
             <a:endParaRPr lang="en-US" dirty="0"/>
           </a:p>
         </p:txBody>
@@ -1752,6 +1475,11 @@
 <file path=ppt/slideMasters/slideMaster1.xml><?xml version="1.0" encoding="utf-8"?>
 <p:sldMaster xmlns:a="http://schemas.openxmlformats.org/drawingml/2006/main" xmlns:r="http://schemas.openxmlformats.org/officeDocument/2006/relationships" xmlns:p="http://schemas.openxmlformats.org/presentationml/2006/main">
   <p:cSld>
+    <p:bg>
+      <p:bgRef idx="1001">
+        <a:schemeClr val="bg1"/>
+      </p:bgRef>
+    </p:bg>
     <p:spTree>
       <p:nvGrpSpPr>
         <p:cNvPr id="1" name=""/>
@@ -2034,6 +1762,7 @@
         <a:solidFill>
           <a:srgbClr val="070F26"/>
         </a:solidFill>
+        <a:effectLst/>
       </p:bgPr>
     </p:bg>
     <p:spTree>
@@ -2052,14 +1781,14 @@
       </p:grpSpPr>
       <p:pic>
         <p:nvPicPr>
-          <p:cNvPr id="2" name="Image 0" descr="preencoded.png">    </p:cNvPr>
+          <p:cNvPr id="2" name="Image 0" descr="preencoded.png"/>
           <p:cNvPicPr>
             <a:picLocks noChangeAspect="1"/>
           </p:cNvPicPr>
           <p:nvPr/>
         </p:nvPicPr>
         <p:blipFill>
-          <a:blip r:embed="rId1"/>
+          <a:blip r:embed="rId3"/>
           <a:stretch>
             <a:fillRect/>
           </a:stretch>
@@ -2095,7 +1824,7 @@
           <a:bodyPr wrap="square" lIns="0" tIns="0" rIns="0" bIns="0" rtlCol="0" anchor="ctr"/>
           <a:lstStyle/>
           <a:p>
-            <a:pPr algn="l" indent="0" marL="0">
+            <a:pPr marL="0" indent="0" algn="l">
               <a:buNone/>
             </a:pPr>
             <a:r>
@@ -2112,7 +1841,7 @@
             <a:endParaRPr lang="en-US" sz="4000" dirty="0"/>
           </a:p>
           <a:p>
-            <a:pPr algn="l" indent="0" marL="0">
+            <a:pPr marL="0" indent="0" algn="l">
               <a:buNone/>
             </a:pPr>
             <a:r>
@@ -2151,7 +1880,7 @@
           <a:bodyPr wrap="square" lIns="0" tIns="0" rIns="0" bIns="0" rtlCol="0" anchor="ctr"/>
           <a:lstStyle/>
           <a:p>
-            <a:pPr algn="l" indent="0" marL="0">
+            <a:pPr marL="0" indent="0" algn="l">
               <a:buNone/>
             </a:pPr>
             <a:r>
@@ -2195,6 +1924,13 @@
             <a:prstDash val="solid"/>
           </a:ln>
         </p:spPr>
+        <p:txBody>
+          <a:bodyPr/>
+          <a:lstStyle/>
+          <a:p>
+            <a:endParaRPr lang="es-PE"/>
+          </a:p>
+        </p:txBody>
       </p:sp>
       <p:sp>
         <p:nvSpPr>
@@ -2217,7 +1953,7 @@
           <a:bodyPr wrap="square" lIns="0" tIns="0" rIns="0" bIns="0" rtlCol="0" anchor="ctr"/>
           <a:lstStyle/>
           <a:p>
-            <a:pPr algn="l" indent="0" marL="0">
+            <a:pPr marL="0" indent="0" algn="l">
               <a:lnSpc>
                 <a:spcPct val="125000"/>
               </a:lnSpc>
@@ -2237,7 +1973,7 @@
             <a:endParaRPr lang="en-US" sz="1150" dirty="0"/>
           </a:p>
           <a:p>
-            <a:pPr algn="l" indent="0" marL="0">
+            <a:pPr marL="0" indent="0" algn="l">
               <a:lnSpc>
                 <a:spcPct val="125000"/>
               </a:lnSpc>
@@ -2257,7 +1993,7 @@
             <a:endParaRPr lang="en-US" sz="1150" dirty="0"/>
           </a:p>
           <a:p>
-            <a:pPr algn="l" indent="0" marL="0">
+            <a:pPr marL="0" indent="0" algn="l">
               <a:lnSpc>
                 <a:spcPct val="125000"/>
               </a:lnSpc>
@@ -2304,6 +2040,13 @@
             <a:prstDash val="solid"/>
           </a:ln>
         </p:spPr>
+        <p:txBody>
+          <a:bodyPr/>
+          <a:lstStyle/>
+          <a:p>
+            <a:endParaRPr lang="es-PE"/>
+          </a:p>
+        </p:txBody>
       </p:sp>
       <p:sp>
         <p:nvSpPr>
@@ -2331,17 +2074,24 @@
             <a:prstDash val="solid"/>
           </a:ln>
         </p:spPr>
+        <p:txBody>
+          <a:bodyPr/>
+          <a:lstStyle/>
+          <a:p>
+            <a:endParaRPr lang="es-PE"/>
+          </a:p>
+        </p:txBody>
       </p:sp>
       <p:pic>
         <p:nvPicPr>
-          <p:cNvPr id="9" name="Image 1" descr="preencoded.png">    </p:cNvPr>
+          <p:cNvPr id="9" name="Image 1" descr="preencoded.png"/>
           <p:cNvPicPr>
             <a:picLocks noChangeAspect="1"/>
           </p:cNvPicPr>
           <p:nvPr/>
         </p:nvPicPr>
         <p:blipFill>
-          <a:blip r:embed="rId2"/>
+          <a:blip r:embed="rId3"/>
           <a:stretch>
             <a:fillRect/>
           </a:stretch>
@@ -2377,7 +2127,7 @@
           <a:bodyPr wrap="square" lIns="0" tIns="0" rIns="0" bIns="0" rtlCol="0" anchor="ctr"/>
           <a:lstStyle/>
           <a:p>
-            <a:pPr indent="0" marL="0">
+            <a:pPr marL="0" indent="0">
               <a:buNone/>
             </a:pPr>
             <a:r>
@@ -2416,7 +2166,7 @@
           <a:bodyPr wrap="square" lIns="0" tIns="0" rIns="0" bIns="0" rtlCol="0" anchor="ctr"/>
           <a:lstStyle/>
           <a:p>
-            <a:pPr algn="r" indent="0" marL="0">
+            <a:pPr marL="0" indent="0" algn="r">
               <a:buNone/>
             </a:pPr>
             <a:r>
@@ -2450,6 +2200,7 @@
         <a:solidFill>
           <a:srgbClr val="070F26"/>
         </a:solidFill>
+        <a:effectLst/>
       </p:bgPr>
     </p:bg>
     <p:spTree>
@@ -2468,14 +2219,14 @@
       </p:grpSpPr>
       <p:pic>
         <p:nvPicPr>
-          <p:cNvPr id="2" name="Image 0" descr="preencoded.png">    </p:cNvPr>
+          <p:cNvPr id="2" name="Image 0" descr="preencoded.png"/>
           <p:cNvPicPr>
             <a:picLocks noChangeAspect="1"/>
           </p:cNvPicPr>
           <p:nvPr/>
         </p:nvPicPr>
         <p:blipFill>
-          <a:blip r:embed="rId1"/>
+          <a:blip r:embed="rId3"/>
           <a:stretch>
             <a:fillRect/>
           </a:stretch>
@@ -2513,7 +2264,7 @@
           </a:bodyPr>
           <a:lstStyle/>
           <a:p>
-            <a:pPr algn="l" indent="0" marL="0">
+            <a:pPr marL="0" indent="0" algn="l">
               <a:buNone/>
             </a:pPr>
             <a:r>
@@ -2555,6 +2306,13 @@
             <a:prstDash val="solid"/>
           </a:ln>
         </p:spPr>
+        <p:txBody>
+          <a:bodyPr/>
+          <a:lstStyle/>
+          <a:p>
+            <a:endParaRPr lang="es-PE"/>
+          </a:p>
+        </p:txBody>
       </p:sp>
       <p:sp>
         <p:nvSpPr>
@@ -2582,6 +2340,13 @@
             <a:prstDash val="solid"/>
           </a:ln>
         </p:spPr>
+        <p:txBody>
+          <a:bodyPr/>
+          <a:lstStyle/>
+          <a:p>
+            <a:endParaRPr lang="es-PE"/>
+          </a:p>
+        </p:txBody>
       </p:sp>
       <p:sp>
         <p:nvSpPr>
@@ -2604,7 +2369,7 @@
           <a:bodyPr wrap="square" lIns="0" tIns="0" rIns="0" bIns="0" rtlCol="0" anchor="ctr"/>
           <a:lstStyle/>
           <a:p>
-            <a:pPr algn="ctr" indent="0" marL="0">
+            <a:pPr marL="0" indent="0" algn="ctr">
               <a:buNone/>
             </a:pPr>
             <a:r>
@@ -2643,7 +2408,7 @@
           <a:bodyPr wrap="square" lIns="381" tIns="381" rIns="381" bIns="381" rtlCol="0" anchor="ctr"/>
           <a:lstStyle/>
           <a:p>
-            <a:pPr algn="ctr" indent="0" marL="0">
+            <a:pPr marL="0" indent="0" algn="ctr">
               <a:buNone/>
             </a:pPr>
             <a:r>
@@ -2687,6 +2452,13 @@
             <a:prstDash val="solid"/>
           </a:ln>
         </p:spPr>
+        <p:txBody>
+          <a:bodyPr/>
+          <a:lstStyle/>
+          <a:p>
+            <a:endParaRPr lang="es-PE"/>
+          </a:p>
+        </p:txBody>
       </p:sp>
       <p:sp>
         <p:nvSpPr>
@@ -2709,7 +2481,7 @@
           <a:bodyPr wrap="square" lIns="0" tIns="0" rIns="0" bIns="0" rtlCol="0" anchor="ctr"/>
           <a:lstStyle/>
           <a:p>
-            <a:pPr algn="ctr" indent="0" marL="0">
+            <a:pPr marL="0" indent="0" algn="ctr">
               <a:buNone/>
             </a:pPr>
             <a:r>
@@ -2748,7 +2520,7 @@
           <a:bodyPr wrap="square" lIns="381" tIns="381" rIns="381" bIns="381" rtlCol="0" anchor="ctr"/>
           <a:lstStyle/>
           <a:p>
-            <a:pPr algn="ctr" indent="0" marL="0">
+            <a:pPr marL="0" indent="0" algn="ctr">
               <a:buNone/>
             </a:pPr>
             <a:r>
@@ -2792,6 +2564,13 @@
             <a:prstDash val="solid"/>
           </a:ln>
         </p:spPr>
+        <p:txBody>
+          <a:bodyPr/>
+          <a:lstStyle/>
+          <a:p>
+            <a:endParaRPr lang="es-PE"/>
+          </a:p>
+        </p:txBody>
       </p:sp>
       <p:sp>
         <p:nvSpPr>
@@ -2814,7 +2593,7 @@
           <a:bodyPr wrap="square" lIns="0" tIns="0" rIns="0" bIns="0" rtlCol="0" anchor="ctr"/>
           <a:lstStyle/>
           <a:p>
-            <a:pPr algn="ctr" indent="0" marL="0">
+            <a:pPr marL="0" indent="0" algn="ctr">
               <a:buNone/>
             </a:pPr>
             <a:r>
@@ -2853,7 +2632,7 @@
           <a:bodyPr wrap="square" lIns="381" tIns="381" rIns="381" bIns="381" rtlCol="0" anchor="ctr"/>
           <a:lstStyle/>
           <a:p>
-            <a:pPr algn="ctr" indent="0" marL="0">
+            <a:pPr marL="0" indent="0" algn="ctr">
               <a:buNone/>
             </a:pPr>
             <a:r>
@@ -2897,6 +2676,13 @@
             <a:prstDash val="solid"/>
           </a:ln>
         </p:spPr>
+        <p:txBody>
+          <a:bodyPr/>
+          <a:lstStyle/>
+          <a:p>
+            <a:endParaRPr lang="es-PE"/>
+          </a:p>
+        </p:txBody>
       </p:sp>
       <p:sp>
         <p:nvSpPr>
@@ -2919,7 +2705,7 @@
           <a:bodyPr wrap="square" lIns="0" tIns="0" rIns="0" bIns="0" rtlCol="0" anchor="ctr"/>
           <a:lstStyle/>
           <a:p>
-            <a:pPr algn="ctr" indent="0" marL="0">
+            <a:pPr marL="0" indent="0" algn="ctr">
               <a:buNone/>
             </a:pPr>
             <a:r>
@@ -2958,7 +2744,7 @@
           <a:bodyPr wrap="square" lIns="381" tIns="381" rIns="381" bIns="381" rtlCol="0" anchor="ctr"/>
           <a:lstStyle/>
           <a:p>
-            <a:pPr algn="ctr" indent="0" marL="0">
+            <a:pPr marL="0" indent="0" algn="ctr">
               <a:buNone/>
             </a:pPr>
             <a:r>
@@ -3002,6 +2788,13 @@
             <a:prstDash val="solid"/>
           </a:ln>
         </p:spPr>
+        <p:txBody>
+          <a:bodyPr/>
+          <a:lstStyle/>
+          <a:p>
+            <a:endParaRPr lang="es-PE"/>
+          </a:p>
+        </p:txBody>
       </p:sp>
       <p:sp>
         <p:nvSpPr>
@@ -3024,7 +2817,7 @@
           <a:bodyPr wrap="square" lIns="0" tIns="0" rIns="0" bIns="0" rtlCol="0" anchor="ctr"/>
           <a:lstStyle/>
           <a:p>
-            <a:pPr algn="l" indent="0" marL="0">
+            <a:pPr marL="0" indent="0" algn="l">
               <a:buNone/>
             </a:pPr>
             <a:r>
@@ -3063,7 +2856,7 @@
           <a:bodyPr wrap="square" lIns="381" tIns="381" rIns="381" bIns="381" rtlCol="0" anchor="ctr"/>
           <a:lstStyle/>
           <a:p>
-            <a:pPr algn="l" indent="0" marL="0">
+            <a:pPr marL="0" indent="0" algn="l">
               <a:lnSpc>
                 <a:spcPct val="130000"/>
               </a:lnSpc>
@@ -3086,14 +2879,14 @@
       </p:sp>
       <p:pic>
         <p:nvPicPr>
-          <p:cNvPr id="20" name="Image 1" descr="preencoded.png">    </p:cNvPr>
+          <p:cNvPr id="20" name="Image 1" descr="preencoded.png"/>
           <p:cNvPicPr>
             <a:picLocks noChangeAspect="1"/>
           </p:cNvPicPr>
           <p:nvPr/>
         </p:nvPicPr>
         <p:blipFill>
-          <a:blip r:embed="rId2"/>
+          <a:blip r:embed="rId3"/>
           <a:stretch>
             <a:fillRect/>
           </a:stretch>
@@ -3129,7 +2922,7 @@
           <a:bodyPr wrap="square" lIns="0" tIns="0" rIns="0" bIns="0" rtlCol="0" anchor="ctr"/>
           <a:lstStyle/>
           <a:p>
-            <a:pPr indent="0" marL="0">
+            <a:pPr marL="0" indent="0">
               <a:buNone/>
             </a:pPr>
             <a:r>
@@ -3168,7 +2961,7 @@
           <a:bodyPr wrap="square" lIns="0" tIns="0" rIns="0" bIns="0" rtlCol="0" anchor="ctr"/>
           <a:lstStyle/>
           <a:p>
-            <a:pPr algn="r" indent="0" marL="0">
+            <a:pPr marL="0" indent="0" algn="r">
               <a:buNone/>
             </a:pPr>
             <a:r>
@@ -3202,6 +2995,7 @@
         <a:solidFill>
           <a:srgbClr val="070F26"/>
         </a:solidFill>
+        <a:effectLst/>
       </p:bgPr>
     </p:bg>
     <p:spTree>
@@ -3220,14 +3014,14 @@
       </p:grpSpPr>
       <p:pic>
         <p:nvPicPr>
-          <p:cNvPr id="2" name="Image 0" descr="preencoded.png">    </p:cNvPr>
+          <p:cNvPr id="2" name="Image 0" descr="preencoded.png"/>
           <p:cNvPicPr>
             <a:picLocks noChangeAspect="1"/>
           </p:cNvPicPr>
           <p:nvPr/>
         </p:nvPicPr>
         <p:blipFill>
-          <a:blip r:embed="rId1"/>
+          <a:blip r:embed="rId3"/>
           <a:stretch>
             <a:fillRect/>
           </a:stretch>
@@ -3265,7 +3059,7 @@
           </a:bodyPr>
           <a:lstStyle/>
           <a:p>
-            <a:pPr algn="l" indent="0" marL="0">
+            <a:pPr marL="0" indent="0" algn="l">
               <a:buNone/>
             </a:pPr>
             <a:r>
@@ -3307,6 +3101,13 @@
             <a:prstDash val="solid"/>
           </a:ln>
         </p:spPr>
+        <p:txBody>
+          <a:bodyPr/>
+          <a:lstStyle/>
+          <a:p>
+            <a:endParaRPr lang="es-PE"/>
+          </a:p>
+        </p:txBody>
       </p:sp>
       <p:sp>
         <p:nvSpPr>
@@ -3329,7 +3130,7 @@
           <a:bodyPr wrap="square" lIns="381" tIns="381" rIns="381" bIns="381" rtlCol="0" anchor="ctr"/>
           <a:lstStyle/>
           <a:p>
-            <a:pPr algn="l" indent="0" marL="0">
+            <a:pPr marL="0" indent="0" algn="l">
               <a:buNone/>
             </a:pPr>
             <a:r>
@@ -3373,6 +3174,13 @@
             <a:prstDash val="solid"/>
           </a:ln>
         </p:spPr>
+        <p:txBody>
+          <a:bodyPr/>
+          <a:lstStyle/>
+          <a:p>
+            <a:endParaRPr lang="es-PE"/>
+          </a:p>
+        </p:txBody>
       </p:sp>
       <p:sp>
         <p:nvSpPr>
@@ -3395,7 +3203,7 @@
           <a:bodyPr wrap="square" lIns="0" tIns="0" rIns="0" bIns="0" rtlCol="0" anchor="ctr"/>
           <a:lstStyle/>
           <a:p>
-            <a:pPr algn="l" indent="0" marL="0">
+            <a:pPr marL="0" indent="0" algn="l">
               <a:buNone/>
             </a:pPr>
             <a:r>
@@ -3434,7 +3242,7 @@
           <a:bodyPr wrap="square" lIns="381" tIns="381" rIns="381" bIns="381" rtlCol="0" anchor="ctr"/>
           <a:lstStyle/>
           <a:p>
-            <a:pPr algn="l" indent="0" marL="0">
+            <a:pPr marL="0" indent="0" algn="l">
               <a:lnSpc>
                 <a:spcPct val="112000"/>
               </a:lnSpc>
@@ -3481,6 +3289,13 @@
             <a:prstDash val="solid"/>
           </a:ln>
         </p:spPr>
+        <p:txBody>
+          <a:bodyPr/>
+          <a:lstStyle/>
+          <a:p>
+            <a:endParaRPr lang="es-PE"/>
+          </a:p>
+        </p:txBody>
       </p:sp>
       <p:sp>
         <p:nvSpPr>
@@ -3503,7 +3318,7 @@
           <a:bodyPr wrap="square" lIns="0" tIns="0" rIns="0" bIns="0" rtlCol="0" anchor="ctr"/>
           <a:lstStyle/>
           <a:p>
-            <a:pPr algn="l" indent="0" marL="0">
+            <a:pPr marL="0" indent="0" algn="l">
               <a:buNone/>
             </a:pPr>
             <a:r>
@@ -3542,7 +3357,7 @@
           <a:bodyPr wrap="square" lIns="381" tIns="381" rIns="381" bIns="381" rtlCol="0" anchor="ctr"/>
           <a:lstStyle/>
           <a:p>
-            <a:pPr algn="l" indent="0" marL="0">
+            <a:pPr marL="0" indent="0" algn="l">
               <a:lnSpc>
                 <a:spcPct val="112000"/>
               </a:lnSpc>
@@ -3565,7 +3380,7 @@
       </p:sp>
       <p:graphicFrame>
         <p:nvGraphicFramePr>
-          <p:cNvPr id="4" name="Table 0"/>
+          <p:cNvPr id="12" name="Table 0"/>
           <p:cNvGraphicFramePr>
             <a:graphicFrameLocks noGrp="1"/>
           </p:cNvGraphicFramePr>
@@ -3579,15 +3394,27 @@
         </p:nvGraphicFramePr>
         <p:xfrm>
           <a:off x="365760" y="2880360"/>
-          <a:ext cx="8503920" cy="914400"/>
+          <a:ext cx="8503920" cy="1353312"/>
         </p:xfrm>
         <a:graphic>
           <a:graphicData uri="http://schemas.openxmlformats.org/drawingml/2006/table">
             <a:tbl>
               <a:tblPr/>
               <a:tblGrid>
-                <a:gridCol w="2377440"/>
-                <a:gridCol w="6126480"/>
+                <a:gridCol w="2377440">
+                  <a:extLst>
+                    <a:ext uri="{9D8B030D-6E8A-4147-A177-3AD203B41FA5}">
+                      <a16:colId xmlns:a16="http://schemas.microsoft.com/office/drawing/2014/main" val="20000"/>
+                    </a:ext>
+                  </a:extLst>
+                </a:gridCol>
+                <a:gridCol w="6126480">
+                  <a:extLst>
+                    <a:ext uri="{9D8B030D-6E8A-4147-A177-3AD203B41FA5}">
+                      <a16:colId xmlns:a16="http://schemas.microsoft.com/office/drawing/2014/main" val="20001"/>
+                    </a:ext>
+                  </a:extLst>
+                </a:gridCol>
               </a:tblGrid>
               <a:tr h="0">
                 <a:tc>
@@ -3595,7 +3422,7 @@
                     <a:bodyPr/>
                     <a:lstStyle/>
                     <a:p>
-                      <a:pPr algn="ctr" indent="0" marL="0">
+                      <a:pPr marL="0" indent="0" algn="ctr">
                         <a:buNone/>
                       </a:pPr>
                       <a:r>
@@ -3663,7 +3490,7 @@
                     <a:bodyPr/>
                     <a:lstStyle/>
                     <a:p>
-                      <a:pPr algn="ctr" indent="0" marL="0">
+                      <a:pPr marL="0" indent="0" algn="ctr">
                         <a:buNone/>
                       </a:pPr>
                       <a:r>
@@ -3726,6 +3553,11 @@
                     </a:solidFill>
                   </a:tcPr>
                 </a:tc>
+                <a:extLst>
+                  <a:ext uri="{0D108BD9-81ED-4DB2-BD59-A6C34878D82A}">
+                    <a16:rowId xmlns:a16="http://schemas.microsoft.com/office/drawing/2014/main" val="10000"/>
+                  </a:ext>
+                </a:extLst>
               </a:tr>
               <a:tr h="0">
                 <a:tc>
@@ -3733,7 +3565,7 @@
                     <a:bodyPr/>
                     <a:lstStyle/>
                     <a:p>
-                      <a:pPr algn="l" indent="0" marL="0">
+                      <a:pPr marL="0" indent="0" algn="l">
                         <a:buNone/>
                       </a:pPr>
                       <a:r>
@@ -3801,7 +3633,7 @@
                     <a:bodyPr/>
                     <a:lstStyle/>
                     <a:p>
-                      <a:pPr algn="l" indent="0" marL="0">
+                      <a:pPr marL="0" indent="0" algn="l">
                         <a:buNone/>
                       </a:pPr>
                       <a:r>
@@ -3864,6 +3696,11 @@
                     </a:solidFill>
                   </a:tcPr>
                 </a:tc>
+                <a:extLst>
+                  <a:ext uri="{0D108BD9-81ED-4DB2-BD59-A6C34878D82A}">
+                    <a16:rowId xmlns:a16="http://schemas.microsoft.com/office/drawing/2014/main" val="10001"/>
+                  </a:ext>
+                </a:extLst>
               </a:tr>
               <a:tr h="0">
                 <a:tc>
@@ -3871,7 +3708,7 @@
                     <a:bodyPr/>
                     <a:lstStyle/>
                     <a:p>
-                      <a:pPr algn="l" indent="0" marL="0">
+                      <a:pPr marL="0" indent="0" algn="l">
                         <a:buNone/>
                       </a:pPr>
                       <a:r>
@@ -3939,7 +3776,7 @@
                     <a:bodyPr/>
                     <a:lstStyle/>
                     <a:p>
-                      <a:pPr algn="l" indent="0" marL="0">
+                      <a:pPr marL="0" indent="0" algn="l">
                         <a:buNone/>
                       </a:pPr>
                       <a:r>
@@ -4002,6 +3839,11 @@
                     </a:solidFill>
                   </a:tcPr>
                 </a:tc>
+                <a:extLst>
+                  <a:ext uri="{0D108BD9-81ED-4DB2-BD59-A6C34878D82A}">
+                    <a16:rowId xmlns:a16="http://schemas.microsoft.com/office/drawing/2014/main" val="10002"/>
+                  </a:ext>
+                </a:extLst>
               </a:tr>
               <a:tr h="0">
                 <a:tc>
@@ -4009,7 +3851,7 @@
                     <a:bodyPr/>
                     <a:lstStyle/>
                     <a:p>
-                      <a:pPr algn="l" indent="0" marL="0">
+                      <a:pPr marL="0" indent="0" algn="l">
                         <a:buNone/>
                       </a:pPr>
                       <a:r>
@@ -4077,7 +3919,7 @@
                     <a:bodyPr/>
                     <a:lstStyle/>
                     <a:p>
-                      <a:pPr algn="l" indent="0" marL="0">
+                      <a:pPr marL="0" indent="0" algn="l">
                         <a:buNone/>
                       </a:pPr>
                       <a:r>
@@ -4140,6 +3982,11 @@
                     </a:solidFill>
                   </a:tcPr>
                 </a:tc>
+                <a:extLst>
+                  <a:ext uri="{0D108BD9-81ED-4DB2-BD59-A6C34878D82A}">
+                    <a16:rowId xmlns:a16="http://schemas.microsoft.com/office/drawing/2014/main" val="10003"/>
+                  </a:ext>
+                </a:extLst>
               </a:tr>
               <a:tr h="0">
                 <a:tc>
@@ -4147,7 +3994,7 @@
                     <a:bodyPr/>
                     <a:lstStyle/>
                     <a:p>
-                      <a:pPr algn="l" indent="0" marL="0">
+                      <a:pPr marL="0" indent="0" algn="l">
                         <a:buNone/>
                       </a:pPr>
                       <a:r>
@@ -4215,7 +4062,7 @@
                     <a:bodyPr/>
                     <a:lstStyle/>
                     <a:p>
-                      <a:pPr algn="l" indent="0" marL="0">
+                      <a:pPr marL="0" indent="0" algn="l">
                         <a:buNone/>
                       </a:pPr>
                       <a:r>
@@ -4278,6 +4125,11 @@
                     </a:solidFill>
                   </a:tcPr>
                 </a:tc>
+                <a:extLst>
+                  <a:ext uri="{0D108BD9-81ED-4DB2-BD59-A6C34878D82A}">
+                    <a16:rowId xmlns:a16="http://schemas.microsoft.com/office/drawing/2014/main" val="10004"/>
+                  </a:ext>
+                </a:extLst>
               </a:tr>
               <a:tr h="0">
                 <a:tc>
@@ -4285,7 +4137,7 @@
                     <a:bodyPr/>
                     <a:lstStyle/>
                     <a:p>
-                      <a:pPr algn="l" indent="0" marL="0">
+                      <a:pPr marL="0" indent="0" algn="l">
                         <a:buNone/>
                       </a:pPr>
                       <a:r>
@@ -4353,7 +4205,7 @@
                     <a:bodyPr/>
                     <a:lstStyle/>
                     <a:p>
-                      <a:pPr algn="l" indent="0" marL="0">
+                      <a:pPr marL="0" indent="0" algn="l">
                         <a:buNone/>
                       </a:pPr>
                       <a:r>
@@ -4416,6 +4268,11 @@
                     </a:solidFill>
                   </a:tcPr>
                 </a:tc>
+                <a:extLst>
+                  <a:ext uri="{0D108BD9-81ED-4DB2-BD59-A6C34878D82A}">
+                    <a16:rowId xmlns:a16="http://schemas.microsoft.com/office/drawing/2014/main" val="10005"/>
+                  </a:ext>
+                </a:extLst>
               </a:tr>
             </a:tbl>
           </a:graphicData>
@@ -4423,14 +4280,14 @@
       </p:graphicFrame>
       <p:pic>
         <p:nvPicPr>
-          <p:cNvPr id="13" name="Image 1" descr="preencoded.png">    </p:cNvPr>
+          <p:cNvPr id="13" name="Image 1" descr="preencoded.png"/>
           <p:cNvPicPr>
             <a:picLocks noChangeAspect="1"/>
           </p:cNvPicPr>
           <p:nvPr/>
         </p:nvPicPr>
         <p:blipFill>
-          <a:blip r:embed="rId2"/>
+          <a:blip r:embed="rId3"/>
           <a:stretch>
             <a:fillRect/>
           </a:stretch>
@@ -4466,7 +4323,7 @@
           <a:bodyPr wrap="square" lIns="0" tIns="0" rIns="0" bIns="0" rtlCol="0" anchor="ctr"/>
           <a:lstStyle/>
           <a:p>
-            <a:pPr indent="0" marL="0">
+            <a:pPr marL="0" indent="0">
               <a:buNone/>
             </a:pPr>
             <a:r>
@@ -4505,7 +4362,7 @@
           <a:bodyPr wrap="square" lIns="0" tIns="0" rIns="0" bIns="0" rtlCol="0" anchor="ctr"/>
           <a:lstStyle/>
           <a:p>
-            <a:pPr algn="r" indent="0" marL="0">
+            <a:pPr marL="0" indent="0" algn="r">
               <a:buNone/>
             </a:pPr>
             <a:r>
@@ -4539,6 +4396,7 @@
         <a:solidFill>
           <a:srgbClr val="070F26"/>
         </a:solidFill>
+        <a:effectLst/>
       </p:bgPr>
     </p:bg>
     <p:spTree>
@@ -4557,14 +4415,14 @@
       </p:grpSpPr>
       <p:pic>
         <p:nvPicPr>
-          <p:cNvPr id="2" name="Image 0" descr="preencoded.png">    </p:cNvPr>
+          <p:cNvPr id="2" name="Image 0" descr="preencoded.png"/>
           <p:cNvPicPr>
             <a:picLocks noChangeAspect="1"/>
           </p:cNvPicPr>
           <p:nvPr/>
         </p:nvPicPr>
         <p:blipFill>
-          <a:blip r:embed="rId1"/>
+          <a:blip r:embed="rId3"/>
           <a:stretch>
             <a:fillRect/>
           </a:stretch>
@@ -4602,7 +4460,7 @@
           </a:bodyPr>
           <a:lstStyle/>
           <a:p>
-            <a:pPr algn="l" indent="0" marL="0">
+            <a:pPr marL="0" indent="0" algn="l">
               <a:buNone/>
             </a:pPr>
             <a:r>
@@ -4644,6 +4502,13 @@
             <a:prstDash val="solid"/>
           </a:ln>
         </p:spPr>
+        <p:txBody>
+          <a:bodyPr/>
+          <a:lstStyle/>
+          <a:p>
+            <a:endParaRPr lang="es-PE"/>
+          </a:p>
+        </p:txBody>
       </p:sp>
       <p:sp>
         <p:nvSpPr>
@@ -4666,7 +4531,7 @@
           <a:bodyPr wrap="square" lIns="381" tIns="381" rIns="381" bIns="381" rtlCol="0" anchor="ctr"/>
           <a:lstStyle/>
           <a:p>
-            <a:pPr algn="l" indent="0" marL="0">
+            <a:pPr marL="0" indent="0" algn="l">
               <a:buNone/>
             </a:pPr>
             <a:r>
@@ -4710,6 +4575,13 @@
             <a:prstDash val="solid"/>
           </a:ln>
         </p:spPr>
+        <p:txBody>
+          <a:bodyPr/>
+          <a:lstStyle/>
+          <a:p>
+            <a:endParaRPr lang="es-PE"/>
+          </a:p>
+        </p:txBody>
       </p:sp>
       <p:sp>
         <p:nvSpPr>
@@ -4732,7 +4604,7 @@
           <a:bodyPr wrap="square" lIns="0" tIns="0" rIns="0" bIns="0" rtlCol="0" anchor="t"/>
           <a:lstStyle/>
           <a:p>
-            <a:pPr algn="ctr" indent="0" marL="0">
+            <a:pPr marL="0" indent="0" algn="ctr">
               <a:buNone/>
             </a:pPr>
             <a:r>
@@ -4771,7 +4643,7 @@
           <a:bodyPr wrap="square" lIns="0" tIns="0" rIns="0" bIns="0" rtlCol="0" anchor="t"/>
           <a:lstStyle/>
           <a:p>
-            <a:pPr algn="ctr" indent="0" marL="0">
+            <a:pPr marL="0" indent="0" algn="ctr">
               <a:buNone/>
             </a:pPr>
             <a:r>
@@ -4810,7 +4682,7 @@
           <a:bodyPr wrap="square" lIns="0" tIns="0" rIns="0" bIns="0" rtlCol="0" anchor="ctr"/>
           <a:lstStyle/>
           <a:p>
-            <a:pPr algn="ctr" indent="0" marL="0">
+            <a:pPr marL="0" indent="0" algn="ctr">
               <a:buNone/>
             </a:pPr>
             <a:r>
@@ -4851,6 +4723,13 @@
             <a:prstDash val="solid"/>
           </a:ln>
         </p:spPr>
+        <p:txBody>
+          <a:bodyPr/>
+          <a:lstStyle/>
+          <a:p>
+            <a:endParaRPr lang="es-PE"/>
+          </a:p>
+        </p:txBody>
       </p:sp>
       <p:sp>
         <p:nvSpPr>
@@ -4873,7 +4752,7 @@
           <a:bodyPr wrap="square" lIns="0" tIns="0" rIns="0" bIns="0" rtlCol="0" anchor="t"/>
           <a:lstStyle/>
           <a:p>
-            <a:pPr algn="ctr" indent="0" marL="0">
+            <a:pPr marL="0" indent="0" algn="ctr">
               <a:buNone/>
             </a:pPr>
             <a:r>
@@ -4912,7 +4791,7 @@
           <a:bodyPr wrap="square" lIns="0" tIns="0" rIns="0" bIns="0" rtlCol="0" anchor="t"/>
           <a:lstStyle/>
           <a:p>
-            <a:pPr algn="ctr" indent="0" marL="0">
+            <a:pPr marL="0" indent="0" algn="ctr">
               <a:buNone/>
             </a:pPr>
             <a:r>
@@ -4951,7 +4830,7 @@
           <a:bodyPr wrap="square" lIns="0" tIns="0" rIns="0" bIns="0" rtlCol="0" anchor="ctr"/>
           <a:lstStyle/>
           <a:p>
-            <a:pPr algn="ctr" indent="0" marL="0">
+            <a:pPr marL="0" indent="0" algn="ctr">
               <a:buNone/>
             </a:pPr>
             <a:r>
@@ -4992,6 +4871,13 @@
             <a:prstDash val="solid"/>
           </a:ln>
         </p:spPr>
+        <p:txBody>
+          <a:bodyPr/>
+          <a:lstStyle/>
+          <a:p>
+            <a:endParaRPr lang="es-PE"/>
+          </a:p>
+        </p:txBody>
       </p:sp>
       <p:sp>
         <p:nvSpPr>
@@ -5014,7 +4900,7 @@
           <a:bodyPr wrap="square" lIns="0" tIns="0" rIns="0" bIns="0" rtlCol="0" anchor="t"/>
           <a:lstStyle/>
           <a:p>
-            <a:pPr algn="ctr" indent="0" marL="0">
+            <a:pPr marL="0" indent="0" algn="ctr">
               <a:buNone/>
             </a:pPr>
             <a:r>
@@ -5053,7 +4939,7 @@
           <a:bodyPr wrap="square" lIns="0" tIns="0" rIns="0" bIns="0" rtlCol="0" anchor="t"/>
           <a:lstStyle/>
           <a:p>
-            <a:pPr algn="ctr" indent="0" marL="0">
+            <a:pPr marL="0" indent="0" algn="ctr">
               <a:buNone/>
             </a:pPr>
             <a:r>
@@ -5092,7 +4978,7 @@
           <a:bodyPr wrap="square" lIns="0" tIns="0" rIns="0" bIns="0" rtlCol="0" anchor="ctr"/>
           <a:lstStyle/>
           <a:p>
-            <a:pPr algn="ctr" indent="0" marL="0">
+            <a:pPr marL="0" indent="0" algn="ctr">
               <a:buNone/>
             </a:pPr>
             <a:r>
@@ -5133,6 +5019,13 @@
             <a:prstDash val="solid"/>
           </a:ln>
         </p:spPr>
+        <p:txBody>
+          <a:bodyPr/>
+          <a:lstStyle/>
+          <a:p>
+            <a:endParaRPr lang="es-PE"/>
+          </a:p>
+        </p:txBody>
       </p:sp>
       <p:sp>
         <p:nvSpPr>
@@ -5155,7 +5048,7 @@
           <a:bodyPr wrap="square" lIns="0" tIns="0" rIns="0" bIns="0" rtlCol="0" anchor="t"/>
           <a:lstStyle/>
           <a:p>
-            <a:pPr algn="ctr" indent="0" marL="0">
+            <a:pPr marL="0" indent="0" algn="ctr">
               <a:buNone/>
             </a:pPr>
             <a:r>
@@ -5194,7 +5087,7 @@
           <a:bodyPr wrap="square" lIns="0" tIns="0" rIns="0" bIns="0" rtlCol="0" anchor="t"/>
           <a:lstStyle/>
           <a:p>
-            <a:pPr algn="ctr" indent="0" marL="0">
+            <a:pPr marL="0" indent="0" algn="ctr">
               <a:buNone/>
             </a:pPr>
             <a:r>
@@ -5233,7 +5126,7 @@
           <a:bodyPr wrap="square" lIns="0" tIns="0" rIns="0" bIns="0" rtlCol="0" anchor="ctr"/>
           <a:lstStyle/>
           <a:p>
-            <a:pPr algn="ctr" indent="0" marL="0">
+            <a:pPr marL="0" indent="0" algn="ctr">
               <a:buNone/>
             </a:pPr>
             <a:r>
@@ -5274,6 +5167,13 @@
             <a:prstDash val="solid"/>
           </a:ln>
         </p:spPr>
+        <p:txBody>
+          <a:bodyPr/>
+          <a:lstStyle/>
+          <a:p>
+            <a:endParaRPr lang="es-PE"/>
+          </a:p>
+        </p:txBody>
       </p:sp>
       <p:sp>
         <p:nvSpPr>
@@ -5296,7 +5196,7 @@
           <a:bodyPr wrap="square" lIns="0" tIns="0" rIns="0" bIns="0" rtlCol="0" anchor="t"/>
           <a:lstStyle/>
           <a:p>
-            <a:pPr algn="ctr" indent="0" marL="0">
+            <a:pPr marL="0" indent="0" algn="ctr">
               <a:buNone/>
             </a:pPr>
             <a:r>
@@ -5335,7 +5235,7 @@
           <a:bodyPr wrap="square" lIns="0" tIns="0" rIns="0" bIns="0" rtlCol="0" anchor="t"/>
           <a:lstStyle/>
           <a:p>
-            <a:pPr algn="ctr" indent="0" marL="0">
+            <a:pPr marL="0" indent="0" algn="ctr">
               <a:buNone/>
             </a:pPr>
             <a:r>
@@ -5374,7 +5274,7 @@
           <a:bodyPr wrap="square" lIns="0" tIns="0" rIns="0" bIns="0" rtlCol="0" anchor="ctr"/>
           <a:lstStyle/>
           <a:p>
-            <a:pPr algn="ctr" indent="0" marL="0">
+            <a:pPr marL="0" indent="0" algn="ctr">
               <a:buNone/>
             </a:pPr>
             <a:r>
@@ -5415,6 +5315,13 @@
             <a:prstDash val="solid"/>
           </a:ln>
         </p:spPr>
+        <p:txBody>
+          <a:bodyPr/>
+          <a:lstStyle/>
+          <a:p>
+            <a:endParaRPr lang="es-PE"/>
+          </a:p>
+        </p:txBody>
       </p:sp>
       <p:sp>
         <p:nvSpPr>
@@ -5437,7 +5344,7 @@
           <a:bodyPr wrap="square" lIns="0" tIns="0" rIns="0" bIns="0" rtlCol="0" anchor="t"/>
           <a:lstStyle/>
           <a:p>
-            <a:pPr algn="ctr" indent="0" marL="0">
+            <a:pPr marL="0" indent="0" algn="ctr">
               <a:buNone/>
             </a:pPr>
             <a:r>
@@ -5476,7 +5383,7 @@
           <a:bodyPr wrap="square" lIns="0" tIns="0" rIns="0" bIns="0" rtlCol="0" anchor="t"/>
           <a:lstStyle/>
           <a:p>
-            <a:pPr algn="ctr" indent="0" marL="0">
+            <a:pPr marL="0" indent="0" algn="ctr">
               <a:buNone/>
             </a:pPr>
             <a:r>
@@ -5515,7 +5422,7 @@
           <a:bodyPr wrap="square" lIns="0" tIns="0" rIns="0" bIns="0" rtlCol="0" anchor="ctr"/>
           <a:lstStyle/>
           <a:p>
-            <a:pPr algn="ctr" indent="0" marL="0">
+            <a:pPr marL="0" indent="0" algn="ctr">
               <a:buNone/>
             </a:pPr>
             <a:r>
@@ -5556,6 +5463,13 @@
             <a:prstDash val="solid"/>
           </a:ln>
         </p:spPr>
+        <p:txBody>
+          <a:bodyPr/>
+          <a:lstStyle/>
+          <a:p>
+            <a:endParaRPr lang="es-PE"/>
+          </a:p>
+        </p:txBody>
       </p:sp>
       <p:sp>
         <p:nvSpPr>
@@ -5578,7 +5492,7 @@
           <a:bodyPr wrap="square" lIns="0" tIns="0" rIns="0" bIns="0" rtlCol="0" anchor="t"/>
           <a:lstStyle/>
           <a:p>
-            <a:pPr algn="ctr" indent="0" marL="0">
+            <a:pPr marL="0" indent="0" algn="ctr">
               <a:buNone/>
             </a:pPr>
             <a:r>
@@ -5617,7 +5531,7 @@
           <a:bodyPr wrap="square" lIns="0" tIns="0" rIns="0" bIns="0" rtlCol="0" anchor="t"/>
           <a:lstStyle/>
           <a:p>
-            <a:pPr algn="ctr" indent="0" marL="0">
+            <a:pPr marL="0" indent="0" algn="ctr">
               <a:buNone/>
             </a:pPr>
             <a:r>
@@ -5661,6 +5575,13 @@
             <a:prstDash val="solid"/>
           </a:ln>
         </p:spPr>
+        <p:txBody>
+          <a:bodyPr/>
+          <a:lstStyle/>
+          <a:p>
+            <a:endParaRPr lang="es-PE"/>
+          </a:p>
+        </p:txBody>
       </p:sp>
       <p:sp>
         <p:nvSpPr>
@@ -5683,7 +5604,7 @@
           <a:bodyPr wrap="square" lIns="0" tIns="0" rIns="0" bIns="0" rtlCol="0" anchor="ctr"/>
           <a:lstStyle/>
           <a:p>
-            <a:pPr algn="l" indent="0" marL="0">
+            <a:pPr marL="0" indent="0" algn="l">
               <a:buNone/>
             </a:pPr>
             <a:r>
@@ -5722,7 +5643,7 @@
           <a:bodyPr wrap="square" lIns="381" tIns="381" rIns="381" bIns="381" rtlCol="0" anchor="ctr"/>
           <a:lstStyle/>
           <a:p>
-            <a:pPr algn="l" indent="0" marL="0">
+            <a:pPr marL="0" indent="0" algn="l">
               <a:lnSpc>
                 <a:spcPct val="115000"/>
               </a:lnSpc>
@@ -5745,14 +5666,14 @@
       </p:sp>
       <p:pic>
         <p:nvPicPr>
-          <p:cNvPr id="36" name="Image 1" descr="preencoded.png">    </p:cNvPr>
+          <p:cNvPr id="36" name="Image 1" descr="preencoded.png"/>
           <p:cNvPicPr>
             <a:picLocks noChangeAspect="1"/>
           </p:cNvPicPr>
           <p:nvPr/>
         </p:nvPicPr>
         <p:blipFill>
-          <a:blip r:embed="rId2"/>
+          <a:blip r:embed="rId3"/>
           <a:stretch>
             <a:fillRect/>
           </a:stretch>
@@ -5788,7 +5709,7 @@
           <a:bodyPr wrap="square" lIns="0" tIns="0" rIns="0" bIns="0" rtlCol="0" anchor="ctr"/>
           <a:lstStyle/>
           <a:p>
-            <a:pPr indent="0" marL="0">
+            <a:pPr marL="0" indent="0">
               <a:buNone/>
             </a:pPr>
             <a:r>
@@ -5827,7 +5748,7 @@
           <a:bodyPr wrap="square" lIns="0" tIns="0" rIns="0" bIns="0" rtlCol="0" anchor="ctr"/>
           <a:lstStyle/>
           <a:p>
-            <a:pPr algn="r" indent="0" marL="0">
+            <a:pPr marL="0" indent="0" algn="r">
               <a:buNone/>
             </a:pPr>
             <a:r>
@@ -5861,6 +5782,7 @@
         <a:solidFill>
           <a:srgbClr val="070F26"/>
         </a:solidFill>
+        <a:effectLst/>
       </p:bgPr>
     </p:bg>
     <p:spTree>
@@ -5879,14 +5801,14 @@
       </p:grpSpPr>
       <p:pic>
         <p:nvPicPr>
-          <p:cNvPr id="2" name="Image 0" descr="preencoded.png">    </p:cNvPr>
+          <p:cNvPr id="2" name="Image 0" descr="preencoded.png"/>
           <p:cNvPicPr>
             <a:picLocks noChangeAspect="1"/>
           </p:cNvPicPr>
           <p:nvPr/>
         </p:nvPicPr>
         <p:blipFill>
-          <a:blip r:embed="rId1"/>
+          <a:blip r:embed="rId3"/>
           <a:stretch>
             <a:fillRect/>
           </a:stretch>
@@ -5924,7 +5846,7 @@
           </a:bodyPr>
           <a:lstStyle/>
           <a:p>
-            <a:pPr algn="l" indent="0" marL="0">
+            <a:pPr marL="0" indent="0" algn="l">
               <a:buNone/>
             </a:pPr>
             <a:r>
@@ -5966,6 +5888,13 @@
             <a:prstDash val="solid"/>
           </a:ln>
         </p:spPr>
+        <p:txBody>
+          <a:bodyPr/>
+          <a:lstStyle/>
+          <a:p>
+            <a:endParaRPr lang="es-PE"/>
+          </a:p>
+        </p:txBody>
       </p:sp>
       <p:sp>
         <p:nvSpPr>
@@ -5988,7 +5917,7 @@
           <a:bodyPr wrap="square" lIns="381" tIns="381" rIns="381" bIns="381" rtlCol="0" anchor="ctr"/>
           <a:lstStyle/>
           <a:p>
-            <a:pPr algn="l" indent="0" marL="0">
+            <a:pPr marL="0" indent="0" algn="l">
               <a:buNone/>
             </a:pPr>
             <a:r>
@@ -6022,20 +5951,62 @@
         </p:nvGraphicFramePr>
         <p:xfrm>
           <a:off x="365760" y="1399032"/>
-          <a:ext cx="8503920" cy="914400"/>
+          <a:ext cx="8503920" cy="981456"/>
         </p:xfrm>
         <a:graphic>
           <a:graphicData uri="http://schemas.openxmlformats.org/drawingml/2006/table">
             <a:tbl>
               <a:tblPr/>
               <a:tblGrid>
-                <a:gridCol w="1097280"/>
-                <a:gridCol w="2606040"/>
-                <a:gridCol w="640080"/>
-                <a:gridCol w="777240"/>
-                <a:gridCol w="777240"/>
-                <a:gridCol w="1371600"/>
-                <a:gridCol w="1234440"/>
+                <a:gridCol w="1097280">
+                  <a:extLst>
+                    <a:ext uri="{9D8B030D-6E8A-4147-A177-3AD203B41FA5}">
+                      <a16:colId xmlns:a16="http://schemas.microsoft.com/office/drawing/2014/main" val="20000"/>
+                    </a:ext>
+                  </a:extLst>
+                </a:gridCol>
+                <a:gridCol w="2606040">
+                  <a:extLst>
+                    <a:ext uri="{9D8B030D-6E8A-4147-A177-3AD203B41FA5}">
+                      <a16:colId xmlns:a16="http://schemas.microsoft.com/office/drawing/2014/main" val="20001"/>
+                    </a:ext>
+                  </a:extLst>
+                </a:gridCol>
+                <a:gridCol w="640080">
+                  <a:extLst>
+                    <a:ext uri="{9D8B030D-6E8A-4147-A177-3AD203B41FA5}">
+                      <a16:colId xmlns:a16="http://schemas.microsoft.com/office/drawing/2014/main" val="20002"/>
+                    </a:ext>
+                  </a:extLst>
+                </a:gridCol>
+                <a:gridCol w="777240">
+                  <a:extLst>
+                    <a:ext uri="{9D8B030D-6E8A-4147-A177-3AD203B41FA5}">
+                      <a16:colId xmlns:a16="http://schemas.microsoft.com/office/drawing/2014/main" val="20003"/>
+                    </a:ext>
+                  </a:extLst>
+                </a:gridCol>
+                <a:gridCol w="777240">
+                  <a:extLst>
+                    <a:ext uri="{9D8B030D-6E8A-4147-A177-3AD203B41FA5}">
+                      <a16:colId xmlns:a16="http://schemas.microsoft.com/office/drawing/2014/main" val="20004"/>
+                    </a:ext>
+                  </a:extLst>
+                </a:gridCol>
+                <a:gridCol w="1371600">
+                  <a:extLst>
+                    <a:ext uri="{9D8B030D-6E8A-4147-A177-3AD203B41FA5}">
+                      <a16:colId xmlns:a16="http://schemas.microsoft.com/office/drawing/2014/main" val="20005"/>
+                    </a:ext>
+                  </a:extLst>
+                </a:gridCol>
+                <a:gridCol w="1234440">
+                  <a:extLst>
+                    <a:ext uri="{9D8B030D-6E8A-4147-A177-3AD203B41FA5}">
+                      <a16:colId xmlns:a16="http://schemas.microsoft.com/office/drawing/2014/main" val="20006"/>
+                    </a:ext>
+                  </a:extLst>
+                </a:gridCol>
               </a:tblGrid>
               <a:tr h="0">
                 <a:tc>
@@ -6043,7 +6014,7 @@
                     <a:bodyPr/>
                     <a:lstStyle/>
                     <a:p>
-                      <a:pPr algn="ctr" indent="0" marL="0">
+                      <a:pPr marL="0" indent="0" algn="ctr">
                         <a:buNone/>
                       </a:pPr>
                       <a:r>
@@ -6111,7 +6082,7 @@
                     <a:bodyPr/>
                     <a:lstStyle/>
                     <a:p>
-                      <a:pPr algn="ctr" indent="0" marL="0">
+                      <a:pPr marL="0" indent="0" algn="ctr">
                         <a:buNone/>
                       </a:pPr>
                       <a:r>
@@ -6179,7 +6150,7 @@
                     <a:bodyPr/>
                     <a:lstStyle/>
                     <a:p>
-                      <a:pPr algn="ctr" indent="0" marL="0">
+                      <a:pPr marL="0" indent="0" algn="ctr">
                         <a:buNone/>
                       </a:pPr>
                       <a:r>
@@ -6247,7 +6218,7 @@
                     <a:bodyPr/>
                     <a:lstStyle/>
                     <a:p>
-                      <a:pPr algn="ctr" indent="0" marL="0">
+                      <a:pPr marL="0" indent="0" algn="ctr">
                         <a:buNone/>
                       </a:pPr>
                       <a:r>
@@ -6315,7 +6286,7 @@
                     <a:bodyPr/>
                     <a:lstStyle/>
                     <a:p>
-                      <a:pPr algn="ctr" indent="0" marL="0">
+                      <a:pPr marL="0" indent="0" algn="ctr">
                         <a:buNone/>
                       </a:pPr>
                       <a:r>
@@ -6383,7 +6354,7 @@
                     <a:bodyPr/>
                     <a:lstStyle/>
                     <a:p>
-                      <a:pPr algn="ctr" indent="0" marL="0">
+                      <a:pPr marL="0" indent="0" algn="ctr">
                         <a:buNone/>
                       </a:pPr>
                       <a:r>
@@ -6451,7 +6422,7 @@
                     <a:bodyPr/>
                     <a:lstStyle/>
                     <a:p>
-                      <a:pPr algn="ctr" indent="0" marL="0">
+                      <a:pPr marL="0" indent="0" algn="ctr">
                         <a:buNone/>
                       </a:pPr>
                       <a:r>
@@ -6514,6 +6485,11 @@
                     </a:solidFill>
                   </a:tcPr>
                 </a:tc>
+                <a:extLst>
+                  <a:ext uri="{0D108BD9-81ED-4DB2-BD59-A6C34878D82A}">
+                    <a16:rowId xmlns:a16="http://schemas.microsoft.com/office/drawing/2014/main" val="10000"/>
+                  </a:ext>
+                </a:extLst>
               </a:tr>
               <a:tr h="0">
                 <a:tc>
@@ -6521,7 +6497,7 @@
                     <a:bodyPr/>
                     <a:lstStyle/>
                     <a:p>
-                      <a:pPr algn="l" indent="0" marL="0">
+                      <a:pPr marL="0" indent="0" algn="l">
                         <a:buNone/>
                       </a:pPr>
                       <a:r>
@@ -6589,7 +6565,7 @@
                     <a:bodyPr/>
                     <a:lstStyle/>
                     <a:p>
-                      <a:pPr algn="l" indent="0" marL="0">
+                      <a:pPr marL="0" indent="0" algn="l">
                         <a:buNone/>
                       </a:pPr>
                       <a:r>
@@ -6657,7 +6633,7 @@
                     <a:bodyPr/>
                     <a:lstStyle/>
                     <a:p>
-                      <a:pPr algn="l" indent="0" marL="0">
+                      <a:pPr marL="0" indent="0" algn="l">
                         <a:buNone/>
                       </a:pPr>
                       <a:r>
@@ -6725,7 +6701,7 @@
                     <a:bodyPr/>
                     <a:lstStyle/>
                     <a:p>
-                      <a:pPr algn="l" indent="0" marL="0">
+                      <a:pPr marL="0" indent="0" algn="l">
                         <a:buNone/>
                       </a:pPr>
                       <a:r>
@@ -6793,7 +6769,7 @@
                     <a:bodyPr/>
                     <a:lstStyle/>
                     <a:p>
-                      <a:pPr algn="l" indent="0" marL="0">
+                      <a:pPr marL="0" indent="0" algn="l">
                         <a:buNone/>
                       </a:pPr>
                       <a:r>
@@ -6861,7 +6837,7 @@
                     <a:bodyPr/>
                     <a:lstStyle/>
                     <a:p>
-                      <a:pPr algn="l" indent="0" marL="0">
+                      <a:pPr marL="0" indent="0" algn="l">
                         <a:buNone/>
                       </a:pPr>
                       <a:r>
@@ -6929,7 +6905,7 @@
                     <a:bodyPr/>
                     <a:lstStyle/>
                     <a:p>
-                      <a:pPr algn="l" indent="0" marL="0">
+                      <a:pPr marL="0" indent="0" algn="l">
                         <a:buNone/>
                       </a:pPr>
                       <a:r>
@@ -6992,6 +6968,11 @@
                     </a:solidFill>
                   </a:tcPr>
                 </a:tc>
+                <a:extLst>
+                  <a:ext uri="{0D108BD9-81ED-4DB2-BD59-A6C34878D82A}">
+                    <a16:rowId xmlns:a16="http://schemas.microsoft.com/office/drawing/2014/main" val="10001"/>
+                  </a:ext>
+                </a:extLst>
               </a:tr>
               <a:tr h="0">
                 <a:tc>
@@ -6999,7 +6980,7 @@
                     <a:bodyPr/>
                     <a:lstStyle/>
                     <a:p>
-                      <a:pPr algn="l" indent="0" marL="0">
+                      <a:pPr marL="0" indent="0" algn="l">
                         <a:buNone/>
                       </a:pPr>
                       <a:r>
@@ -7067,7 +7048,7 @@
                     <a:bodyPr/>
                     <a:lstStyle/>
                     <a:p>
-                      <a:pPr algn="l" indent="0" marL="0">
+                      <a:pPr marL="0" indent="0" algn="l">
                         <a:buNone/>
                       </a:pPr>
                       <a:r>
@@ -7135,7 +7116,7 @@
                     <a:bodyPr/>
                     <a:lstStyle/>
                     <a:p>
-                      <a:pPr algn="l" indent="0" marL="0">
+                      <a:pPr marL="0" indent="0" algn="l">
                         <a:buNone/>
                       </a:pPr>
                       <a:r>
@@ -7203,7 +7184,7 @@
                     <a:bodyPr/>
                     <a:lstStyle/>
                     <a:p>
-                      <a:pPr algn="l" indent="0" marL="0">
+                      <a:pPr marL="0" indent="0" algn="l">
                         <a:buNone/>
                       </a:pPr>
                       <a:r>
@@ -7271,7 +7252,7 @@
                     <a:bodyPr/>
                     <a:lstStyle/>
                     <a:p>
-                      <a:pPr algn="l" indent="0" marL="0">
+                      <a:pPr marL="0" indent="0" algn="l">
                         <a:buNone/>
                       </a:pPr>
                       <a:r>
@@ -7339,7 +7320,7 @@
                     <a:bodyPr/>
                     <a:lstStyle/>
                     <a:p>
-                      <a:pPr algn="l" indent="0" marL="0">
+                      <a:pPr marL="0" indent="0" algn="l">
                         <a:buNone/>
                       </a:pPr>
                       <a:r>
@@ -7407,7 +7388,7 @@
                     <a:bodyPr/>
                     <a:lstStyle/>
                     <a:p>
-                      <a:pPr algn="l" indent="0" marL="0">
+                      <a:pPr marL="0" indent="0" algn="l">
                         <a:buNone/>
                       </a:pPr>
                       <a:r>
@@ -7470,6 +7451,11 @@
                     </a:solidFill>
                   </a:tcPr>
                 </a:tc>
+                <a:extLst>
+                  <a:ext uri="{0D108BD9-81ED-4DB2-BD59-A6C34878D82A}">
+                    <a16:rowId xmlns:a16="http://schemas.microsoft.com/office/drawing/2014/main" val="10002"/>
+                  </a:ext>
+                </a:extLst>
               </a:tr>
             </a:tbl>
           </a:graphicData>
@@ -7496,7 +7482,7 @@
           <a:bodyPr wrap="square" lIns="0" tIns="0" rIns="0" bIns="0" rtlCol="0" anchor="ctr"/>
           <a:lstStyle/>
           <a:p>
-            <a:pPr algn="l" indent="0" marL="0">
+            <a:pPr marL="0" indent="0" algn="l">
               <a:buNone/>
             </a:pPr>
             <a:r>
@@ -7535,7 +7521,7 @@
           <a:bodyPr wrap="square" lIns="0" tIns="0" rIns="0" bIns="0" rtlCol="0" anchor="ctr"/>
           <a:lstStyle/>
           <a:p>
-            <a:pPr algn="l" indent="0" marL="0">
+            <a:pPr marL="0" indent="0" algn="l">
               <a:buNone/>
             </a:pPr>
             <a:r>
@@ -7579,6 +7565,13 @@
             <a:prstDash val="solid"/>
           </a:ln>
         </p:spPr>
+        <p:txBody>
+          <a:bodyPr/>
+          <a:lstStyle/>
+          <a:p>
+            <a:endParaRPr lang="es-PE"/>
+          </a:p>
+        </p:txBody>
       </p:sp>
       <p:sp>
         <p:nvSpPr>
@@ -7601,7 +7594,7 @@
           <a:bodyPr wrap="square" lIns="0" tIns="0" rIns="0" bIns="0" rtlCol="0" anchor="ctr"/>
           <a:lstStyle/>
           <a:p>
-            <a:pPr algn="ctr" indent="0" marL="0">
+            <a:pPr marL="0" indent="0" algn="ctr">
               <a:lnSpc>
                 <a:spcPct val="95000"/>
               </a:lnSpc>
@@ -7619,12 +7612,6 @@
               <a:t>75 %
 </a:t>
             </a:r>
-            <a:pPr algn="ctr" indent="0" marL="0">
-              <a:lnSpc>
-                <a:spcPct val="95000"/>
-              </a:lnSpc>
-              <a:buNone/>
-            </a:pPr>
             <a:r>
               <a:rPr lang="en-US" sz="700" dirty="0">
                 <a:solidFill>
@@ -7642,7 +7629,7 @@
       </p:sp>
       <p:graphicFrame>
         <p:nvGraphicFramePr>
-          <p:cNvPr id="11" name="Chart 0" descr=""/>
+          <p:cNvPr id="11" name="Chart 0"/>
           <p:cNvGraphicFramePr/>
           <p:nvPr/>
         </p:nvGraphicFramePr>
@@ -7650,9 +7637,9 @@
           <a:off x="365760" y="3218688"/>
           <a:ext cx="4114800" cy="1152144"/>
         </p:xfrm>
-        <a:graphic xmlns:a="http://schemas.openxmlformats.org/drawingml/2006/main">
+        <a:graphic>
           <a:graphicData uri="http://schemas.openxmlformats.org/drawingml/2006/chart">
-            <c:chart xmlns:c="http://schemas.openxmlformats.org/drawingml/2006/chart" r:id="rId2"/>
+            <c:chart xmlns:c="http://schemas.openxmlformats.org/drawingml/2006/chart" xmlns:r="http://schemas.openxmlformats.org/officeDocument/2006/relationships" r:id="rId4"/>
           </a:graphicData>
         </a:graphic>
       </p:graphicFrame>
@@ -7677,7 +7664,7 @@
           <a:bodyPr wrap="square" lIns="0" tIns="0" rIns="0" bIns="0" rtlCol="0" anchor="t"/>
           <a:lstStyle/>
           <a:p>
-            <a:pPr algn="ctr" indent="0" marL="0">
+            <a:pPr marL="0" indent="0" algn="ctr">
               <a:buNone/>
             </a:pPr>
             <a:r>
@@ -7716,7 +7703,7 @@
           <a:bodyPr wrap="square" lIns="0" tIns="0" rIns="0" bIns="0" rtlCol="0" anchor="ctr"/>
           <a:lstStyle/>
           <a:p>
-            <a:pPr algn="l" indent="0" marL="0">
+            <a:pPr marL="0" indent="0" algn="l">
               <a:buNone/>
             </a:pPr>
             <a:r>
@@ -7755,7 +7742,7 @@
           <a:bodyPr wrap="square" lIns="0" tIns="0" rIns="0" bIns="0" rtlCol="0" anchor="ctr"/>
           <a:lstStyle/>
           <a:p>
-            <a:pPr algn="l" indent="0" marL="0">
+            <a:pPr marL="0" indent="0" algn="l">
               <a:buNone/>
             </a:pPr>
             <a:r>
@@ -7799,6 +7786,13 @@
             <a:prstDash val="solid"/>
           </a:ln>
         </p:spPr>
+        <p:txBody>
+          <a:bodyPr/>
+          <a:lstStyle/>
+          <a:p>
+            <a:endParaRPr lang="es-PE"/>
+          </a:p>
+        </p:txBody>
       </p:sp>
       <p:sp>
         <p:nvSpPr>
@@ -7821,7 +7815,7 @@
           <a:bodyPr wrap="square" lIns="0" tIns="0" rIns="0" bIns="0" rtlCol="0" anchor="ctr"/>
           <a:lstStyle/>
           <a:p>
-            <a:pPr algn="ctr" indent="0" marL="0">
+            <a:pPr marL="0" indent="0" algn="ctr">
               <a:lnSpc>
                 <a:spcPct val="95000"/>
               </a:lnSpc>
@@ -7839,12 +7833,6 @@
               <a:t>79 %
 </a:t>
             </a:r>
-            <a:pPr algn="ctr" indent="0" marL="0">
-              <a:lnSpc>
-                <a:spcPct val="95000"/>
-              </a:lnSpc>
-              <a:buNone/>
-            </a:pPr>
             <a:r>
               <a:rPr lang="en-US" sz="700" dirty="0">
                 <a:solidFill>
@@ -7862,7 +7850,7 @@
       </p:sp>
       <p:graphicFrame>
         <p:nvGraphicFramePr>
-          <p:cNvPr id="17" name="Chart 1" descr=""/>
+          <p:cNvPr id="17" name="Chart 1"/>
           <p:cNvGraphicFramePr/>
           <p:nvPr/>
         </p:nvGraphicFramePr>
@@ -7870,9 +7858,9 @@
           <a:off x="4754880" y="3218688"/>
           <a:ext cx="4114800" cy="1152144"/>
         </p:xfrm>
-        <a:graphic xmlns:a="http://schemas.openxmlformats.org/drawingml/2006/main">
+        <a:graphic>
           <a:graphicData uri="http://schemas.openxmlformats.org/drawingml/2006/chart">
-            <c:chart xmlns:c="http://schemas.openxmlformats.org/drawingml/2006/chart" r:id="rId3"/>
+            <c:chart xmlns:c="http://schemas.openxmlformats.org/drawingml/2006/chart" xmlns:r="http://schemas.openxmlformats.org/officeDocument/2006/relationships" r:id="rId5"/>
           </a:graphicData>
         </a:graphic>
       </p:graphicFrame>
@@ -7897,7 +7885,7 @@
           <a:bodyPr wrap="square" lIns="0" tIns="0" rIns="0" bIns="0" rtlCol="0" anchor="t"/>
           <a:lstStyle/>
           <a:p>
-            <a:pPr algn="ctr" indent="0" marL="0">
+            <a:pPr marL="0" indent="0" algn="ctr">
               <a:buNone/>
             </a:pPr>
             <a:r>
@@ -7936,7 +7924,7 @@
           <a:bodyPr wrap="square" lIns="381" tIns="381" rIns="381" bIns="381" rtlCol="0" anchor="ctr"/>
           <a:lstStyle/>
           <a:p>
-            <a:pPr algn="l" indent="0" marL="0">
+            <a:pPr marL="0" indent="0" algn="l">
               <a:buNone/>
             </a:pPr>
             <a:r>
@@ -7956,14 +7944,14 @@
       </p:sp>
       <p:pic>
         <p:nvPicPr>
-          <p:cNvPr id="20" name="Image 1" descr="preencoded.png">    </p:cNvPr>
+          <p:cNvPr id="20" name="Image 1" descr="preencoded.png"/>
           <p:cNvPicPr>
             <a:picLocks noChangeAspect="1"/>
           </p:cNvPicPr>
           <p:nvPr/>
         </p:nvPicPr>
         <p:blipFill>
-          <a:blip r:embed="rId4"/>
+          <a:blip r:embed="rId3"/>
           <a:stretch>
             <a:fillRect/>
           </a:stretch>
@@ -7999,7 +7987,7 @@
           <a:bodyPr wrap="square" lIns="0" tIns="0" rIns="0" bIns="0" rtlCol="0" anchor="ctr"/>
           <a:lstStyle/>
           <a:p>
-            <a:pPr indent="0" marL="0">
+            <a:pPr marL="0" indent="0">
               <a:buNone/>
             </a:pPr>
             <a:r>
@@ -8038,7 +8026,7 @@
           <a:bodyPr wrap="square" lIns="0" tIns="0" rIns="0" bIns="0" rtlCol="0" anchor="ctr"/>
           <a:lstStyle/>
           <a:p>
-            <a:pPr algn="r" indent="0" marL="0">
+            <a:pPr marL="0" indent="0" algn="r">
               <a:buNone/>
             </a:pPr>
             <a:r>
@@ -8072,6 +8060,7 @@
         <a:solidFill>
           <a:srgbClr val="070F26"/>
         </a:solidFill>
+        <a:effectLst/>
       </p:bgPr>
     </p:bg>
     <p:spTree>
@@ -8090,14 +8079,14 @@
       </p:grpSpPr>
       <p:pic>
         <p:nvPicPr>
-          <p:cNvPr id="2" name="Image 0" descr="preencoded.png">    </p:cNvPr>
+          <p:cNvPr id="2" name="Image 0" descr="preencoded.png"/>
           <p:cNvPicPr>
             <a:picLocks noChangeAspect="1"/>
           </p:cNvPicPr>
           <p:nvPr/>
         </p:nvPicPr>
         <p:blipFill>
-          <a:blip r:embed="rId1"/>
+          <a:blip r:embed="rId3"/>
           <a:stretch>
             <a:fillRect/>
           </a:stretch>
@@ -8135,7 +8124,7 @@
           </a:bodyPr>
           <a:lstStyle/>
           <a:p>
-            <a:pPr algn="l" indent="0" marL="0">
+            <a:pPr marL="0" indent="0" algn="l">
               <a:buNone/>
             </a:pPr>
             <a:r>
@@ -8177,6 +8166,13 @@
             <a:prstDash val="solid"/>
           </a:ln>
         </p:spPr>
+        <p:txBody>
+          <a:bodyPr/>
+          <a:lstStyle/>
+          <a:p>
+            <a:endParaRPr lang="es-PE"/>
+          </a:p>
+        </p:txBody>
       </p:sp>
       <p:sp>
         <p:nvSpPr>
@@ -8204,6 +8200,13 @@
             <a:prstDash val="solid"/>
           </a:ln>
         </p:spPr>
+        <p:txBody>
+          <a:bodyPr/>
+          <a:lstStyle/>
+          <a:p>
+            <a:endParaRPr lang="es-PE"/>
+          </a:p>
+        </p:txBody>
       </p:sp>
       <p:sp>
         <p:nvSpPr>
@@ -8226,7 +8229,7 @@
           <a:bodyPr wrap="square" lIns="0" tIns="0" rIns="0" bIns="0" rtlCol="0" anchor="ctr"/>
           <a:lstStyle/>
           <a:p>
-            <a:pPr algn="ctr" indent="0" marL="0">
+            <a:pPr marL="0" indent="0" algn="ctr">
               <a:buNone/>
             </a:pPr>
             <a:r>
@@ -8265,7 +8268,7 @@
           <a:bodyPr wrap="square" lIns="0" tIns="0" rIns="0" bIns="0" rtlCol="0" anchor="ctr"/>
           <a:lstStyle/>
           <a:p>
-            <a:pPr algn="ctr" indent="0" marL="0">
+            <a:pPr marL="0" indent="0" algn="ctr">
               <a:buNone/>
             </a:pPr>
             <a:r>
@@ -8309,6 +8312,13 @@
             <a:prstDash val="solid"/>
           </a:ln>
         </p:spPr>
+        <p:txBody>
+          <a:bodyPr/>
+          <a:lstStyle/>
+          <a:p>
+            <a:endParaRPr lang="es-PE"/>
+          </a:p>
+        </p:txBody>
       </p:sp>
       <p:sp>
         <p:nvSpPr>
@@ -8331,7 +8341,7 @@
           <a:bodyPr wrap="square" lIns="0" tIns="0" rIns="0" bIns="0" rtlCol="0" anchor="ctr"/>
           <a:lstStyle/>
           <a:p>
-            <a:pPr algn="ctr" indent="0" marL="0">
+            <a:pPr marL="0" indent="0" algn="ctr">
               <a:buNone/>
             </a:pPr>
             <a:r>
@@ -8370,7 +8380,7 @@
           <a:bodyPr wrap="square" lIns="0" tIns="0" rIns="0" bIns="0" rtlCol="0" anchor="ctr"/>
           <a:lstStyle/>
           <a:p>
-            <a:pPr algn="ctr" indent="0" marL="0">
+            <a:pPr marL="0" indent="0" algn="ctr">
               <a:buNone/>
             </a:pPr>
             <a:r>
@@ -8414,6 +8424,13 @@
             <a:prstDash val="solid"/>
           </a:ln>
         </p:spPr>
+        <p:txBody>
+          <a:bodyPr/>
+          <a:lstStyle/>
+          <a:p>
+            <a:endParaRPr lang="es-PE"/>
+          </a:p>
+        </p:txBody>
       </p:sp>
       <p:sp>
         <p:nvSpPr>
@@ -8436,7 +8453,7 @@
           <a:bodyPr wrap="square" lIns="0" tIns="0" rIns="0" bIns="0" rtlCol="0" anchor="ctr"/>
           <a:lstStyle/>
           <a:p>
-            <a:pPr algn="ctr" indent="0" marL="0">
+            <a:pPr marL="0" indent="0" algn="ctr">
               <a:buNone/>
             </a:pPr>
             <a:r>
@@ -8475,7 +8492,7 @@
           <a:bodyPr wrap="square" lIns="0" tIns="0" rIns="0" bIns="0" rtlCol="0" anchor="ctr"/>
           <a:lstStyle/>
           <a:p>
-            <a:pPr algn="ctr" indent="0" marL="0">
+            <a:pPr marL="0" indent="0" algn="ctr">
               <a:buNone/>
             </a:pPr>
             <a:r>
@@ -8519,6 +8536,13 @@
             <a:prstDash val="solid"/>
           </a:ln>
         </p:spPr>
+        <p:txBody>
+          <a:bodyPr/>
+          <a:lstStyle/>
+          <a:p>
+            <a:endParaRPr lang="es-PE"/>
+          </a:p>
+        </p:txBody>
       </p:sp>
       <p:sp>
         <p:nvSpPr>
@@ -8541,7 +8565,7 @@
           <a:bodyPr wrap="square" lIns="0" tIns="0" rIns="0" bIns="0" rtlCol="0" anchor="ctr"/>
           <a:lstStyle/>
           <a:p>
-            <a:pPr algn="ctr" indent="0" marL="0">
+            <a:pPr marL="0" indent="0" algn="ctr">
               <a:buNone/>
             </a:pPr>
             <a:r>
@@ -8580,7 +8604,7 @@
           <a:bodyPr wrap="square" lIns="0" tIns="0" rIns="0" bIns="0" rtlCol="0" anchor="ctr"/>
           <a:lstStyle/>
           <a:p>
-            <a:pPr algn="ctr" indent="0" marL="0">
+            <a:pPr marL="0" indent="0" algn="ctr">
               <a:buNone/>
             </a:pPr>
             <a:r>
@@ -8624,6 +8648,13 @@
             <a:prstDash val="solid"/>
           </a:ln>
         </p:spPr>
+        <p:txBody>
+          <a:bodyPr/>
+          <a:lstStyle/>
+          <a:p>
+            <a:endParaRPr lang="es-PE"/>
+          </a:p>
+        </p:txBody>
       </p:sp>
       <p:sp>
         <p:nvSpPr>
@@ -8646,7 +8677,7 @@
           <a:bodyPr wrap="square" lIns="0" tIns="0" rIns="0" bIns="0" rtlCol="0" anchor="ctr"/>
           <a:lstStyle/>
           <a:p>
-            <a:pPr algn="ctr" indent="0" marL="0">
+            <a:pPr marL="0" indent="0" algn="ctr">
               <a:lnSpc>
                 <a:spcPct val="100000"/>
               </a:lnSpc>
@@ -8664,12 +8695,6 @@
               <a:t>SEM 1
 </a:t>
             </a:r>
-            <a:pPr algn="ctr" indent="0" marL="0">
-              <a:lnSpc>
-                <a:spcPct val="100000"/>
-              </a:lnSpc>
-              <a:buNone/>
-            </a:pPr>
             <a:r>
               <a:rPr lang="en-US" sz="700" dirty="0">
                 <a:solidFill>
@@ -8711,6 +8736,13 @@
             <a:prstDash val="solid"/>
           </a:ln>
         </p:spPr>
+        <p:txBody>
+          <a:bodyPr/>
+          <a:lstStyle/>
+          <a:p>
+            <a:endParaRPr lang="es-PE"/>
+          </a:p>
+        </p:txBody>
       </p:sp>
       <p:sp>
         <p:nvSpPr>
@@ -8733,7 +8765,7 @@
           <a:bodyPr wrap="square" lIns="0" tIns="0" rIns="0" bIns="0" rtlCol="0" anchor="ctr"/>
           <a:lstStyle/>
           <a:p>
-            <a:pPr algn="ctr" indent="0" marL="0">
+            <a:pPr marL="0" indent="0" algn="ctr">
               <a:lnSpc>
                 <a:spcPct val="100000"/>
               </a:lnSpc>
@@ -8751,12 +8783,6 @@
               <a:t>SEM 2
 </a:t>
             </a:r>
-            <a:pPr algn="ctr" indent="0" marL="0">
-              <a:lnSpc>
-                <a:spcPct val="100000"/>
-              </a:lnSpc>
-              <a:buNone/>
-            </a:pPr>
             <a:r>
               <a:rPr lang="en-US" sz="700" dirty="0">
                 <a:solidFill>
@@ -8798,6 +8824,13 @@
             <a:prstDash val="solid"/>
           </a:ln>
         </p:spPr>
+        <p:txBody>
+          <a:bodyPr/>
+          <a:lstStyle/>
+          <a:p>
+            <a:endParaRPr lang="es-PE"/>
+          </a:p>
+        </p:txBody>
       </p:sp>
       <p:sp>
         <p:nvSpPr>
@@ -8820,7 +8853,7 @@
           <a:bodyPr wrap="square" lIns="0" tIns="0" rIns="0" bIns="0" rtlCol="0" anchor="ctr"/>
           <a:lstStyle/>
           <a:p>
-            <a:pPr algn="ctr" indent="0" marL="0">
+            <a:pPr marL="0" indent="0" algn="ctr">
               <a:lnSpc>
                 <a:spcPct val="100000"/>
               </a:lnSpc>
@@ -8838,12 +8871,6 @@
               <a:t>SEM 3
 </a:t>
             </a:r>
-            <a:pPr algn="ctr" indent="0" marL="0">
-              <a:lnSpc>
-                <a:spcPct val="100000"/>
-              </a:lnSpc>
-              <a:buNone/>
-            </a:pPr>
             <a:r>
               <a:rPr lang="en-US" sz="700" dirty="0">
                 <a:solidFill>
@@ -8885,6 +8912,13 @@
             <a:prstDash val="solid"/>
           </a:ln>
         </p:spPr>
+        <p:txBody>
+          <a:bodyPr/>
+          <a:lstStyle/>
+          <a:p>
+            <a:endParaRPr lang="es-PE"/>
+          </a:p>
+        </p:txBody>
       </p:sp>
       <p:sp>
         <p:nvSpPr>
@@ -8907,7 +8941,7 @@
           <a:bodyPr wrap="square" lIns="0" tIns="0" rIns="0" bIns="0" rtlCol="0" anchor="ctr"/>
           <a:lstStyle/>
           <a:p>
-            <a:pPr algn="ctr" indent="0" marL="0">
+            <a:pPr marL="0" indent="0" algn="ctr">
               <a:lnSpc>
                 <a:spcPct val="100000"/>
               </a:lnSpc>
@@ -8925,12 +8959,6 @@
               <a:t>SEM 4
 </a:t>
             </a:r>
-            <a:pPr algn="ctr" indent="0" marL="0">
-              <a:lnSpc>
-                <a:spcPct val="100000"/>
-              </a:lnSpc>
-              <a:buNone/>
-            </a:pPr>
             <a:r>
               <a:rPr lang="en-US" sz="700" dirty="0">
                 <a:solidFill>
@@ -8972,6 +9000,13 @@
             <a:prstDash val="solid"/>
           </a:ln>
         </p:spPr>
+        <p:txBody>
+          <a:bodyPr/>
+          <a:lstStyle/>
+          <a:p>
+            <a:endParaRPr lang="es-PE"/>
+          </a:p>
+        </p:txBody>
       </p:sp>
       <p:sp>
         <p:nvSpPr>
@@ -8994,7 +9029,7 @@
           <a:bodyPr wrap="square" lIns="0" tIns="0" rIns="0" bIns="0" rtlCol="0" anchor="ctr"/>
           <a:lstStyle/>
           <a:p>
-            <a:pPr algn="ctr" indent="0" marL="0">
+            <a:pPr marL="0" indent="0" algn="ctr">
               <a:lnSpc>
                 <a:spcPct val="100000"/>
               </a:lnSpc>
@@ -9012,12 +9047,6 @@
               <a:t>SEM 5
 </a:t>
             </a:r>
-            <a:pPr algn="ctr" indent="0" marL="0">
-              <a:lnSpc>
-                <a:spcPct val="100000"/>
-              </a:lnSpc>
-              <a:buNone/>
-            </a:pPr>
             <a:r>
               <a:rPr lang="en-US" sz="700" dirty="0">
                 <a:solidFill>
@@ -9059,6 +9088,13 @@
             <a:prstDash val="solid"/>
           </a:ln>
         </p:spPr>
+        <p:txBody>
+          <a:bodyPr/>
+          <a:lstStyle/>
+          <a:p>
+            <a:endParaRPr lang="es-PE"/>
+          </a:p>
+        </p:txBody>
       </p:sp>
       <p:sp>
         <p:nvSpPr>
@@ -9081,7 +9117,7 @@
           <a:bodyPr wrap="square" lIns="0" tIns="0" rIns="0" bIns="0" rtlCol="0" anchor="ctr"/>
           <a:lstStyle/>
           <a:p>
-            <a:pPr algn="ctr" indent="0" marL="0">
+            <a:pPr marL="0" indent="0" algn="ctr">
               <a:lnSpc>
                 <a:spcPct val="100000"/>
               </a:lnSpc>
@@ -9099,12 +9135,6 @@
               <a:t>SEM 6
 </a:t>
             </a:r>
-            <a:pPr algn="ctr" indent="0" marL="0">
-              <a:lnSpc>
-                <a:spcPct val="100000"/>
-              </a:lnSpc>
-              <a:buNone/>
-            </a:pPr>
             <a:r>
               <a:rPr lang="en-US" sz="700" dirty="0">
                 <a:solidFill>
@@ -9146,6 +9176,13 @@
             <a:prstDash val="solid"/>
           </a:ln>
         </p:spPr>
+        <p:txBody>
+          <a:bodyPr/>
+          <a:lstStyle/>
+          <a:p>
+            <a:endParaRPr lang="es-PE"/>
+          </a:p>
+        </p:txBody>
       </p:sp>
       <p:sp>
         <p:nvSpPr>
@@ -9168,7 +9205,7 @@
           <a:bodyPr wrap="square" lIns="0" tIns="0" rIns="0" bIns="0" rtlCol="0" anchor="ctr"/>
           <a:lstStyle/>
           <a:p>
-            <a:pPr algn="ctr" indent="0" marL="0">
+            <a:pPr marL="0" indent="0" algn="ctr">
               <a:lnSpc>
                 <a:spcPct val="100000"/>
               </a:lnSpc>
@@ -9186,12 +9223,6 @@
               <a:t>SEM 7
 </a:t>
             </a:r>
-            <a:pPr algn="ctr" indent="0" marL="0">
-              <a:lnSpc>
-                <a:spcPct val="100000"/>
-              </a:lnSpc>
-              <a:buNone/>
-            </a:pPr>
             <a:r>
               <a:rPr lang="en-US" sz="700" dirty="0">
                 <a:solidFill>
@@ -9233,6 +9264,13 @@
             <a:prstDash val="solid"/>
           </a:ln>
         </p:spPr>
+        <p:txBody>
+          <a:bodyPr/>
+          <a:lstStyle/>
+          <a:p>
+            <a:endParaRPr lang="es-PE"/>
+          </a:p>
+        </p:txBody>
       </p:sp>
       <p:sp>
         <p:nvSpPr>
@@ -9255,7 +9293,7 @@
           <a:bodyPr wrap="square" lIns="0" tIns="0" rIns="0" bIns="0" rtlCol="0" anchor="ctr"/>
           <a:lstStyle/>
           <a:p>
-            <a:pPr algn="ctr" indent="0" marL="0">
+            <a:pPr marL="0" indent="0" algn="ctr">
               <a:lnSpc>
                 <a:spcPct val="100000"/>
               </a:lnSpc>
@@ -9273,12 +9311,6 @@
               <a:t>SEM 8
 </a:t>
             </a:r>
-            <a:pPr algn="ctr" indent="0" marL="0">
-              <a:lnSpc>
-                <a:spcPct val="100000"/>
-              </a:lnSpc>
-              <a:buNone/>
-            </a:pPr>
             <a:r>
               <a:rPr lang="en-US" sz="700" dirty="0">
                 <a:solidFill>
@@ -9320,6 +9352,13 @@
             <a:prstDash val="solid"/>
           </a:ln>
         </p:spPr>
+        <p:txBody>
+          <a:bodyPr/>
+          <a:lstStyle/>
+          <a:p>
+            <a:endParaRPr lang="es-PE"/>
+          </a:p>
+        </p:txBody>
       </p:sp>
       <p:sp>
         <p:nvSpPr>
@@ -9342,7 +9381,7 @@
           <a:bodyPr wrap="square" lIns="0" tIns="0" rIns="0" bIns="0" rtlCol="0" anchor="ctr"/>
           <a:lstStyle/>
           <a:p>
-            <a:pPr algn="l" indent="0" marL="0">
+            <a:pPr marL="0" indent="0" algn="l">
               <a:lnSpc>
                 <a:spcPct val="105000"/>
               </a:lnSpc>
@@ -9389,6 +9428,13 @@
             <a:prstDash val="solid"/>
           </a:ln>
         </p:spPr>
+        <p:txBody>
+          <a:bodyPr/>
+          <a:lstStyle/>
+          <a:p>
+            <a:endParaRPr lang="es-PE"/>
+          </a:p>
+        </p:txBody>
       </p:sp>
       <p:sp>
         <p:nvSpPr>
@@ -9411,7 +9457,7 @@
           <a:bodyPr wrap="square" lIns="0" tIns="0" rIns="0" bIns="0" rtlCol="0" anchor="ctr"/>
           <a:lstStyle/>
           <a:p>
-            <a:pPr algn="l" indent="0" marL="0">
+            <a:pPr marL="0" indent="0" algn="l">
               <a:lnSpc>
                 <a:spcPct val="105000"/>
               </a:lnSpc>
@@ -9458,6 +9504,13 @@
             <a:prstDash val="solid"/>
           </a:ln>
         </p:spPr>
+        <p:txBody>
+          <a:bodyPr/>
+          <a:lstStyle/>
+          <a:p>
+            <a:endParaRPr lang="es-PE"/>
+          </a:p>
+        </p:txBody>
       </p:sp>
       <p:sp>
         <p:nvSpPr>
@@ -9480,7 +9533,7 @@
           <a:bodyPr wrap="square" lIns="0" tIns="0" rIns="0" bIns="0" rtlCol="0" anchor="ctr"/>
           <a:lstStyle/>
           <a:p>
-            <a:pPr algn="l" indent="0" marL="0">
+            <a:pPr marL="0" indent="0" algn="l">
               <a:lnSpc>
                 <a:spcPct val="105000"/>
               </a:lnSpc>
@@ -9527,6 +9580,13 @@
             <a:prstDash val="solid"/>
           </a:ln>
         </p:spPr>
+        <p:txBody>
+          <a:bodyPr/>
+          <a:lstStyle/>
+          <a:p>
+            <a:endParaRPr lang="es-PE"/>
+          </a:p>
+        </p:txBody>
       </p:sp>
       <p:sp>
         <p:nvSpPr>
@@ -9549,7 +9609,7 @@
           <a:bodyPr wrap="square" lIns="0" tIns="0" rIns="0" bIns="0" rtlCol="0" anchor="ctr"/>
           <a:lstStyle/>
           <a:p>
-            <a:pPr algn="l" indent="0" marL="0">
+            <a:pPr marL="0" indent="0" algn="l">
               <a:lnSpc>
                 <a:spcPct val="105000"/>
               </a:lnSpc>
@@ -9596,6 +9656,13 @@
             <a:prstDash val="solid"/>
           </a:ln>
         </p:spPr>
+        <p:txBody>
+          <a:bodyPr/>
+          <a:lstStyle/>
+          <a:p>
+            <a:endParaRPr lang="es-PE"/>
+          </a:p>
+        </p:txBody>
       </p:sp>
       <p:sp>
         <p:nvSpPr>
@@ -9618,7 +9685,7 @@
           <a:bodyPr wrap="square" lIns="0" tIns="0" rIns="0" bIns="0" rtlCol="0" anchor="ctr"/>
           <a:lstStyle/>
           <a:p>
-            <a:pPr algn="l" indent="0" marL="0">
+            <a:pPr marL="0" indent="0" algn="l">
               <a:lnSpc>
                 <a:spcPct val="105000"/>
               </a:lnSpc>
@@ -9665,6 +9732,13 @@
             <a:prstDash val="solid"/>
           </a:ln>
         </p:spPr>
+        <p:txBody>
+          <a:bodyPr/>
+          <a:lstStyle/>
+          <a:p>
+            <a:endParaRPr lang="es-PE"/>
+          </a:p>
+        </p:txBody>
       </p:sp>
       <p:sp>
         <p:nvSpPr>
@@ -9687,7 +9761,7 @@
           <a:bodyPr wrap="square" lIns="0" tIns="0" rIns="0" bIns="0" rtlCol="0" anchor="ctr"/>
           <a:lstStyle/>
           <a:p>
-            <a:pPr algn="l" indent="0" marL="0">
+            <a:pPr marL="0" indent="0" algn="l">
               <a:lnSpc>
                 <a:spcPct val="105000"/>
               </a:lnSpc>
@@ -9734,6 +9808,13 @@
             <a:prstDash val="solid"/>
           </a:ln>
         </p:spPr>
+        <p:txBody>
+          <a:bodyPr/>
+          <a:lstStyle/>
+          <a:p>
+            <a:endParaRPr lang="es-PE"/>
+          </a:p>
+        </p:txBody>
       </p:sp>
       <p:sp>
         <p:nvSpPr>
@@ -9756,7 +9837,7 @@
           <a:bodyPr wrap="square" lIns="0" tIns="0" rIns="0" bIns="0" rtlCol="0" anchor="ctr"/>
           <a:lstStyle/>
           <a:p>
-            <a:pPr algn="l" indent="0" marL="0">
+            <a:pPr marL="0" indent="0" algn="l">
               <a:lnSpc>
                 <a:spcPct val="105000"/>
               </a:lnSpc>
@@ -9803,6 +9884,13 @@
             <a:prstDash val="solid"/>
           </a:ln>
         </p:spPr>
+        <p:txBody>
+          <a:bodyPr/>
+          <a:lstStyle/>
+          <a:p>
+            <a:endParaRPr lang="es-PE"/>
+          </a:p>
+        </p:txBody>
       </p:sp>
       <p:sp>
         <p:nvSpPr>
@@ -9825,7 +9913,7 @@
           <a:bodyPr wrap="square" lIns="0" tIns="0" rIns="0" bIns="0" rtlCol="0" anchor="ctr"/>
           <a:lstStyle/>
           <a:p>
-            <a:pPr algn="l" indent="0" marL="0">
+            <a:pPr marL="0" indent="0" algn="l">
               <a:lnSpc>
                 <a:spcPct val="105000"/>
               </a:lnSpc>
@@ -9872,6 +9960,13 @@
             <a:prstDash val="solid"/>
           </a:ln>
         </p:spPr>
+        <p:txBody>
+          <a:bodyPr/>
+          <a:lstStyle/>
+          <a:p>
+            <a:endParaRPr lang="es-PE"/>
+          </a:p>
+        </p:txBody>
       </p:sp>
       <p:sp>
         <p:nvSpPr>
@@ -9894,7 +9989,7 @@
           <a:bodyPr wrap="square" lIns="0" tIns="0" rIns="0" bIns="0" rtlCol="0" anchor="ctr"/>
           <a:lstStyle/>
           <a:p>
-            <a:pPr algn="l" indent="0" marL="0">
+            <a:pPr marL="0" indent="0" algn="ctr">
               <a:lnSpc>
                 <a:spcPct val="105000"/>
               </a:lnSpc>
@@ -9941,6 +10036,13 @@
             <a:prstDash val="solid"/>
           </a:ln>
         </p:spPr>
+        <p:txBody>
+          <a:bodyPr/>
+          <a:lstStyle/>
+          <a:p>
+            <a:endParaRPr lang="es-PE"/>
+          </a:p>
+        </p:txBody>
       </p:sp>
       <p:sp>
         <p:nvSpPr>
@@ -9963,7 +10065,7 @@
           <a:bodyPr wrap="square" lIns="0" tIns="0" rIns="0" bIns="0" rtlCol="0" anchor="ctr"/>
           <a:lstStyle/>
           <a:p>
-            <a:pPr algn="l" indent="0" marL="0">
+            <a:pPr marL="0" indent="0" algn="ctr">
               <a:lnSpc>
                 <a:spcPct val="105000"/>
               </a:lnSpc>
@@ -10010,6 +10112,13 @@
             <a:prstDash val="solid"/>
           </a:ln>
         </p:spPr>
+        <p:txBody>
+          <a:bodyPr/>
+          <a:lstStyle/>
+          <a:p>
+            <a:endParaRPr lang="es-PE"/>
+          </a:p>
+        </p:txBody>
       </p:sp>
       <p:sp>
         <p:nvSpPr>
@@ -10032,7 +10141,7 @@
           <a:bodyPr wrap="square" lIns="0" tIns="0" rIns="0" bIns="0" rtlCol="0" anchor="ctr"/>
           <a:lstStyle/>
           <a:p>
-            <a:pPr algn="l" indent="0" marL="0">
+            <a:pPr marL="0" indent="0" algn="ctr">
               <a:lnSpc>
                 <a:spcPct val="105000"/>
               </a:lnSpc>
@@ -10079,6 +10188,13 @@
             <a:prstDash val="solid"/>
           </a:ln>
         </p:spPr>
+        <p:txBody>
+          <a:bodyPr/>
+          <a:lstStyle/>
+          <a:p>
+            <a:endParaRPr lang="es-PE"/>
+          </a:p>
+        </p:txBody>
       </p:sp>
       <p:sp>
         <p:nvSpPr>
@@ -10101,7 +10217,7 @@
           <a:bodyPr wrap="square" lIns="0" tIns="0" rIns="0" bIns="0" rtlCol="0" anchor="ctr"/>
           <a:lstStyle/>
           <a:p>
-            <a:pPr algn="l" indent="0" marL="0">
+            <a:pPr marL="0" indent="0" algn="l">
               <a:lnSpc>
                 <a:spcPct val="105000"/>
               </a:lnSpc>
@@ -10148,6 +10264,13 @@
             <a:prstDash val="solid"/>
           </a:ln>
         </p:spPr>
+        <p:txBody>
+          <a:bodyPr/>
+          <a:lstStyle/>
+          <a:p>
+            <a:endParaRPr lang="es-PE"/>
+          </a:p>
+        </p:txBody>
       </p:sp>
       <p:sp>
         <p:nvSpPr>
@@ -10170,7 +10293,7 @@
           <a:bodyPr wrap="square" lIns="0" tIns="0" rIns="0" bIns="0" rtlCol="0" anchor="ctr"/>
           <a:lstStyle/>
           <a:p>
-            <a:pPr algn="l" indent="0" marL="0">
+            <a:pPr marL="0" indent="0" algn="l">
               <a:lnSpc>
                 <a:spcPct val="105000"/>
               </a:lnSpc>
@@ -10217,6 +10340,13 @@
             <a:prstDash val="solid"/>
           </a:ln>
         </p:spPr>
+        <p:txBody>
+          <a:bodyPr/>
+          <a:lstStyle/>
+          <a:p>
+            <a:endParaRPr lang="es-PE"/>
+          </a:p>
+        </p:txBody>
       </p:sp>
       <p:sp>
         <p:nvSpPr>
@@ -10239,7 +10369,7 @@
           <a:bodyPr wrap="square" lIns="0" tIns="0" rIns="0" bIns="0" rtlCol="0" anchor="ctr"/>
           <a:lstStyle/>
           <a:p>
-            <a:pPr algn="l" indent="0" marL="0">
+            <a:pPr marL="0" indent="0" algn="l">
               <a:buNone/>
             </a:pPr>
             <a:r>
@@ -10283,6 +10413,13 @@
             <a:prstDash val="solid"/>
           </a:ln>
         </p:spPr>
+        <p:txBody>
+          <a:bodyPr/>
+          <a:lstStyle/>
+          <a:p>
+            <a:endParaRPr lang="es-PE"/>
+          </a:p>
+        </p:txBody>
       </p:sp>
       <p:sp>
         <p:nvSpPr>
@@ -10305,7 +10442,7 @@
           <a:bodyPr wrap="square" lIns="0" tIns="0" rIns="0" bIns="0" rtlCol="0" anchor="ctr"/>
           <a:lstStyle/>
           <a:p>
-            <a:pPr algn="l" indent="0" marL="0">
+            <a:pPr marL="0" indent="0" algn="l">
               <a:buNone/>
             </a:pPr>
             <a:r>
@@ -10349,6 +10486,13 @@
             <a:prstDash val="solid"/>
           </a:ln>
         </p:spPr>
+        <p:txBody>
+          <a:bodyPr/>
+          <a:lstStyle/>
+          <a:p>
+            <a:endParaRPr lang="es-PE"/>
+          </a:p>
+        </p:txBody>
       </p:sp>
       <p:sp>
         <p:nvSpPr>
@@ -10371,7 +10515,7 @@
           <a:bodyPr wrap="square" lIns="0" tIns="0" rIns="0" bIns="0" rtlCol="0" anchor="ctr"/>
           <a:lstStyle/>
           <a:p>
-            <a:pPr algn="l" indent="0" marL="0">
+            <a:pPr marL="0" indent="0" algn="l">
               <a:buNone/>
             </a:pPr>
             <a:r>
@@ -10391,14 +10535,14 @@
       </p:sp>
       <p:pic>
         <p:nvPicPr>
-          <p:cNvPr id="65" name="Image 1" descr="preencoded.png">    </p:cNvPr>
+          <p:cNvPr id="65" name="Image 1" descr="preencoded.png"/>
           <p:cNvPicPr>
             <a:picLocks noChangeAspect="1"/>
           </p:cNvPicPr>
           <p:nvPr/>
         </p:nvPicPr>
         <p:blipFill>
-          <a:blip r:embed="rId2"/>
+          <a:blip r:embed="rId3"/>
           <a:stretch>
             <a:fillRect/>
           </a:stretch>
@@ -10434,7 +10578,7 @@
           <a:bodyPr wrap="square" lIns="0" tIns="0" rIns="0" bIns="0" rtlCol="0" anchor="ctr"/>
           <a:lstStyle/>
           <a:p>
-            <a:pPr indent="0" marL="0">
+            <a:pPr marL="0" indent="0">
               <a:buNone/>
             </a:pPr>
             <a:r>
@@ -10473,7 +10617,7 @@
           <a:bodyPr wrap="square" lIns="0" tIns="0" rIns="0" bIns="0" rtlCol="0" anchor="ctr"/>
           <a:lstStyle/>
           <a:p>
-            <a:pPr algn="r" indent="0" marL="0">
+            <a:pPr marL="0" indent="0" algn="r">
               <a:buNone/>
             </a:pPr>
             <a:r>
@@ -10507,6 +10651,7 @@
         <a:solidFill>
           <a:srgbClr val="070F26"/>
         </a:solidFill>
+        <a:effectLst/>
       </p:bgPr>
     </p:bg>
     <p:spTree>
@@ -10525,14 +10670,14 @@
       </p:grpSpPr>
       <p:pic>
         <p:nvPicPr>
-          <p:cNvPr id="2" name="Image 0" descr="preencoded.png">    </p:cNvPr>
+          <p:cNvPr id="2" name="Image 0" descr="preencoded.png"/>
           <p:cNvPicPr>
             <a:picLocks noChangeAspect="1"/>
           </p:cNvPicPr>
           <p:nvPr/>
         </p:nvPicPr>
         <p:blipFill>
-          <a:blip r:embed="rId1"/>
+          <a:blip r:embed="rId3"/>
           <a:stretch>
             <a:fillRect/>
           </a:stretch>
@@ -10570,7 +10715,7 @@
           </a:bodyPr>
           <a:lstStyle/>
           <a:p>
-            <a:pPr algn="l" indent="0" marL="0">
+            <a:pPr marL="0" indent="0" algn="l">
               <a:buNone/>
             </a:pPr>
             <a:r>
@@ -10612,6 +10757,13 @@
             <a:prstDash val="solid"/>
           </a:ln>
         </p:spPr>
+        <p:txBody>
+          <a:bodyPr/>
+          <a:lstStyle/>
+          <a:p>
+            <a:endParaRPr lang="es-PE"/>
+          </a:p>
+        </p:txBody>
       </p:sp>
       <p:sp>
         <p:nvSpPr>
@@ -10639,6 +10791,13 @@
             <a:prstDash val="solid"/>
           </a:ln>
         </p:spPr>
+        <p:txBody>
+          <a:bodyPr/>
+          <a:lstStyle/>
+          <a:p>
+            <a:endParaRPr lang="es-PE"/>
+          </a:p>
+        </p:txBody>
       </p:sp>
       <p:sp>
         <p:nvSpPr>
@@ -10664,6 +10823,13 @@
             <a:prstDash val="solid"/>
           </a:ln>
         </p:spPr>
+        <p:txBody>
+          <a:bodyPr/>
+          <a:lstStyle/>
+          <a:p>
+            <a:endParaRPr lang="es-PE"/>
+          </a:p>
+        </p:txBody>
       </p:sp>
       <p:sp>
         <p:nvSpPr>
@@ -10686,7 +10852,7 @@
           <a:bodyPr wrap="square" lIns="0" tIns="0" rIns="0" bIns="0" rtlCol="0" anchor="ctr"/>
           <a:lstStyle/>
           <a:p>
-            <a:pPr algn="ctr" indent="0" marL="0">
+            <a:pPr marL="0" indent="0" algn="ctr">
               <a:buNone/>
             </a:pPr>
             <a:r>
@@ -10725,7 +10891,7 @@
           <a:bodyPr wrap="square" lIns="0" tIns="0" rIns="0" bIns="0" rtlCol="0" anchor="ctr"/>
           <a:lstStyle/>
           <a:p>
-            <a:pPr algn="l" indent="0" marL="0">
+            <a:pPr marL="0" indent="0" algn="l">
               <a:buNone/>
             </a:pPr>
             <a:r>
@@ -10764,7 +10930,7 @@
           <a:bodyPr wrap="square" lIns="381" tIns="381" rIns="381" bIns="381" rtlCol="0" anchor="ctr"/>
           <a:lstStyle/>
           <a:p>
-            <a:pPr algn="l" indent="0" marL="0">
+            <a:pPr marL="0" indent="0" algn="l">
               <a:lnSpc>
                 <a:spcPct val="108000"/>
               </a:lnSpc>
@@ -10811,6 +10977,13 @@
             <a:prstDash val="solid"/>
           </a:ln>
         </p:spPr>
+        <p:txBody>
+          <a:bodyPr/>
+          <a:lstStyle/>
+          <a:p>
+            <a:endParaRPr lang="es-PE"/>
+          </a:p>
+        </p:txBody>
       </p:sp>
       <p:sp>
         <p:nvSpPr>
@@ -10836,6 +11009,13 @@
             <a:prstDash val="solid"/>
           </a:ln>
         </p:spPr>
+        <p:txBody>
+          <a:bodyPr/>
+          <a:lstStyle/>
+          <a:p>
+            <a:endParaRPr lang="es-PE"/>
+          </a:p>
+        </p:txBody>
       </p:sp>
       <p:sp>
         <p:nvSpPr>
@@ -10858,7 +11038,7 @@
           <a:bodyPr wrap="square" lIns="0" tIns="0" rIns="0" bIns="0" rtlCol="0" anchor="ctr"/>
           <a:lstStyle/>
           <a:p>
-            <a:pPr algn="ctr" indent="0" marL="0">
+            <a:pPr marL="0" indent="0" algn="ctr">
               <a:buNone/>
             </a:pPr>
             <a:r>
@@ -10897,7 +11077,7 @@
           <a:bodyPr wrap="square" lIns="0" tIns="0" rIns="0" bIns="0" rtlCol="0" anchor="ctr"/>
           <a:lstStyle/>
           <a:p>
-            <a:pPr algn="l" indent="0" marL="0">
+            <a:pPr marL="0" indent="0" algn="l">
               <a:buNone/>
             </a:pPr>
             <a:r>
@@ -10936,7 +11116,7 @@
           <a:bodyPr wrap="square" lIns="381" tIns="381" rIns="381" bIns="381" rtlCol="0" anchor="ctr"/>
           <a:lstStyle/>
           <a:p>
-            <a:pPr algn="l" indent="0" marL="0">
+            <a:pPr marL="0" indent="0" algn="l">
               <a:lnSpc>
                 <a:spcPct val="108000"/>
               </a:lnSpc>
@@ -10983,6 +11163,13 @@
             <a:prstDash val="solid"/>
           </a:ln>
         </p:spPr>
+        <p:txBody>
+          <a:bodyPr/>
+          <a:lstStyle/>
+          <a:p>
+            <a:endParaRPr lang="es-PE"/>
+          </a:p>
+        </p:txBody>
       </p:sp>
       <p:sp>
         <p:nvSpPr>
@@ -11008,6 +11195,13 @@
             <a:prstDash val="solid"/>
           </a:ln>
         </p:spPr>
+        <p:txBody>
+          <a:bodyPr/>
+          <a:lstStyle/>
+          <a:p>
+            <a:endParaRPr lang="es-PE"/>
+          </a:p>
+        </p:txBody>
       </p:sp>
       <p:sp>
         <p:nvSpPr>
@@ -11030,7 +11224,7 @@
           <a:bodyPr wrap="square" lIns="0" tIns="0" rIns="0" bIns="0" rtlCol="0" anchor="ctr"/>
           <a:lstStyle/>
           <a:p>
-            <a:pPr algn="ctr" indent="0" marL="0">
+            <a:pPr marL="0" indent="0" algn="ctr">
               <a:buNone/>
             </a:pPr>
             <a:r>
@@ -11069,7 +11263,7 @@
           <a:bodyPr wrap="square" lIns="0" tIns="0" rIns="0" bIns="0" rtlCol="0" anchor="ctr"/>
           <a:lstStyle/>
           <a:p>
-            <a:pPr algn="l" indent="0" marL="0">
+            <a:pPr marL="0" indent="0" algn="l">
               <a:buNone/>
             </a:pPr>
             <a:r>
@@ -11108,7 +11302,7 @@
           <a:bodyPr wrap="square" lIns="381" tIns="381" rIns="381" bIns="381" rtlCol="0" anchor="ctr"/>
           <a:lstStyle/>
           <a:p>
-            <a:pPr algn="l" indent="0" marL="0">
+            <a:pPr marL="0" indent="0" algn="l">
               <a:lnSpc>
                 <a:spcPct val="108000"/>
               </a:lnSpc>
@@ -11155,6 +11349,13 @@
             <a:prstDash val="solid"/>
           </a:ln>
         </p:spPr>
+        <p:txBody>
+          <a:bodyPr/>
+          <a:lstStyle/>
+          <a:p>
+            <a:endParaRPr lang="es-PE"/>
+          </a:p>
+        </p:txBody>
       </p:sp>
       <p:sp>
         <p:nvSpPr>
@@ -11180,6 +11381,13 @@
             <a:prstDash val="solid"/>
           </a:ln>
         </p:spPr>
+        <p:txBody>
+          <a:bodyPr/>
+          <a:lstStyle/>
+          <a:p>
+            <a:endParaRPr lang="es-PE"/>
+          </a:p>
+        </p:txBody>
       </p:sp>
       <p:sp>
         <p:nvSpPr>
@@ -11202,7 +11410,7 @@
           <a:bodyPr wrap="square" lIns="0" tIns="0" rIns="0" bIns="0" rtlCol="0" anchor="ctr"/>
           <a:lstStyle/>
           <a:p>
-            <a:pPr algn="ctr" indent="0" marL="0">
+            <a:pPr marL="0" indent="0" algn="ctr">
               <a:buNone/>
             </a:pPr>
             <a:r>
@@ -11241,7 +11449,7 @@
           <a:bodyPr wrap="square" lIns="0" tIns="0" rIns="0" bIns="0" rtlCol="0" anchor="ctr"/>
           <a:lstStyle/>
           <a:p>
-            <a:pPr algn="l" indent="0" marL="0">
+            <a:pPr marL="0" indent="0" algn="l">
               <a:buNone/>
             </a:pPr>
             <a:r>
@@ -11280,7 +11488,7 @@
           <a:bodyPr wrap="square" lIns="381" tIns="381" rIns="381" bIns="381" rtlCol="0" anchor="ctr"/>
           <a:lstStyle/>
           <a:p>
-            <a:pPr algn="l" indent="0" marL="0">
+            <a:pPr marL="0" indent="0" algn="l">
               <a:lnSpc>
                 <a:spcPct val="108000"/>
               </a:lnSpc>
@@ -11303,14 +11511,14 @@
       </p:sp>
       <p:pic>
         <p:nvPicPr>
-          <p:cNvPr id="25" name="Image 1" descr="preencoded.png">    </p:cNvPr>
+          <p:cNvPr id="25" name="Image 1" descr="preencoded.png"/>
           <p:cNvPicPr>
             <a:picLocks noChangeAspect="1"/>
           </p:cNvPicPr>
           <p:nvPr/>
         </p:nvPicPr>
         <p:blipFill>
-          <a:blip r:embed="rId2"/>
+          <a:blip r:embed="rId3"/>
           <a:stretch>
             <a:fillRect/>
           </a:stretch>
@@ -11346,7 +11554,7 @@
           <a:bodyPr wrap="square" lIns="0" tIns="0" rIns="0" bIns="0" rtlCol="0" anchor="ctr"/>
           <a:lstStyle/>
           <a:p>
-            <a:pPr indent="0" marL="0">
+            <a:pPr marL="0" indent="0">
               <a:buNone/>
             </a:pPr>
             <a:r>
@@ -11385,7 +11593,7 @@
           <a:bodyPr wrap="square" lIns="0" tIns="0" rIns="0" bIns="0" rtlCol="0" anchor="ctr"/>
           <a:lstStyle/>
           <a:p>
-            <a:pPr algn="r" indent="0" marL="0">
+            <a:pPr marL="0" indent="0" algn="r">
               <a:buNone/>
             </a:pPr>
             <a:r>
@@ -11419,6 +11627,7 @@
         <a:solidFill>
           <a:srgbClr val="070F26"/>
         </a:solidFill>
+        <a:effectLst/>
       </p:bgPr>
     </p:bg>
     <p:spTree>
@@ -11437,14 +11646,14 @@
       </p:grpSpPr>
       <p:pic>
         <p:nvPicPr>
-          <p:cNvPr id="2" name="Image 0" descr="preencoded.png">    </p:cNvPr>
+          <p:cNvPr id="2" name="Image 0" descr="preencoded.png"/>
           <p:cNvPicPr>
             <a:picLocks noChangeAspect="1"/>
           </p:cNvPicPr>
           <p:nvPr/>
         </p:nvPicPr>
         <p:blipFill>
-          <a:blip r:embed="rId1"/>
+          <a:blip r:embed="rId3"/>
           <a:stretch>
             <a:fillRect/>
           </a:stretch>
@@ -11480,7 +11689,7 @@
           <a:bodyPr wrap="square" lIns="0" tIns="0" rIns="0" bIns="0" rtlCol="0" anchor="ctr"/>
           <a:lstStyle/>
           <a:p>
-            <a:pPr algn="ctr" indent="0" marL="0">
+            <a:pPr marL="0" indent="0" algn="ctr">
               <a:buNone/>
             </a:pPr>
             <a:r>
@@ -11519,7 +11728,7 @@
           <a:bodyPr wrap="square" lIns="0" tIns="0" rIns="0" bIns="0" rtlCol="0" anchor="ctr"/>
           <a:lstStyle/>
           <a:p>
-            <a:pPr algn="ctr" indent="0" marL="0">
+            <a:pPr marL="0" indent="0" algn="ctr">
               <a:buNone/>
             </a:pPr>
             <a:r>
@@ -11563,6 +11772,13 @@
             <a:prstDash val="solid"/>
           </a:ln>
         </p:spPr>
+        <p:txBody>
+          <a:bodyPr/>
+          <a:lstStyle/>
+          <a:p>
+            <a:endParaRPr lang="es-PE"/>
+          </a:p>
+        </p:txBody>
       </p:sp>
       <p:sp>
         <p:nvSpPr>
@@ -11585,7 +11801,7 @@
           <a:bodyPr wrap="square" lIns="0" tIns="0" rIns="0" bIns="0" rtlCol="0" anchor="ctr"/>
           <a:lstStyle/>
           <a:p>
-            <a:pPr algn="ctr" indent="0" marL="0">
+            <a:pPr marL="0" indent="0" algn="ctr">
               <a:buNone/>
             </a:pPr>
             <a:r>
@@ -11629,6 +11845,13 @@
             <a:prstDash val="solid"/>
           </a:ln>
         </p:spPr>
+        <p:txBody>
+          <a:bodyPr/>
+          <a:lstStyle/>
+          <a:p>
+            <a:endParaRPr lang="es-PE"/>
+          </a:p>
+        </p:txBody>
       </p:sp>
       <p:sp>
         <p:nvSpPr>
@@ -11656,17 +11879,24 @@
             <a:prstDash val="solid"/>
           </a:ln>
         </p:spPr>
+        <p:txBody>
+          <a:bodyPr/>
+          <a:lstStyle/>
+          <a:p>
+            <a:endParaRPr lang="es-PE"/>
+          </a:p>
+        </p:txBody>
       </p:sp>
       <p:pic>
         <p:nvPicPr>
-          <p:cNvPr id="9" name="Image 1" descr="preencoded.png">    </p:cNvPr>
+          <p:cNvPr id="9" name="Image 1" descr="preencoded.png"/>
           <p:cNvPicPr>
             <a:picLocks noChangeAspect="1"/>
           </p:cNvPicPr>
           <p:nvPr/>
         </p:nvPicPr>
         <p:blipFill>
-          <a:blip r:embed="rId2"/>
+          <a:blip r:embed="rId3"/>
           <a:stretch>
             <a:fillRect/>
           </a:stretch>
@@ -11702,7 +11932,7 @@
           <a:bodyPr wrap="square" lIns="0" tIns="0" rIns="0" bIns="0" rtlCol="0" anchor="ctr"/>
           <a:lstStyle/>
           <a:p>
-            <a:pPr indent="0" marL="0">
+            <a:pPr marL="0" indent="0">
               <a:buNone/>
             </a:pPr>
             <a:r>
@@ -11741,7 +11971,7 @@
           <a:bodyPr wrap="square" lIns="0" tIns="0" rIns="0" bIns="0" rtlCol="0" anchor="ctr"/>
           <a:lstStyle/>
           <a:p>
-            <a:pPr algn="r" indent="0" marL="0">
+            <a:pPr marL="0" indent="0" algn="r">
               <a:buNone/>
             </a:pPr>
             <a:r>
@@ -12060,4 +12290,319 @@
     </a:ext>
   </a:extLst>
 </a:theme>
+</file>
+
+<file path=ppt/theme/theme2.xml><?xml version="1.0" encoding="utf-8"?>
+<a:theme xmlns:a="http://schemas.openxmlformats.org/drawingml/2006/main" name="Tema de Office">
+  <a:themeElements>
+    <a:clrScheme name="Office">
+      <a:dk1>
+        <a:sysClr val="windowText" lastClr="000000"/>
+      </a:dk1>
+      <a:lt1>
+        <a:sysClr val="window" lastClr="FFFFFF"/>
+      </a:lt1>
+      <a:dk2>
+        <a:srgbClr val="0E2841"/>
+      </a:dk2>
+      <a:lt2>
+        <a:srgbClr val="E8E8E8"/>
+      </a:lt2>
+      <a:accent1>
+        <a:srgbClr val="156082"/>
+      </a:accent1>
+      <a:accent2>
+        <a:srgbClr val="E97132"/>
+      </a:accent2>
+      <a:accent3>
+        <a:srgbClr val="196B24"/>
+      </a:accent3>
+      <a:accent4>
+        <a:srgbClr val="0F9ED5"/>
+      </a:accent4>
+      <a:accent5>
+        <a:srgbClr val="A02B93"/>
+      </a:accent5>
+      <a:accent6>
+        <a:srgbClr val="4EA72E"/>
+      </a:accent6>
+      <a:hlink>
+        <a:srgbClr val="467886"/>
+      </a:hlink>
+      <a:folHlink>
+        <a:srgbClr val="96607D"/>
+      </a:folHlink>
+    </a:clrScheme>
+    <a:fontScheme name="Office">
+      <a:majorFont>
+        <a:latin typeface="Aptos Display" panose="02110004020202020204"/>
+        <a:ea typeface=""/>
+        <a:cs typeface=""/>
+        <a:font script="Jpan" typeface="游ゴシック Light"/>
+        <a:font script="Hang" typeface="맑은 고딕"/>
+        <a:font script="Hans" typeface="等线 Light"/>
+        <a:font script="Hant" typeface="新細明體"/>
+        <a:font script="Arab" typeface="Times New Roman"/>
+        <a:font script="Hebr" typeface="Times New Roman"/>
+        <a:font script="Thai" typeface="Angsana New"/>
+        <a:font script="Ethi" typeface="Nyala"/>
+        <a:font script="Beng" typeface="Vrinda"/>
+        <a:font script="Gujr" typeface="Shruti"/>
+        <a:font script="Khmr" typeface="MoolBoran"/>
+        <a:font script="Knda" typeface="Tunga"/>
+        <a:font script="Guru" typeface="Raavi"/>
+        <a:font script="Cans" typeface="Euphemia"/>
+        <a:font script="Cher" typeface="Plantagenet Cherokee"/>
+        <a:font script="Yiii" typeface="Microsoft Yi Baiti"/>
+        <a:font script="Tibt" typeface="Microsoft Himalaya"/>
+        <a:font script="Thaa" typeface="MV Boli"/>
+        <a:font script="Deva" typeface="Mangal"/>
+        <a:font script="Telu" typeface="Gautami"/>
+        <a:font script="Taml" typeface="Latha"/>
+        <a:font script="Syrc" typeface="Estrangelo Edessa"/>
+        <a:font script="Orya" typeface="Kalinga"/>
+        <a:font script="Mlym" typeface="Kartika"/>
+        <a:font script="Laoo" typeface="DokChampa"/>
+        <a:font script="Sinh" typeface="Iskoola Pota"/>
+        <a:font script="Mong" typeface="Mongolian Baiti"/>
+        <a:font script="Viet" typeface="Times New Roman"/>
+        <a:font script="Uigh" typeface="Microsoft Uighur"/>
+        <a:font script="Geor" typeface="Sylfaen"/>
+        <a:font script="Armn" typeface="Arial"/>
+        <a:font script="Bugi" typeface="Leelawadee UI"/>
+        <a:font script="Bopo" typeface="Microsoft JhengHei"/>
+        <a:font script="Java" typeface="Javanese Text"/>
+        <a:font script="Lisu" typeface="Segoe UI"/>
+        <a:font script="Mymr" typeface="Myanmar Text"/>
+        <a:font script="Nkoo" typeface="Ebrima"/>
+        <a:font script="Olck" typeface="Nirmala UI"/>
+        <a:font script="Osma" typeface="Ebrima"/>
+        <a:font script="Phag" typeface="Phagspa"/>
+        <a:font script="Syrn" typeface="Estrangelo Edessa"/>
+        <a:font script="Syrj" typeface="Estrangelo Edessa"/>
+        <a:font script="Syre" typeface="Estrangelo Edessa"/>
+        <a:font script="Sora" typeface="Nirmala UI"/>
+        <a:font script="Tale" typeface="Microsoft Tai Le"/>
+        <a:font script="Talu" typeface="Microsoft New Tai Lue"/>
+        <a:font script="Tfng" typeface="Ebrima"/>
+      </a:majorFont>
+      <a:minorFont>
+        <a:latin typeface="Aptos" panose="02110004020202020204"/>
+        <a:ea typeface=""/>
+        <a:cs typeface=""/>
+        <a:font script="Jpan" typeface="游ゴシック"/>
+        <a:font script="Hang" typeface="맑은 고딕"/>
+        <a:font script="Hans" typeface="等线"/>
+        <a:font script="Hant" typeface="新細明體"/>
+        <a:font script="Arab" typeface="Arial"/>
+        <a:font script="Hebr" typeface="Arial"/>
+        <a:font script="Thai" typeface="Cordia New"/>
+        <a:font script="Ethi" typeface="Nyala"/>
+        <a:font script="Beng" typeface="Vrinda"/>
+        <a:font script="Gujr" typeface="Shruti"/>
+        <a:font script="Khmr" typeface="DaunPenh"/>
+        <a:font script="Knda" typeface="Tunga"/>
+        <a:font script="Guru" typeface="Raavi"/>
+        <a:font script="Cans" typeface="Euphemia"/>
+        <a:font script="Cher" typeface="Plantagenet Cherokee"/>
+        <a:font script="Yiii" typeface="Microsoft Yi Baiti"/>
+        <a:font script="Tibt" typeface="Microsoft Himalaya"/>
+        <a:font script="Thaa" typeface="MV Boli"/>
+        <a:font script="Deva" typeface="Mangal"/>
+        <a:font script="Telu" typeface="Gautami"/>
+        <a:font script="Taml" typeface="Latha"/>
+        <a:font script="Syrc" typeface="Estrangelo Edessa"/>
+        <a:font script="Orya" typeface="Kalinga"/>
+        <a:font script="Mlym" typeface="Kartika"/>
+        <a:font script="Laoo" typeface="DokChampa"/>
+        <a:font script="Sinh" typeface="Iskoola Pota"/>
+        <a:font script="Mong" typeface="Mongolian Baiti"/>
+        <a:font script="Viet" typeface="Arial"/>
+        <a:font script="Uigh" typeface="Microsoft Uighur"/>
+        <a:font script="Geor" typeface="Sylfaen"/>
+        <a:font script="Armn" typeface="Arial"/>
+        <a:font script="Bugi" typeface="Leelawadee UI"/>
+        <a:font script="Bopo" typeface="Microsoft JhengHei"/>
+        <a:font script="Java" typeface="Javanese Text"/>
+        <a:font script="Lisu" typeface="Segoe UI"/>
+        <a:font script="Mymr" typeface="Myanmar Text"/>
+        <a:font script="Nkoo" typeface="Ebrima"/>
+        <a:font script="Olck" typeface="Nirmala UI"/>
+        <a:font script="Osma" typeface="Ebrima"/>
+        <a:font script="Phag" typeface="Phagspa"/>
+        <a:font script="Syrn" typeface="Estrangelo Edessa"/>
+        <a:font script="Syrj" typeface="Estrangelo Edessa"/>
+        <a:font script="Syre" typeface="Estrangelo Edessa"/>
+        <a:font script="Sora" typeface="Nirmala UI"/>
+        <a:font script="Tale" typeface="Microsoft Tai Le"/>
+        <a:font script="Talu" typeface="Microsoft New Tai Lue"/>
+        <a:font script="Tfng" typeface="Ebrima"/>
+      </a:minorFont>
+    </a:fontScheme>
+    <a:fmtScheme name="Office">
+      <a:fillStyleLst>
+        <a:solidFill>
+          <a:schemeClr val="phClr"/>
+        </a:solidFill>
+        <a:gradFill rotWithShape="1">
+          <a:gsLst>
+            <a:gs pos="0">
+              <a:schemeClr val="phClr">
+                <a:lumMod val="110000"/>
+                <a:satMod val="105000"/>
+                <a:tint val="67000"/>
+              </a:schemeClr>
+            </a:gs>
+            <a:gs pos="50000">
+              <a:schemeClr val="phClr">
+                <a:lumMod val="105000"/>
+                <a:satMod val="103000"/>
+                <a:tint val="73000"/>
+              </a:schemeClr>
+            </a:gs>
+            <a:gs pos="100000">
+              <a:schemeClr val="phClr">
+                <a:lumMod val="105000"/>
+                <a:satMod val="109000"/>
+                <a:tint val="81000"/>
+              </a:schemeClr>
+            </a:gs>
+          </a:gsLst>
+          <a:lin ang="5400000" scaled="0"/>
+        </a:gradFill>
+        <a:gradFill rotWithShape="1">
+          <a:gsLst>
+            <a:gs pos="0">
+              <a:schemeClr val="phClr">
+                <a:satMod val="103000"/>
+                <a:lumMod val="102000"/>
+                <a:tint val="94000"/>
+              </a:schemeClr>
+            </a:gs>
+            <a:gs pos="50000">
+              <a:schemeClr val="phClr">
+                <a:satMod val="110000"/>
+                <a:lumMod val="100000"/>
+                <a:shade val="100000"/>
+              </a:schemeClr>
+            </a:gs>
+            <a:gs pos="100000">
+              <a:schemeClr val="phClr">
+                <a:lumMod val="99000"/>
+                <a:satMod val="120000"/>
+                <a:shade val="78000"/>
+              </a:schemeClr>
+            </a:gs>
+          </a:gsLst>
+          <a:lin ang="5400000" scaled="0"/>
+        </a:gradFill>
+      </a:fillStyleLst>
+      <a:lnStyleLst>
+        <a:ln w="12700" cap="flat" cmpd="sng" algn="ctr">
+          <a:solidFill>
+            <a:schemeClr val="phClr"/>
+          </a:solidFill>
+          <a:prstDash val="solid"/>
+          <a:miter lim="800000"/>
+        </a:ln>
+        <a:ln w="19050" cap="flat" cmpd="sng" algn="ctr">
+          <a:solidFill>
+            <a:schemeClr val="phClr"/>
+          </a:solidFill>
+          <a:prstDash val="solid"/>
+          <a:miter lim="800000"/>
+        </a:ln>
+        <a:ln w="25400" cap="flat" cmpd="sng" algn="ctr">
+          <a:solidFill>
+            <a:schemeClr val="phClr"/>
+          </a:solidFill>
+          <a:prstDash val="solid"/>
+          <a:miter lim="800000"/>
+        </a:ln>
+      </a:lnStyleLst>
+      <a:effectStyleLst>
+        <a:effectStyle>
+          <a:effectLst/>
+        </a:effectStyle>
+        <a:effectStyle>
+          <a:effectLst/>
+        </a:effectStyle>
+        <a:effectStyle>
+          <a:effectLst>
+            <a:outerShdw blurRad="57150" dist="19050" dir="5400000" algn="ctr" rotWithShape="0">
+              <a:srgbClr val="000000">
+                <a:alpha val="63000"/>
+              </a:srgbClr>
+            </a:outerShdw>
+          </a:effectLst>
+        </a:effectStyle>
+      </a:effectStyleLst>
+      <a:bgFillStyleLst>
+        <a:solidFill>
+          <a:schemeClr val="phClr"/>
+        </a:solidFill>
+        <a:solidFill>
+          <a:schemeClr val="phClr">
+            <a:tint val="95000"/>
+            <a:satMod val="170000"/>
+          </a:schemeClr>
+        </a:solidFill>
+        <a:gradFill rotWithShape="1">
+          <a:gsLst>
+            <a:gs pos="0">
+              <a:schemeClr val="phClr">
+                <a:tint val="93000"/>
+                <a:satMod val="150000"/>
+                <a:shade val="98000"/>
+                <a:lumMod val="102000"/>
+              </a:schemeClr>
+            </a:gs>
+            <a:gs pos="50000">
+              <a:schemeClr val="phClr">
+                <a:tint val="98000"/>
+                <a:satMod val="130000"/>
+                <a:shade val="90000"/>
+                <a:lumMod val="103000"/>
+              </a:schemeClr>
+            </a:gs>
+            <a:gs pos="100000">
+              <a:schemeClr val="phClr">
+                <a:shade val="63000"/>
+                <a:satMod val="120000"/>
+              </a:schemeClr>
+            </a:gs>
+          </a:gsLst>
+          <a:lin ang="5400000" scaled="0"/>
+        </a:gradFill>
+      </a:bgFillStyleLst>
+    </a:fmtScheme>
+  </a:themeElements>
+  <a:objectDefaults>
+    <a:lnDef>
+      <a:spPr/>
+      <a:bodyPr/>
+      <a:lstStyle/>
+      <a:style>
+        <a:lnRef idx="2">
+          <a:schemeClr val="accent1"/>
+        </a:lnRef>
+        <a:fillRef idx="0">
+          <a:schemeClr val="accent1"/>
+        </a:fillRef>
+        <a:effectRef idx="1">
+          <a:schemeClr val="accent1"/>
+        </a:effectRef>
+        <a:fontRef idx="minor">
+          <a:schemeClr val="tx1"/>
+        </a:fontRef>
+      </a:style>
+    </a:lnDef>
+  </a:objectDefaults>
+  <a:extraClrSchemeLst/>
+  <a:extLst>
+    <a:ext uri="{05A4C25C-085E-4340-85A3-A5531E510DB2}">
+      <thm15:themeFamily xmlns:thm15="http://schemas.microsoft.com/office/thememl/2012/main" name="Office Theme" id="{2E142A2C-CD16-42D6-873A-C26D2A0506FA}" vid="{1BDDFF52-6CD6-40A5-AB3C-68EB2F1E4D0A}"/>
+    </a:ext>
+  </a:extLst>
+</a:theme>
 </file>
</xml_diff>